<commit_message>
Intègre le volet 2 d'aeroVFR au support sorties de piste
Ajout de la diapositive de préparation (exemple de Barcelonnette), du cas
DR-360 à contre-QFU, de l'expérience récente du pilote du DA40 et des
sources complémentaires. 24 diapositives.

Co-Authored-By: Claude Fable 5.1 <noreply@anthropic.com>
Claude-Session: https://claude.ai/code/session_01HRmUKUt1JuTKhtALye4yQd
</commit_message>
<xml_diff>
--- a/aeroclub/sorties-de-piste/Sorties_de_piste_longitudinales_FV.pptx
+++ b/aeroclub/sorties-de-piste/Sorties_de_piste_longitudinales_FV.pptx
@@ -28,6 +28,7 @@
     <p:sldId id="276" r:id="rId28"/>
     <p:sldId id="277" r:id="rId29"/>
     <p:sldId id="278" r:id="rId30"/>
+    <p:sldId id="279" r:id="rId31"/>
   </p:sldIdLst>
   <p:sldSz cx="12188952" cy="6858000" type="screen4x3"/>
   <p:notesSz cx="6858000" cy="9144000"/>
@@ -594,7 +595,7 @@
           <a:lstStyle/>
           <a:p>
             <a:r>
-              <a:t>Vérifier ces ordres de grandeur avec les manuels de vol des avions du club (DR400, Cessna, etc.) et adapter la slide. L'important est le message : les majorations se multiplient entre elles.</a:t>
+              <a:t>Exemple développé dans le volet 2 d'aeroVFR. À remplacer ou compléter par un terrain que le club fréquente réellement, avec sa VAC projetée à l'écran.</a:t>
             </a:r>
           </a:p>
         </p:txBody>
@@ -664,7 +665,7 @@
           <a:lstStyle/>
           <a:p>
             <a:r>
-              <a:t>Doctrine reprise d'aeroVFR 2015 « Pour éviter les sorties longitudinales » et du guide DGAC sur l'approche stabilisée. En aviation commerciale la porte est à 1 000 ft, en aviation générale à 300 ft sol.</a:t>
+              <a:t>Vérifier ces ordres de grandeur avec les manuels de vol des avions du club (DR400, Cessna, etc.) et adapter la slide. L'important est le message : les majorations se multiplient entre elles.</a:t>
             </a:r>
           </a:p>
         </p:txBody>
@@ -734,7 +735,7 @@
           <a:lstStyle/>
           <a:p>
             <a:r>
-              <a:t>Insister sur la dernière ligne de droite : dans deux des trois cas, le pilote avait déjà remis les gaz une fois, et n'a pas refait le même choix à la seconde approche.</a:t>
+              <a:t>Doctrine reprise d'aeroVFR 2015 « Pour éviter les sorties longitudinales » et du guide DGAC sur l'approche stabilisée. En aviation commerciale la porte est à 1 000 ft, en aviation générale à 300 ft sol.</a:t>
             </a:r>
           </a:p>
         </p:txBody>
@@ -760,6 +761,76 @@
 </file>
 
 <file path=ppt/notesSlides/notesSlide13.xml><?xml version="1.0" encoding="utf-8"?>
+<p:notes xmlns:a="http://schemas.openxmlformats.org/drawingml/2006/main" xmlns:p="http://schemas.openxmlformats.org/presentationml/2006/main" xmlns:r="http://schemas.openxmlformats.org/officeDocument/2006/relationships">
+  <p:cSld>
+    <p:spTree>
+      <p:nvGrpSpPr>
+        <p:cNvPr id="1" name=""/>
+        <p:cNvGrpSpPr/>
+        <p:nvPr/>
+      </p:nvGrpSpPr>
+      <p:grpSpPr>
+        <a:xfrm>
+          <a:off x="0" y="0"/>
+          <a:ext cx="0" cy="0"/>
+          <a:chOff x="0" y="0"/>
+          <a:chExt cx="0" cy="0"/>
+        </a:xfrm>
+      </p:grpSpPr>
+      <p:sp>
+        <p:nvSpPr>
+          <p:cNvPr id="2" name="Slide Image Placeholder 1"/>
+          <p:cNvSpPr>
+            <a:spLocks noGrp="1"/>
+          </p:cNvSpPr>
+          <p:nvPr>
+            <p:ph type="sldImg" idx="2"/>
+          </p:nvPr>
+        </p:nvSpPr>
+        <p:spPr/>
+      </p:sp>
+      <p:sp>
+        <p:nvSpPr>
+          <p:cNvPr id="3" name="Notes Placeholder 2"/>
+          <p:cNvSpPr>
+            <a:spLocks noGrp="1"/>
+          </p:cNvSpPr>
+          <p:nvPr>
+            <p:ph type="body" idx="3" sz="quarter"/>
+          </p:nvPr>
+        </p:nvSpPr>
+        <p:spPr/>
+        <p:txBody>
+          <a:bodyPr/>
+          <a:lstStyle/>
+          <a:p>
+            <a:r>
+              <a:t>Insister sur la dernière ligne de droite : dans deux des trois cas, le pilote avait déjà remis les gaz une fois, et n'a pas refait le même choix à la seconde approche.</a:t>
+            </a:r>
+          </a:p>
+        </p:txBody>
+      </p:sp>
+      <p:sp>
+        <p:nvSpPr>
+          <p:cNvPr id="4" name="Slide Number Placeholder 3"/>
+          <p:cNvSpPr>
+            <a:spLocks noGrp="1"/>
+          </p:cNvSpPr>
+          <p:nvPr>
+            <p:ph type="sldNum" idx="5" sz="quarter"/>
+          </p:nvPr>
+        </p:nvSpPr>
+        <p:spPr/>
+      </p:sp>
+    </p:spTree>
+  </p:cSld>
+  <p:clrMapOvr>
+    <a:masterClrMapping/>
+  </p:clrMapOvr>
+</p:notes>
+</file>
+
+<file path=ppt/notesSlides/notesSlide14.xml><?xml version="1.0" encoding="utf-8"?>
 <p:notes xmlns:a="http://schemas.openxmlformats.org/drawingml/2006/main" xmlns:p="http://schemas.openxmlformats.org/presentationml/2006/main" xmlns:r="http://schemas.openxmlformats.org/officeDocument/2006/relationships">
   <p:cSld>
     <p:spTree>
@@ -6437,7 +6508,7 @@
                 </a:solidFill>
                 <a:latin typeface="Calibri Light"/>
               </a:rPr>
-              <a:t>       Manche à air non surveillée, approche à contre-QFU par vent « calme », composante arrière acceptée.</a:t>
+              <a:t>       Manche à air non surveillée, composante arrière acceptée. Un DR-360 posé à contre-QFU, haut et vite en finale : sortie longitudinale, avion lourdement endommagé.</a:t>
             </a:r>
           </a:p>
           <a:p>
@@ -6921,8 +6992,8 @@
         </p:nvSpPr>
         <p:spPr>
           <a:xfrm>
-            <a:off x="1005840" y="1554480"/>
-            <a:ext cx="10241280" cy="1280160"/>
+            <a:off x="1005840" y="1463040"/>
+            <a:ext cx="10241280" cy="1417320"/>
           </a:xfrm>
           <a:prstGeom prst="rect">
             <a:avLst/>
@@ -7566,7 +7637,7 @@
                 </a:solidFill>
                 <a:latin typeface="Calibri Light"/>
               </a:rPr>
-              <a:t>La physique ne négocie pas</a:t>
+              <a:t>Préparer un terrain : l'exemple de Barcelonnette</a:t>
             </a:r>
           </a:p>
         </p:txBody>
@@ -7717,8 +7788,333 @@
         </p:nvSpPr>
         <p:spPr>
           <a:xfrm>
-            <a:off x="640080" y="1828800"/>
-            <a:ext cx="3566160" cy="54864"/>
+            <a:off x="640080" y="1371600"/>
+            <a:ext cx="10881360" cy="1600200"/>
+          </a:xfrm>
+          <a:prstGeom prst="rect">
+            <a:avLst/>
+          </a:prstGeom>
+          <a:solidFill>
+            <a:srgbClr val="D2EBF8"/>
+          </a:solidFill>
+          <a:ln>
+            <a:noFill/>
+          </a:ln>
+          <a:effectLst/>
+        </p:spPr>
+        <p:style>
+          <a:lnRef idx="1">
+            <a:schemeClr val="accent1"/>
+          </a:lnRef>
+          <a:fillRef idx="3">
+            <a:schemeClr val="accent1"/>
+          </a:fillRef>
+          <a:effectRef idx="2">
+            <a:schemeClr val="accent1"/>
+          </a:effectRef>
+          <a:fontRef idx="minor">
+            <a:schemeClr val="lt1"/>
+          </a:fontRef>
+        </p:style>
+        <p:txBody>
+          <a:bodyPr rtlCol="0" anchor="ctr"/>
+          <a:lstStyle/>
+          <a:p>
+            <a:pPr algn="ctr"/>
+          </a:p>
+        </p:txBody>
+      </p:sp>
+      <p:sp>
+        <p:nvSpPr>
+          <p:cNvPr id="10" name="Rectangle 9"/>
+          <p:cNvSpPr/>
+          <p:nvPr/>
+        </p:nvSpPr>
+        <p:spPr>
+          <a:xfrm>
+            <a:off x="640080" y="1371600"/>
+            <a:ext cx="109728" cy="1600200"/>
+          </a:xfrm>
+          <a:prstGeom prst="rect">
+            <a:avLst/>
+          </a:prstGeom>
+          <a:solidFill>
+            <a:srgbClr val="4A9ED6"/>
+          </a:solidFill>
+          <a:ln>
+            <a:noFill/>
+          </a:ln>
+          <a:effectLst/>
+        </p:spPr>
+        <p:style>
+          <a:lnRef idx="1">
+            <a:schemeClr val="accent1"/>
+          </a:lnRef>
+          <a:fillRef idx="3">
+            <a:schemeClr val="accent1"/>
+          </a:fillRef>
+          <a:effectRef idx="2">
+            <a:schemeClr val="accent1"/>
+          </a:effectRef>
+          <a:fontRef idx="minor">
+            <a:schemeClr val="lt1"/>
+          </a:fontRef>
+        </p:style>
+        <p:txBody>
+          <a:bodyPr rtlCol="0" anchor="ctr"/>
+          <a:lstStyle/>
+          <a:p>
+            <a:pPr algn="ctr"/>
+          </a:p>
+        </p:txBody>
+      </p:sp>
+      <p:sp>
+        <p:nvSpPr>
+          <p:cNvPr id="11" name="TextBox 10"/>
+          <p:cNvSpPr txBox="1"/>
+          <p:nvPr/>
+        </p:nvSpPr>
+        <p:spPr>
+          <a:xfrm>
+            <a:off x="1005840" y="1463040"/>
+            <a:ext cx="10241280" cy="1417320"/>
+          </a:xfrm>
+          <a:prstGeom prst="rect">
+            <a:avLst/>
+          </a:prstGeom>
+          <a:noFill/>
+        </p:spPr>
+        <p:txBody>
+          <a:bodyPr wrap="square" anchor="ctr">
+            <a:spAutoFit/>
+          </a:bodyPr>
+          <a:lstStyle/>
+          <a:p>
+            <a:pPr algn="l"/>
+            <a:r>
+              <a:rPr sz="1700" b="0" i="0">
+                <a:solidFill>
+                  <a:srgbClr val="1A3A5C"/>
+                </a:solidFill>
+                <a:latin typeface="Calibri Light"/>
+              </a:rPr>
+              <a:t>« Pour un terrain peu ou pas pratiqué récemment, surtout avec une piste courte ou limitative, la préparation se fait bien avant le décollage : analyse de la VAC, topographie sur Google Earth, lecture des consignes particulières qui annoncent une turbulence par certains vents ou une piste en pente. »</a:t>
+            </a:r>
+          </a:p>
+        </p:txBody>
+      </p:sp>
+      <p:sp>
+        <p:nvSpPr>
+          <p:cNvPr id="12" name="Rectangle 11"/>
+          <p:cNvSpPr/>
+          <p:nvPr/>
+        </p:nvSpPr>
+        <p:spPr>
+          <a:xfrm>
+            <a:off x="640080" y="3337560"/>
+            <a:ext cx="3383280" cy="2606040"/>
+          </a:xfrm>
+          <a:prstGeom prst="rect">
+            <a:avLst/>
+          </a:prstGeom>
+          <a:solidFill>
+            <a:srgbClr val="1A3A5C"/>
+          </a:solidFill>
+          <a:ln>
+            <a:noFill/>
+          </a:ln>
+          <a:effectLst/>
+        </p:spPr>
+        <p:style>
+          <a:lnRef idx="1">
+            <a:schemeClr val="accent1"/>
+          </a:lnRef>
+          <a:fillRef idx="3">
+            <a:schemeClr val="accent1"/>
+          </a:fillRef>
+          <a:effectRef idx="2">
+            <a:schemeClr val="accent1"/>
+          </a:effectRef>
+          <a:fontRef idx="minor">
+            <a:schemeClr val="lt1"/>
+          </a:fontRef>
+        </p:style>
+        <p:txBody>
+          <a:bodyPr rtlCol="0" anchor="ctr"/>
+          <a:lstStyle/>
+          <a:p>
+            <a:pPr algn="ctr"/>
+          </a:p>
+        </p:txBody>
+      </p:sp>
+      <p:sp>
+        <p:nvSpPr>
+          <p:cNvPr id="13" name="Rectangle 12"/>
+          <p:cNvSpPr/>
+          <p:nvPr/>
+        </p:nvSpPr>
+        <p:spPr>
+          <a:xfrm>
+            <a:off x="640080" y="3337560"/>
+            <a:ext cx="3383280" cy="457200"/>
+          </a:xfrm>
+          <a:prstGeom prst="rect">
+            <a:avLst/>
+          </a:prstGeom>
+          <a:solidFill>
+            <a:srgbClr val="4A9ED6"/>
+          </a:solidFill>
+          <a:ln>
+            <a:noFill/>
+          </a:ln>
+          <a:effectLst/>
+        </p:spPr>
+        <p:style>
+          <a:lnRef idx="1">
+            <a:schemeClr val="accent1"/>
+          </a:lnRef>
+          <a:fillRef idx="3">
+            <a:schemeClr val="accent1"/>
+          </a:fillRef>
+          <a:effectRef idx="2">
+            <a:schemeClr val="accent1"/>
+          </a:effectRef>
+          <a:fontRef idx="minor">
+            <a:schemeClr val="lt1"/>
+          </a:fontRef>
+        </p:style>
+        <p:txBody>
+          <a:bodyPr rtlCol="0" anchor="ctr"/>
+          <a:lstStyle/>
+          <a:p>
+            <a:pPr algn="ctr"/>
+          </a:p>
+        </p:txBody>
+      </p:sp>
+      <p:sp>
+        <p:nvSpPr>
+          <p:cNvPr id="14" name="TextBox 13"/>
+          <p:cNvSpPr txBox="1"/>
+          <p:nvPr/>
+        </p:nvSpPr>
+        <p:spPr>
+          <a:xfrm>
+            <a:off x="777240" y="3410712"/>
+            <a:ext cx="3200400" cy="365760"/>
+          </a:xfrm>
+          <a:prstGeom prst="rect">
+            <a:avLst/>
+          </a:prstGeom>
+          <a:noFill/>
+        </p:spPr>
+        <p:txBody>
+          <a:bodyPr wrap="square" anchor="ctr">
+            <a:spAutoFit/>
+          </a:bodyPr>
+          <a:lstStyle/>
+          <a:p>
+            <a:pPr algn="l"/>
+            <a:r>
+              <a:rPr sz="1300" b="1" i="0">
+                <a:solidFill>
+                  <a:srgbClr val="FFFFFF"/>
+                </a:solidFill>
+                <a:latin typeface="Calibri"/>
+              </a:rPr>
+              <a:t>Ce que dit la VAC</a:t>
+            </a:r>
+          </a:p>
+        </p:txBody>
+      </p:sp>
+      <p:sp>
+        <p:nvSpPr>
+          <p:cNvPr id="15" name="TextBox 14"/>
+          <p:cNvSpPr txBox="1"/>
+          <p:nvPr/>
+        </p:nvSpPr>
+        <p:spPr>
+          <a:xfrm>
+            <a:off x="777240" y="3886200"/>
+            <a:ext cx="3154680" cy="2011680"/>
+          </a:xfrm>
+          <a:prstGeom prst="rect">
+            <a:avLst/>
+          </a:prstGeom>
+          <a:noFill/>
+        </p:spPr>
+        <p:txBody>
+          <a:bodyPr wrap="square">
+            <a:spAutoFit/>
+          </a:bodyPr>
+          <a:lstStyle/>
+          <a:p>
+            <a:pPr algn="l"/>
+            <a:r>
+              <a:rPr sz="1300" b="0" i="0">
+                <a:solidFill>
+                  <a:srgbClr val="D2EBF8"/>
+                </a:solidFill>
+                <a:latin typeface="Calibri Light"/>
+              </a:rPr>
+              <a:t>En été, vent calme le matin, brise forte l'après-midi. Piste 27 alors obligatoire, avec forte turbulence et rabattants possibles en courte finale.</a:t>
+            </a:r>
+          </a:p>
+        </p:txBody>
+      </p:sp>
+      <p:sp>
+        <p:nvSpPr>
+          <p:cNvPr id="16" name="Rectangle 15"/>
+          <p:cNvSpPr/>
+          <p:nvPr/>
+        </p:nvSpPr>
+        <p:spPr>
+          <a:xfrm>
+            <a:off x="4343400" y="3337560"/>
+            <a:ext cx="3383280" cy="2606040"/>
+          </a:xfrm>
+          <a:prstGeom prst="rect">
+            <a:avLst/>
+          </a:prstGeom>
+          <a:solidFill>
+            <a:srgbClr val="1A3A5C"/>
+          </a:solidFill>
+          <a:ln>
+            <a:noFill/>
+          </a:ln>
+          <a:effectLst/>
+        </p:spPr>
+        <p:style>
+          <a:lnRef idx="1">
+            <a:schemeClr val="accent1"/>
+          </a:lnRef>
+          <a:fillRef idx="3">
+            <a:schemeClr val="accent1"/>
+          </a:fillRef>
+          <a:effectRef idx="2">
+            <a:schemeClr val="accent1"/>
+          </a:effectRef>
+          <a:fontRef idx="minor">
+            <a:schemeClr val="lt1"/>
+          </a:fontRef>
+        </p:style>
+        <p:txBody>
+          <a:bodyPr rtlCol="0" anchor="ctr"/>
+          <a:lstStyle/>
+          <a:p>
+            <a:pPr algn="ctr"/>
+          </a:p>
+        </p:txBody>
+      </p:sp>
+      <p:sp>
+        <p:nvSpPr>
+          <p:cNvPr id="17" name="Rectangle 16"/>
+          <p:cNvSpPr/>
+          <p:nvPr/>
+        </p:nvSpPr>
+        <p:spPr>
+          <a:xfrm>
+            <a:off x="4343400" y="3337560"/>
+            <a:ext cx="3383280" cy="457200"/>
           </a:xfrm>
           <a:prstGeom prst="rect">
             <a:avLst/>
@@ -7755,14 +8151,49 @@
       </p:sp>
       <p:sp>
         <p:nvSpPr>
-          <p:cNvPr id="10" name="TextBox 9"/>
+          <p:cNvPr id="18" name="TextBox 17"/>
           <p:cNvSpPr txBox="1"/>
           <p:nvPr/>
         </p:nvSpPr>
         <p:spPr>
           <a:xfrm>
-            <a:off x="640080" y="2148840"/>
-            <a:ext cx="3566160" cy="1188720"/>
+            <a:off x="4480560" y="3410712"/>
+            <a:ext cx="3200400" cy="365760"/>
+          </a:xfrm>
+          <a:prstGeom prst="rect">
+            <a:avLst/>
+          </a:prstGeom>
+          <a:noFill/>
+        </p:spPr>
+        <p:txBody>
+          <a:bodyPr wrap="square" anchor="ctr">
+            <a:spAutoFit/>
+          </a:bodyPr>
+          <a:lstStyle/>
+          <a:p>
+            <a:pPr algn="l"/>
+            <a:r>
+              <a:rPr sz="1300" b="1" i="0">
+                <a:solidFill>
+                  <a:srgbClr val="FFFFFF"/>
+                </a:solidFill>
+                <a:latin typeface="Calibri"/>
+              </a:rPr>
+              <a:t>Ce que dit le relief</a:t>
+            </a:r>
+          </a:p>
+        </p:txBody>
+      </p:sp>
+      <p:sp>
+        <p:nvSpPr>
+          <p:cNvPr id="19" name="TextBox 18"/>
+          <p:cNvSpPr txBox="1"/>
+          <p:nvPr/>
+        </p:nvSpPr>
+        <p:spPr>
+          <a:xfrm>
+            <a:off x="4480560" y="3886200"/>
+            <a:ext cx="3154680" cy="2011680"/>
           </a:xfrm>
           <a:prstGeom prst="rect">
             <a:avLst/>
@@ -7775,70 +8206,35 @@
           </a:bodyPr>
           <a:lstStyle/>
           <a:p>
-            <a:pPr algn="ctr"/>
-            <a:r>
-              <a:rPr sz="5000" b="1" i="0">
-                <a:solidFill>
-                  <a:srgbClr val="1A3A5C"/>
+            <a:pPr algn="l"/>
+            <a:r>
+              <a:rPr sz="1300" b="0" i="0">
+                <a:solidFill>
+                  <a:srgbClr val="D2EBF8"/>
                 </a:solidFill>
                 <a:latin typeface="Calibri Light"/>
               </a:rPr>
-              <a:t>+ 20 %</a:t>
-            </a:r>
-          </a:p>
-        </p:txBody>
-      </p:sp>
-      <p:sp>
-        <p:nvSpPr>
-          <p:cNvPr id="11" name="TextBox 10"/>
-          <p:cNvSpPr txBox="1"/>
-          <p:nvPr/>
-        </p:nvSpPr>
-        <p:spPr>
-          <a:xfrm>
-            <a:off x="640080" y="3429000"/>
-            <a:ext cx="3566160" cy="1005840"/>
-          </a:xfrm>
-          <a:prstGeom prst="rect">
-            <a:avLst/>
-          </a:prstGeom>
-          <a:noFill/>
-        </p:spPr>
-        <p:txBody>
-          <a:bodyPr wrap="square">
-            <a:spAutoFit/>
-          </a:bodyPr>
-          <a:lstStyle/>
-          <a:p>
-            <a:pPr algn="ctr"/>
-            <a:r>
-              <a:rPr sz="1500" b="0" i="0">
-                <a:solidFill>
-                  <a:srgbClr val="6B7A8C"/>
-                </a:solidFill>
-                <a:latin typeface="Calibri"/>
-              </a:rPr>
-              <a:t>de distance d'atterrissage pour 10 % de vitesse en trop (l'énergie varie avec le carré de la vitesse)</a:t>
-            </a:r>
-          </a:p>
-        </p:txBody>
-      </p:sp>
-      <p:sp>
-        <p:nvSpPr>
-          <p:cNvPr id="12" name="Rectangle 11"/>
+              <a:t>Piste bombée dans le sens longitudinal : l'autre extrémité n'est pas visible depuis le seuil. La distance disponible est trompeuse à l'œil.</a:t>
+            </a:r>
+          </a:p>
+        </p:txBody>
+      </p:sp>
+      <p:sp>
+        <p:nvSpPr>
+          <p:cNvPr id="20" name="Rectangle 19"/>
           <p:cNvSpPr/>
           <p:nvPr/>
         </p:nvSpPr>
         <p:spPr>
           <a:xfrm>
-            <a:off x="4434840" y="1828800"/>
-            <a:ext cx="3566160" cy="54864"/>
+            <a:off x="8046720" y="3337560"/>
+            <a:ext cx="3383280" cy="2606040"/>
           </a:xfrm>
           <a:prstGeom prst="rect">
             <a:avLst/>
           </a:prstGeom>
           <a:solidFill>
-            <a:srgbClr val="C0392B"/>
+            <a:srgbClr val="1A3A5C"/>
           </a:solidFill>
           <a:ln>
             <a:noFill/>
@@ -7869,90 +8265,20 @@
       </p:sp>
       <p:sp>
         <p:nvSpPr>
-          <p:cNvPr id="13" name="TextBox 12"/>
-          <p:cNvSpPr txBox="1"/>
-          <p:nvPr/>
-        </p:nvSpPr>
-        <p:spPr>
-          <a:xfrm>
-            <a:off x="4434840" y="2148840"/>
-            <a:ext cx="3566160" cy="1188720"/>
-          </a:xfrm>
-          <a:prstGeom prst="rect">
-            <a:avLst/>
-          </a:prstGeom>
-          <a:noFill/>
-        </p:spPr>
-        <p:txBody>
-          <a:bodyPr wrap="square">
-            <a:spAutoFit/>
-          </a:bodyPr>
-          <a:lstStyle/>
-          <a:p>
-            <a:pPr algn="ctr"/>
-            <a:r>
-              <a:rPr sz="5000" b="1" i="0">
-                <a:solidFill>
-                  <a:srgbClr val="1A3A5C"/>
-                </a:solidFill>
-                <a:latin typeface="Calibri Light"/>
-              </a:rPr>
-              <a:t>× 1,5</a:t>
-            </a:r>
-          </a:p>
-        </p:txBody>
-      </p:sp>
-      <p:sp>
-        <p:nvSpPr>
-          <p:cNvPr id="14" name="TextBox 13"/>
-          <p:cNvSpPr txBox="1"/>
-          <p:nvPr/>
-        </p:nvSpPr>
-        <p:spPr>
-          <a:xfrm>
-            <a:off x="4434840" y="3429000"/>
-            <a:ext cx="3566160" cy="1005840"/>
-          </a:xfrm>
-          <a:prstGeom prst="rect">
-            <a:avLst/>
-          </a:prstGeom>
-          <a:noFill/>
-        </p:spPr>
-        <p:txBody>
-          <a:bodyPr wrap="square">
-            <a:spAutoFit/>
-          </a:bodyPr>
-          <a:lstStyle/>
-          <a:p>
-            <a:pPr algn="ctr"/>
-            <a:r>
-              <a:rPr sz="1500" b="0" i="0">
-                <a:solidFill>
-                  <a:srgbClr val="6B7A8C"/>
-                </a:solidFill>
-                <a:latin typeface="Calibri"/>
-              </a:rPr>
-              <a:t>distance de roulement avec 10 kt de vent arrière (ordre de grandeur donné par les manuels Cessna)</a:t>
-            </a:r>
-          </a:p>
-        </p:txBody>
-      </p:sp>
-      <p:sp>
-        <p:nvSpPr>
-          <p:cNvPr id="15" name="Rectangle 14"/>
+          <p:cNvPr id="21" name="Rectangle 20"/>
           <p:cNvSpPr/>
           <p:nvPr/>
         </p:nvSpPr>
         <p:spPr>
           <a:xfrm>
-            <a:off x="8229600" y="1828800"/>
-            <a:ext cx="3566160" cy="54864"/>
+            <a:off x="8046720" y="3337560"/>
+            <a:ext cx="3383280" cy="457200"/>
           </a:xfrm>
           <a:prstGeom prst="rect">
             <a:avLst/>
           </a:prstGeom>
           <a:solidFill>
-            <a:srgbClr val="D68910"/>
+            <a:srgbClr val="2E7D4F"/>
           </a:solidFill>
           <a:ln>
             <a:noFill/>
@@ -7983,14 +8309,49 @@
       </p:sp>
       <p:sp>
         <p:nvSpPr>
-          <p:cNvPr id="16" name="TextBox 15"/>
+          <p:cNvPr id="22" name="TextBox 21"/>
           <p:cNvSpPr txBox="1"/>
           <p:nvPr/>
         </p:nvSpPr>
         <p:spPr>
           <a:xfrm>
-            <a:off x="8229600" y="2148840"/>
-            <a:ext cx="3566160" cy="1188720"/>
+            <a:off x="8183880" y="3410712"/>
+            <a:ext cx="3200400" cy="365760"/>
+          </a:xfrm>
+          <a:prstGeom prst="rect">
+            <a:avLst/>
+          </a:prstGeom>
+          <a:noFill/>
+        </p:spPr>
+        <p:txBody>
+          <a:bodyPr wrap="square" anchor="ctr">
+            <a:spAutoFit/>
+          </a:bodyPr>
+          <a:lstStyle/>
+          <a:p>
+            <a:pPr algn="l"/>
+            <a:r>
+              <a:rPr sz="1300" b="1" i="0">
+                <a:solidFill>
+                  <a:srgbClr val="FFFFFF"/>
+                </a:solidFill>
+                <a:latin typeface="Calibri"/>
+              </a:rPr>
+              <a:t>Ce que je décide</a:t>
+            </a:r>
+          </a:p>
+        </p:txBody>
+      </p:sp>
+      <p:sp>
+        <p:nvSpPr>
+          <p:cNvPr id="23" name="TextBox 22"/>
+          <p:cNvSpPr txBox="1"/>
+          <p:nvPr/>
+        </p:nvSpPr>
+        <p:spPr>
+          <a:xfrm>
+            <a:off x="8183880" y="3886200"/>
+            <a:ext cx="3154680" cy="2011680"/>
           </a:xfrm>
           <a:prstGeom prst="rect">
             <a:avLst/>
@@ -8003,85 +8364,15 @@
           </a:bodyPr>
           <a:lstStyle/>
           <a:p>
-            <a:pPr algn="ctr"/>
-            <a:r>
-              <a:rPr sz="5000" b="1" i="0">
-                <a:solidFill>
-                  <a:srgbClr val="1A3A5C"/>
+            <a:pPr algn="l"/>
+            <a:r>
+              <a:rPr sz="1300" b="0" i="0">
+                <a:solidFill>
+                  <a:srgbClr val="D2EBF8"/>
                 </a:solidFill>
                 <a:latin typeface="Calibri Light"/>
               </a:rPr>
-              <a:t>× 1,3</a:t>
-            </a:r>
-          </a:p>
-        </p:txBody>
-      </p:sp>
-      <p:sp>
-        <p:nvSpPr>
-          <p:cNvPr id="17" name="TextBox 16"/>
-          <p:cNvSpPr txBox="1"/>
-          <p:nvPr/>
-        </p:nvSpPr>
-        <p:spPr>
-          <a:xfrm>
-            <a:off x="8229600" y="3429000"/>
-            <a:ext cx="3566160" cy="1005840"/>
-          </a:xfrm>
-          <a:prstGeom prst="rect">
-            <a:avLst/>
-          </a:prstGeom>
-          <a:noFill/>
-        </p:spPr>
-        <p:txBody>
-          <a:bodyPr wrap="square">
-            <a:spAutoFit/>
-          </a:bodyPr>
-          <a:lstStyle/>
-          <a:p>
-            <a:pPr algn="ctr"/>
-            <a:r>
-              <a:rPr sz="1500" b="0" i="0">
-                <a:solidFill>
-                  <a:srgbClr val="6B7A8C"/>
-                </a:solidFill>
-                <a:latin typeface="Calibri"/>
-              </a:rPr>
-              <a:t>sur herbe mouillée ou haute, par rapport à une piste en dur sèche (majorations usuelles)</a:t>
-            </a:r>
-          </a:p>
-        </p:txBody>
-      </p:sp>
-      <p:sp>
-        <p:nvSpPr>
-          <p:cNvPr id="18" name="TextBox 17"/>
-          <p:cNvSpPr txBox="1"/>
-          <p:nvPr/>
-        </p:nvSpPr>
-        <p:spPr>
-          <a:xfrm>
-            <a:off x="640080" y="5120640"/>
-            <a:ext cx="10881360" cy="822960"/>
-          </a:xfrm>
-          <a:prstGeom prst="rect">
-            <a:avLst/>
-          </a:prstGeom>
-          <a:noFill/>
-        </p:spPr>
-        <p:txBody>
-          <a:bodyPr wrap="square">
-            <a:spAutoFit/>
-          </a:bodyPr>
-          <a:lstStyle/>
-          <a:p>
-            <a:pPr algn="l"/>
-            <a:r>
-              <a:rPr sz="1300" b="0" i="1">
-                <a:solidFill>
-                  <a:srgbClr val="6B7A8C"/>
-                </a:solidFill>
-                <a:latin typeface="Calibri"/>
-              </a:rPr>
-              <a:t>Ces coefficients se cumulent. Ils sont indicatifs : la référence reste le manuel de vol de l'avion, puis une marge personnelle par-dessus. Le calcul se fait au sol, avant le départ, jamais en finale.</a:t>
+              <a:t>Toucher visé dans le premier quart montant, pour compenser la partie descendante de la seconde moitié. Arriver le matin, ou renoncer si la brise est établie.</a:t>
             </a:r>
           </a:p>
         </p:txBody>
@@ -8095,6 +8386,670 @@
 </file>
 
 <file path=ppt/slides/slide15.xml><?xml version="1.0" encoding="utf-8"?>
+<p:sld xmlns:a="http://schemas.openxmlformats.org/drawingml/2006/main" xmlns:p="http://schemas.openxmlformats.org/presentationml/2006/main" xmlns:r="http://schemas.openxmlformats.org/officeDocument/2006/relationships">
+  <p:cSld>
+    <p:bg>
+      <p:bgPr>
+        <a:solidFill>
+          <a:srgbClr val="FFFFFF"/>
+        </a:solidFill>
+        <a:effectLst/>
+      </p:bgPr>
+    </p:bg>
+    <p:spTree>
+      <p:nvGrpSpPr>
+        <p:cNvPr id="1" name=""/>
+        <p:cNvGrpSpPr/>
+        <p:nvPr/>
+      </p:nvGrpSpPr>
+      <p:grpSpPr/>
+      <p:sp>
+        <p:nvSpPr>
+          <p:cNvPr id="2" name="Rectangle 1"/>
+          <p:cNvSpPr/>
+          <p:nvPr/>
+        </p:nvSpPr>
+        <p:spPr>
+          <a:xfrm>
+            <a:off x="0" y="0"/>
+            <a:ext cx="12188952" cy="960120"/>
+          </a:xfrm>
+          <a:prstGeom prst="rect">
+            <a:avLst/>
+          </a:prstGeom>
+          <a:solidFill>
+            <a:srgbClr val="1A3A5C"/>
+          </a:solidFill>
+          <a:ln>
+            <a:noFill/>
+          </a:ln>
+          <a:effectLst/>
+        </p:spPr>
+        <p:style>
+          <a:lnRef idx="1">
+            <a:schemeClr val="accent1"/>
+          </a:lnRef>
+          <a:fillRef idx="3">
+            <a:schemeClr val="accent1"/>
+          </a:fillRef>
+          <a:effectRef idx="2">
+            <a:schemeClr val="accent1"/>
+          </a:effectRef>
+          <a:fontRef idx="minor">
+            <a:schemeClr val="lt1"/>
+          </a:fontRef>
+        </p:style>
+        <p:txBody>
+          <a:bodyPr rtlCol="0" anchor="ctr"/>
+          <a:lstStyle/>
+          <a:p>
+            <a:pPr algn="ctr"/>
+          </a:p>
+        </p:txBody>
+      </p:sp>
+      <p:sp>
+        <p:nvSpPr>
+          <p:cNvPr id="3" name="Rectangle 2"/>
+          <p:cNvSpPr/>
+          <p:nvPr/>
+        </p:nvSpPr>
+        <p:spPr>
+          <a:xfrm>
+            <a:off x="0" y="960120"/>
+            <a:ext cx="12188952" cy="54864"/>
+          </a:xfrm>
+          <a:prstGeom prst="rect">
+            <a:avLst/>
+          </a:prstGeom>
+          <a:solidFill>
+            <a:srgbClr val="4A9ED6"/>
+          </a:solidFill>
+          <a:ln>
+            <a:noFill/>
+          </a:ln>
+          <a:effectLst/>
+        </p:spPr>
+        <p:style>
+          <a:lnRef idx="1">
+            <a:schemeClr val="accent1"/>
+          </a:lnRef>
+          <a:fillRef idx="3">
+            <a:schemeClr val="accent1"/>
+          </a:fillRef>
+          <a:effectRef idx="2">
+            <a:schemeClr val="accent1"/>
+          </a:effectRef>
+          <a:fontRef idx="minor">
+            <a:schemeClr val="lt1"/>
+          </a:fontRef>
+        </p:style>
+        <p:txBody>
+          <a:bodyPr rtlCol="0" anchor="ctr"/>
+          <a:lstStyle/>
+          <a:p>
+            <a:pPr algn="ctr"/>
+          </a:p>
+        </p:txBody>
+      </p:sp>
+      <p:sp>
+        <p:nvSpPr>
+          <p:cNvPr id="4" name="TextBox 3"/>
+          <p:cNvSpPr txBox="1"/>
+          <p:nvPr/>
+        </p:nvSpPr>
+        <p:spPr>
+          <a:xfrm>
+            <a:off x="457200" y="155448"/>
+            <a:ext cx="11274552" cy="713232"/>
+          </a:xfrm>
+          <a:prstGeom prst="rect">
+            <a:avLst/>
+          </a:prstGeom>
+          <a:noFill/>
+        </p:spPr>
+        <p:txBody>
+          <a:bodyPr wrap="square" anchor="ctr">
+            <a:spAutoFit/>
+          </a:bodyPr>
+          <a:lstStyle/>
+          <a:p>
+            <a:pPr algn="l"/>
+            <a:r>
+              <a:rPr sz="2800" b="1" i="0">
+                <a:solidFill>
+                  <a:srgbClr val="FFFFFF"/>
+                </a:solidFill>
+                <a:latin typeface="Calibri Light"/>
+              </a:rPr>
+              <a:t>La physique ne négocie pas</a:t>
+            </a:r>
+          </a:p>
+        </p:txBody>
+      </p:sp>
+      <p:sp>
+        <p:nvSpPr>
+          <p:cNvPr id="5" name="Rectangle 4"/>
+          <p:cNvSpPr/>
+          <p:nvPr/>
+        </p:nvSpPr>
+        <p:spPr>
+          <a:xfrm>
+            <a:off x="0" y="6510528"/>
+            <a:ext cx="12188952" cy="347472"/>
+          </a:xfrm>
+          <a:prstGeom prst="rect">
+            <a:avLst/>
+          </a:prstGeom>
+          <a:solidFill>
+            <a:srgbClr val="1A3A5C"/>
+          </a:solidFill>
+          <a:ln>
+            <a:noFill/>
+          </a:ln>
+          <a:effectLst/>
+        </p:spPr>
+        <p:style>
+          <a:lnRef idx="1">
+            <a:schemeClr val="accent1"/>
+          </a:lnRef>
+          <a:fillRef idx="3">
+            <a:schemeClr val="accent1"/>
+          </a:fillRef>
+          <a:effectRef idx="2">
+            <a:schemeClr val="accent1"/>
+          </a:effectRef>
+          <a:fontRef idx="minor">
+            <a:schemeClr val="lt1"/>
+          </a:fontRef>
+        </p:style>
+        <p:txBody>
+          <a:bodyPr rtlCol="0" anchor="ctr"/>
+          <a:lstStyle/>
+          <a:p>
+            <a:pPr algn="ctr"/>
+          </a:p>
+        </p:txBody>
+      </p:sp>
+      <p:sp>
+        <p:nvSpPr>
+          <p:cNvPr id="6" name="TextBox 5"/>
+          <p:cNvSpPr txBox="1"/>
+          <p:nvPr/>
+        </p:nvSpPr>
+        <p:spPr>
+          <a:xfrm>
+            <a:off x="365760" y="6556248"/>
+            <a:ext cx="8229600" cy="274320"/>
+          </a:xfrm>
+          <a:prstGeom prst="rect">
+            <a:avLst/>
+          </a:prstGeom>
+          <a:noFill/>
+        </p:spPr>
+        <p:txBody>
+          <a:bodyPr wrap="square">
+            <a:spAutoFit/>
+          </a:bodyPr>
+          <a:lstStyle/>
+          <a:p>
+            <a:pPr algn="l"/>
+            <a:r>
+              <a:rPr sz="900" b="0" i="0">
+                <a:solidFill>
+                  <a:srgbClr val="D2EBF8"/>
+                </a:solidFill>
+                <a:latin typeface="Calibri"/>
+              </a:rPr>
+              <a:t>Formation PPL · LAPL  —  Frédéric Vincenot · FI</a:t>
+            </a:r>
+          </a:p>
+        </p:txBody>
+      </p:sp>
+      <p:pic>
+        <p:nvPicPr>
+          <p:cNvPr id="7" name="Picture 6" descr="tampon_fv_gris.png"/>
+          <p:cNvPicPr>
+            <a:picLocks noChangeAspect="1"/>
+          </p:cNvPicPr>
+          <p:nvPr/>
+        </p:nvPicPr>
+        <p:blipFill>
+          <a:blip r:embed="rId2"/>
+          <a:stretch>
+            <a:fillRect/>
+          </a:stretch>
+        </p:blipFill>
+        <p:spPr>
+          <a:xfrm>
+            <a:off x="11274552" y="6108192"/>
+            <a:ext cx="640080" cy="320040"/>
+          </a:xfrm>
+          <a:prstGeom prst="rect">
+            <a:avLst/>
+          </a:prstGeom>
+        </p:spPr>
+      </p:pic>
+      <p:sp>
+        <p:nvSpPr>
+          <p:cNvPr id="8" name="TextBox 7"/>
+          <p:cNvSpPr txBox="1"/>
+          <p:nvPr/>
+        </p:nvSpPr>
+        <p:spPr>
+          <a:xfrm>
+            <a:off x="11686032" y="6556248"/>
+            <a:ext cx="365760" cy="274320"/>
+          </a:xfrm>
+          <a:prstGeom prst="rect">
+            <a:avLst/>
+          </a:prstGeom>
+          <a:noFill/>
+        </p:spPr>
+        <p:txBody>
+          <a:bodyPr wrap="square">
+            <a:spAutoFit/>
+          </a:bodyPr>
+          <a:lstStyle/>
+          <a:p>
+            <a:pPr algn="r"/>
+            <a:r>
+              <a:rPr sz="900" b="0" i="0">
+                <a:solidFill>
+                  <a:srgbClr val="D2EBF8"/>
+                </a:solidFill>
+                <a:latin typeface="Calibri"/>
+              </a:rPr>
+              <a:t>15</a:t>
+            </a:r>
+          </a:p>
+        </p:txBody>
+      </p:sp>
+      <p:sp>
+        <p:nvSpPr>
+          <p:cNvPr id="9" name="Rectangle 8"/>
+          <p:cNvSpPr/>
+          <p:nvPr/>
+        </p:nvSpPr>
+        <p:spPr>
+          <a:xfrm>
+            <a:off x="640080" y="1828800"/>
+            <a:ext cx="3566160" cy="54864"/>
+          </a:xfrm>
+          <a:prstGeom prst="rect">
+            <a:avLst/>
+          </a:prstGeom>
+          <a:solidFill>
+            <a:srgbClr val="D68910"/>
+          </a:solidFill>
+          <a:ln>
+            <a:noFill/>
+          </a:ln>
+          <a:effectLst/>
+        </p:spPr>
+        <p:style>
+          <a:lnRef idx="1">
+            <a:schemeClr val="accent1"/>
+          </a:lnRef>
+          <a:fillRef idx="3">
+            <a:schemeClr val="accent1"/>
+          </a:fillRef>
+          <a:effectRef idx="2">
+            <a:schemeClr val="accent1"/>
+          </a:effectRef>
+          <a:fontRef idx="minor">
+            <a:schemeClr val="lt1"/>
+          </a:fontRef>
+        </p:style>
+        <p:txBody>
+          <a:bodyPr rtlCol="0" anchor="ctr"/>
+          <a:lstStyle/>
+          <a:p>
+            <a:pPr algn="ctr"/>
+          </a:p>
+        </p:txBody>
+      </p:sp>
+      <p:sp>
+        <p:nvSpPr>
+          <p:cNvPr id="10" name="TextBox 9"/>
+          <p:cNvSpPr txBox="1"/>
+          <p:nvPr/>
+        </p:nvSpPr>
+        <p:spPr>
+          <a:xfrm>
+            <a:off x="640080" y="2148840"/>
+            <a:ext cx="3566160" cy="1188720"/>
+          </a:xfrm>
+          <a:prstGeom prst="rect">
+            <a:avLst/>
+          </a:prstGeom>
+          <a:noFill/>
+        </p:spPr>
+        <p:txBody>
+          <a:bodyPr wrap="square">
+            <a:spAutoFit/>
+          </a:bodyPr>
+          <a:lstStyle/>
+          <a:p>
+            <a:pPr algn="ctr"/>
+            <a:r>
+              <a:rPr sz="5000" b="1" i="0">
+                <a:solidFill>
+                  <a:srgbClr val="1A3A5C"/>
+                </a:solidFill>
+                <a:latin typeface="Calibri Light"/>
+              </a:rPr>
+              <a:t>+ 20 %</a:t>
+            </a:r>
+          </a:p>
+        </p:txBody>
+      </p:sp>
+      <p:sp>
+        <p:nvSpPr>
+          <p:cNvPr id="11" name="TextBox 10"/>
+          <p:cNvSpPr txBox="1"/>
+          <p:nvPr/>
+        </p:nvSpPr>
+        <p:spPr>
+          <a:xfrm>
+            <a:off x="640080" y="3429000"/>
+            <a:ext cx="3566160" cy="1005840"/>
+          </a:xfrm>
+          <a:prstGeom prst="rect">
+            <a:avLst/>
+          </a:prstGeom>
+          <a:noFill/>
+        </p:spPr>
+        <p:txBody>
+          <a:bodyPr wrap="square">
+            <a:spAutoFit/>
+          </a:bodyPr>
+          <a:lstStyle/>
+          <a:p>
+            <a:pPr algn="ctr"/>
+            <a:r>
+              <a:rPr sz="1500" b="0" i="0">
+                <a:solidFill>
+                  <a:srgbClr val="6B7A8C"/>
+                </a:solidFill>
+                <a:latin typeface="Calibri"/>
+              </a:rPr>
+              <a:t>de distance d'atterrissage pour 10 % de vitesse en trop (l'énergie varie avec le carré de la vitesse)</a:t>
+            </a:r>
+          </a:p>
+        </p:txBody>
+      </p:sp>
+      <p:sp>
+        <p:nvSpPr>
+          <p:cNvPr id="12" name="Rectangle 11"/>
+          <p:cNvSpPr/>
+          <p:nvPr/>
+        </p:nvSpPr>
+        <p:spPr>
+          <a:xfrm>
+            <a:off x="4434840" y="1828800"/>
+            <a:ext cx="3566160" cy="54864"/>
+          </a:xfrm>
+          <a:prstGeom prst="rect">
+            <a:avLst/>
+          </a:prstGeom>
+          <a:solidFill>
+            <a:srgbClr val="C0392B"/>
+          </a:solidFill>
+          <a:ln>
+            <a:noFill/>
+          </a:ln>
+          <a:effectLst/>
+        </p:spPr>
+        <p:style>
+          <a:lnRef idx="1">
+            <a:schemeClr val="accent1"/>
+          </a:lnRef>
+          <a:fillRef idx="3">
+            <a:schemeClr val="accent1"/>
+          </a:fillRef>
+          <a:effectRef idx="2">
+            <a:schemeClr val="accent1"/>
+          </a:effectRef>
+          <a:fontRef idx="minor">
+            <a:schemeClr val="lt1"/>
+          </a:fontRef>
+        </p:style>
+        <p:txBody>
+          <a:bodyPr rtlCol="0" anchor="ctr"/>
+          <a:lstStyle/>
+          <a:p>
+            <a:pPr algn="ctr"/>
+          </a:p>
+        </p:txBody>
+      </p:sp>
+      <p:sp>
+        <p:nvSpPr>
+          <p:cNvPr id="13" name="TextBox 12"/>
+          <p:cNvSpPr txBox="1"/>
+          <p:nvPr/>
+        </p:nvSpPr>
+        <p:spPr>
+          <a:xfrm>
+            <a:off x="4434840" y="2148840"/>
+            <a:ext cx="3566160" cy="1188720"/>
+          </a:xfrm>
+          <a:prstGeom prst="rect">
+            <a:avLst/>
+          </a:prstGeom>
+          <a:noFill/>
+        </p:spPr>
+        <p:txBody>
+          <a:bodyPr wrap="square">
+            <a:spAutoFit/>
+          </a:bodyPr>
+          <a:lstStyle/>
+          <a:p>
+            <a:pPr algn="ctr"/>
+            <a:r>
+              <a:rPr sz="5000" b="1" i="0">
+                <a:solidFill>
+                  <a:srgbClr val="1A3A5C"/>
+                </a:solidFill>
+                <a:latin typeface="Calibri Light"/>
+              </a:rPr>
+              <a:t>× 1,5</a:t>
+            </a:r>
+          </a:p>
+        </p:txBody>
+      </p:sp>
+      <p:sp>
+        <p:nvSpPr>
+          <p:cNvPr id="14" name="TextBox 13"/>
+          <p:cNvSpPr txBox="1"/>
+          <p:nvPr/>
+        </p:nvSpPr>
+        <p:spPr>
+          <a:xfrm>
+            <a:off x="4434840" y="3429000"/>
+            <a:ext cx="3566160" cy="1005840"/>
+          </a:xfrm>
+          <a:prstGeom prst="rect">
+            <a:avLst/>
+          </a:prstGeom>
+          <a:noFill/>
+        </p:spPr>
+        <p:txBody>
+          <a:bodyPr wrap="square">
+            <a:spAutoFit/>
+          </a:bodyPr>
+          <a:lstStyle/>
+          <a:p>
+            <a:pPr algn="ctr"/>
+            <a:r>
+              <a:rPr sz="1500" b="0" i="0">
+                <a:solidFill>
+                  <a:srgbClr val="6B7A8C"/>
+                </a:solidFill>
+                <a:latin typeface="Calibri"/>
+              </a:rPr>
+              <a:t>distance de roulement avec 10 kt de vent arrière (ordre de grandeur donné par les manuels Cessna)</a:t>
+            </a:r>
+          </a:p>
+        </p:txBody>
+      </p:sp>
+      <p:sp>
+        <p:nvSpPr>
+          <p:cNvPr id="15" name="Rectangle 14"/>
+          <p:cNvSpPr/>
+          <p:nvPr/>
+        </p:nvSpPr>
+        <p:spPr>
+          <a:xfrm>
+            <a:off x="8229600" y="1828800"/>
+            <a:ext cx="3566160" cy="54864"/>
+          </a:xfrm>
+          <a:prstGeom prst="rect">
+            <a:avLst/>
+          </a:prstGeom>
+          <a:solidFill>
+            <a:srgbClr val="D68910"/>
+          </a:solidFill>
+          <a:ln>
+            <a:noFill/>
+          </a:ln>
+          <a:effectLst/>
+        </p:spPr>
+        <p:style>
+          <a:lnRef idx="1">
+            <a:schemeClr val="accent1"/>
+          </a:lnRef>
+          <a:fillRef idx="3">
+            <a:schemeClr val="accent1"/>
+          </a:fillRef>
+          <a:effectRef idx="2">
+            <a:schemeClr val="accent1"/>
+          </a:effectRef>
+          <a:fontRef idx="minor">
+            <a:schemeClr val="lt1"/>
+          </a:fontRef>
+        </p:style>
+        <p:txBody>
+          <a:bodyPr rtlCol="0" anchor="ctr"/>
+          <a:lstStyle/>
+          <a:p>
+            <a:pPr algn="ctr"/>
+          </a:p>
+        </p:txBody>
+      </p:sp>
+      <p:sp>
+        <p:nvSpPr>
+          <p:cNvPr id="16" name="TextBox 15"/>
+          <p:cNvSpPr txBox="1"/>
+          <p:nvPr/>
+        </p:nvSpPr>
+        <p:spPr>
+          <a:xfrm>
+            <a:off x="8229600" y="2148840"/>
+            <a:ext cx="3566160" cy="1188720"/>
+          </a:xfrm>
+          <a:prstGeom prst="rect">
+            <a:avLst/>
+          </a:prstGeom>
+          <a:noFill/>
+        </p:spPr>
+        <p:txBody>
+          <a:bodyPr wrap="square">
+            <a:spAutoFit/>
+          </a:bodyPr>
+          <a:lstStyle/>
+          <a:p>
+            <a:pPr algn="ctr"/>
+            <a:r>
+              <a:rPr sz="5000" b="1" i="0">
+                <a:solidFill>
+                  <a:srgbClr val="1A3A5C"/>
+                </a:solidFill>
+                <a:latin typeface="Calibri Light"/>
+              </a:rPr>
+              <a:t>× 1,3</a:t>
+            </a:r>
+          </a:p>
+        </p:txBody>
+      </p:sp>
+      <p:sp>
+        <p:nvSpPr>
+          <p:cNvPr id="17" name="TextBox 16"/>
+          <p:cNvSpPr txBox="1"/>
+          <p:nvPr/>
+        </p:nvSpPr>
+        <p:spPr>
+          <a:xfrm>
+            <a:off x="8229600" y="3429000"/>
+            <a:ext cx="3566160" cy="1005840"/>
+          </a:xfrm>
+          <a:prstGeom prst="rect">
+            <a:avLst/>
+          </a:prstGeom>
+          <a:noFill/>
+        </p:spPr>
+        <p:txBody>
+          <a:bodyPr wrap="square">
+            <a:spAutoFit/>
+          </a:bodyPr>
+          <a:lstStyle/>
+          <a:p>
+            <a:pPr algn="ctr"/>
+            <a:r>
+              <a:rPr sz="1500" b="0" i="0">
+                <a:solidFill>
+                  <a:srgbClr val="6B7A8C"/>
+                </a:solidFill>
+                <a:latin typeface="Calibri"/>
+              </a:rPr>
+              <a:t>sur herbe mouillée ou haute, par rapport à une piste en dur sèche (majorations usuelles)</a:t>
+            </a:r>
+          </a:p>
+        </p:txBody>
+      </p:sp>
+      <p:sp>
+        <p:nvSpPr>
+          <p:cNvPr id="18" name="TextBox 17"/>
+          <p:cNvSpPr txBox="1"/>
+          <p:nvPr/>
+        </p:nvSpPr>
+        <p:spPr>
+          <a:xfrm>
+            <a:off x="640080" y="5120640"/>
+            <a:ext cx="10881360" cy="822960"/>
+          </a:xfrm>
+          <a:prstGeom prst="rect">
+            <a:avLst/>
+          </a:prstGeom>
+          <a:noFill/>
+        </p:spPr>
+        <p:txBody>
+          <a:bodyPr wrap="square">
+            <a:spAutoFit/>
+          </a:bodyPr>
+          <a:lstStyle/>
+          <a:p>
+            <a:pPr algn="l"/>
+            <a:r>
+              <a:rPr sz="1300" b="0" i="1">
+                <a:solidFill>
+                  <a:srgbClr val="6B7A8C"/>
+                </a:solidFill>
+                <a:latin typeface="Calibri"/>
+              </a:rPr>
+              <a:t>Ces coefficients se cumulent. Ils sont indicatifs : la référence reste le manuel de vol de l'avion, puis une marge personnelle par-dessus. Le calcul se fait au sol, avant le départ, jamais en finale.</a:t>
+            </a:r>
+          </a:p>
+        </p:txBody>
+      </p:sp>
+    </p:spTree>
+  </p:cSld>
+  <p:clrMapOvr>
+    <a:masterClrMapping/>
+  </p:clrMapOvr>
+</p:sld>
+</file>
+
+<file path=ppt/slides/slide16.xml><?xml version="1.0" encoding="utf-8"?>
 <p:sld xmlns:a="http://schemas.openxmlformats.org/drawingml/2006/main" xmlns:p="http://schemas.openxmlformats.org/presentationml/2006/main" xmlns:r="http://schemas.openxmlformats.org/officeDocument/2006/relationships">
   <p:cSld>
     <p:bg>
@@ -8438,7 +9393,7 @@
                 </a:solidFill>
                 <a:latin typeface="Calibri"/>
               </a:rPr>
-              <a:t>15</a:t>
+              <a:t>16</a:t>
             </a:r>
           </a:p>
         </p:txBody>
@@ -8451,7 +9406,7 @@
 </p:sld>
 </file>
 
-<file path=ppt/slides/slide16.xml><?xml version="1.0" encoding="utf-8"?>
+<file path=ppt/slides/slide17.xml><?xml version="1.0" encoding="utf-8"?>
 <p:sld xmlns:a="http://schemas.openxmlformats.org/drawingml/2006/main" xmlns:p="http://schemas.openxmlformats.org/presentationml/2006/main" xmlns:r="http://schemas.openxmlformats.org/officeDocument/2006/relationships">
   <p:cSld>
     <p:bg>
@@ -8725,7 +9680,7 @@
                 </a:solidFill>
                 <a:latin typeface="Calibri"/>
               </a:rPr>
-              <a:t>16</a:t>
+              <a:t>17</a:t>
             </a:r>
           </a:p>
         </p:txBody>
@@ -8921,7 +9876,7 @@
 </p:sld>
 </file>
 
-<file path=ppt/slides/slide17.xml><?xml version="1.0" encoding="utf-8"?>
+<file path=ppt/slides/slide18.xml><?xml version="1.0" encoding="utf-8"?>
 <p:sld xmlns:a="http://schemas.openxmlformats.org/drawingml/2006/main" xmlns:p="http://schemas.openxmlformats.org/presentationml/2006/main" xmlns:r="http://schemas.openxmlformats.org/officeDocument/2006/relationships">
   <p:cSld>
     <p:bg>
@@ -9195,7 +10150,7 @@
                 </a:solidFill>
                 <a:latin typeface="Calibri"/>
               </a:rPr>
-              <a:t>17</a:t>
+              <a:t>18</a:t>
             </a:r>
           </a:p>
         </p:txBody>
@@ -9680,460 +10635,6 @@
                 <a:latin typeface="Calibri"/>
               </a:rPr>
               <a:t>▸  J'ai déjà remis les gaz une fois : même règle la seconde fois</a:t>
-            </a:r>
-          </a:p>
-        </p:txBody>
-      </p:sp>
-    </p:spTree>
-  </p:cSld>
-  <p:clrMapOvr>
-    <a:masterClrMapping/>
-  </p:clrMapOvr>
-</p:sld>
-</file>
-
-<file path=ppt/slides/slide18.xml><?xml version="1.0" encoding="utf-8"?>
-<p:sld xmlns:a="http://schemas.openxmlformats.org/drawingml/2006/main" xmlns:p="http://schemas.openxmlformats.org/presentationml/2006/main" xmlns:r="http://schemas.openxmlformats.org/officeDocument/2006/relationships">
-  <p:cSld>
-    <p:bg>
-      <p:bgPr>
-        <a:solidFill>
-          <a:srgbClr val="FFFFFF"/>
-        </a:solidFill>
-        <a:effectLst/>
-      </p:bgPr>
-    </p:bg>
-    <p:spTree>
-      <p:nvGrpSpPr>
-        <p:cNvPr id="1" name=""/>
-        <p:cNvGrpSpPr/>
-        <p:nvPr/>
-      </p:nvGrpSpPr>
-      <p:grpSpPr/>
-      <p:sp>
-        <p:nvSpPr>
-          <p:cNvPr id="2" name="Rectangle 1"/>
-          <p:cNvSpPr/>
-          <p:nvPr/>
-        </p:nvSpPr>
-        <p:spPr>
-          <a:xfrm>
-            <a:off x="0" y="0"/>
-            <a:ext cx="12188952" cy="960120"/>
-          </a:xfrm>
-          <a:prstGeom prst="rect">
-            <a:avLst/>
-          </a:prstGeom>
-          <a:solidFill>
-            <a:srgbClr val="1A3A5C"/>
-          </a:solidFill>
-          <a:ln>
-            <a:noFill/>
-          </a:ln>
-          <a:effectLst/>
-        </p:spPr>
-        <p:style>
-          <a:lnRef idx="1">
-            <a:schemeClr val="accent1"/>
-          </a:lnRef>
-          <a:fillRef idx="3">
-            <a:schemeClr val="accent1"/>
-          </a:fillRef>
-          <a:effectRef idx="2">
-            <a:schemeClr val="accent1"/>
-          </a:effectRef>
-          <a:fontRef idx="minor">
-            <a:schemeClr val="lt1"/>
-          </a:fontRef>
-        </p:style>
-        <p:txBody>
-          <a:bodyPr rtlCol="0" anchor="ctr"/>
-          <a:lstStyle/>
-          <a:p>
-            <a:pPr algn="ctr"/>
-          </a:p>
-        </p:txBody>
-      </p:sp>
-      <p:sp>
-        <p:nvSpPr>
-          <p:cNvPr id="3" name="Rectangle 2"/>
-          <p:cNvSpPr/>
-          <p:nvPr/>
-        </p:nvSpPr>
-        <p:spPr>
-          <a:xfrm>
-            <a:off x="0" y="960120"/>
-            <a:ext cx="12188952" cy="54864"/>
-          </a:xfrm>
-          <a:prstGeom prst="rect">
-            <a:avLst/>
-          </a:prstGeom>
-          <a:solidFill>
-            <a:srgbClr val="4A9ED6"/>
-          </a:solidFill>
-          <a:ln>
-            <a:noFill/>
-          </a:ln>
-          <a:effectLst/>
-        </p:spPr>
-        <p:style>
-          <a:lnRef idx="1">
-            <a:schemeClr val="accent1"/>
-          </a:lnRef>
-          <a:fillRef idx="3">
-            <a:schemeClr val="accent1"/>
-          </a:fillRef>
-          <a:effectRef idx="2">
-            <a:schemeClr val="accent1"/>
-          </a:effectRef>
-          <a:fontRef idx="minor">
-            <a:schemeClr val="lt1"/>
-          </a:fontRef>
-        </p:style>
-        <p:txBody>
-          <a:bodyPr rtlCol="0" anchor="ctr"/>
-          <a:lstStyle/>
-          <a:p>
-            <a:pPr algn="ctr"/>
-          </a:p>
-        </p:txBody>
-      </p:sp>
-      <p:sp>
-        <p:nvSpPr>
-          <p:cNvPr id="4" name="TextBox 3"/>
-          <p:cNvSpPr txBox="1"/>
-          <p:nvPr/>
-        </p:nvSpPr>
-        <p:spPr>
-          <a:xfrm>
-            <a:off x="457200" y="155448"/>
-            <a:ext cx="11274552" cy="713232"/>
-          </a:xfrm>
-          <a:prstGeom prst="rect">
-            <a:avLst/>
-          </a:prstGeom>
-          <a:noFill/>
-        </p:spPr>
-        <p:txBody>
-          <a:bodyPr wrap="square" anchor="ctr">
-            <a:spAutoFit/>
-          </a:bodyPr>
-          <a:lstStyle/>
-          <a:p>
-            <a:pPr algn="l"/>
-            <a:r>
-              <a:rPr sz="2800" b="1" i="0">
-                <a:solidFill>
-                  <a:srgbClr val="FFFFFF"/>
-                </a:solidFill>
-                <a:latin typeface="Calibri Light"/>
-              </a:rPr>
-              <a:t>Application à nos pistes et à nos navigations</a:t>
-            </a:r>
-          </a:p>
-        </p:txBody>
-      </p:sp>
-      <p:sp>
-        <p:nvSpPr>
-          <p:cNvPr id="5" name="Rectangle 4"/>
-          <p:cNvSpPr/>
-          <p:nvPr/>
-        </p:nvSpPr>
-        <p:spPr>
-          <a:xfrm>
-            <a:off x="0" y="6510528"/>
-            <a:ext cx="12188952" cy="347472"/>
-          </a:xfrm>
-          <a:prstGeom prst="rect">
-            <a:avLst/>
-          </a:prstGeom>
-          <a:solidFill>
-            <a:srgbClr val="1A3A5C"/>
-          </a:solidFill>
-          <a:ln>
-            <a:noFill/>
-          </a:ln>
-          <a:effectLst/>
-        </p:spPr>
-        <p:style>
-          <a:lnRef idx="1">
-            <a:schemeClr val="accent1"/>
-          </a:lnRef>
-          <a:fillRef idx="3">
-            <a:schemeClr val="accent1"/>
-          </a:fillRef>
-          <a:effectRef idx="2">
-            <a:schemeClr val="accent1"/>
-          </a:effectRef>
-          <a:fontRef idx="minor">
-            <a:schemeClr val="lt1"/>
-          </a:fontRef>
-        </p:style>
-        <p:txBody>
-          <a:bodyPr rtlCol="0" anchor="ctr"/>
-          <a:lstStyle/>
-          <a:p>
-            <a:pPr algn="ctr"/>
-          </a:p>
-        </p:txBody>
-      </p:sp>
-      <p:sp>
-        <p:nvSpPr>
-          <p:cNvPr id="6" name="TextBox 5"/>
-          <p:cNvSpPr txBox="1"/>
-          <p:nvPr/>
-        </p:nvSpPr>
-        <p:spPr>
-          <a:xfrm>
-            <a:off x="365760" y="6556248"/>
-            <a:ext cx="8229600" cy="274320"/>
-          </a:xfrm>
-          <a:prstGeom prst="rect">
-            <a:avLst/>
-          </a:prstGeom>
-          <a:noFill/>
-        </p:spPr>
-        <p:txBody>
-          <a:bodyPr wrap="square">
-            <a:spAutoFit/>
-          </a:bodyPr>
-          <a:lstStyle/>
-          <a:p>
-            <a:pPr algn="l"/>
-            <a:r>
-              <a:rPr sz="900" b="0" i="0">
-                <a:solidFill>
-                  <a:srgbClr val="D2EBF8"/>
-                </a:solidFill>
-                <a:latin typeface="Calibri"/>
-              </a:rPr>
-              <a:t>Formation PPL · LAPL  —  Frédéric Vincenot · FI</a:t>
-            </a:r>
-          </a:p>
-        </p:txBody>
-      </p:sp>
-      <p:pic>
-        <p:nvPicPr>
-          <p:cNvPr id="7" name="Picture 6" descr="tampon_fv_gris.png"/>
-          <p:cNvPicPr>
-            <a:picLocks noChangeAspect="1"/>
-          </p:cNvPicPr>
-          <p:nvPr/>
-        </p:nvPicPr>
-        <p:blipFill>
-          <a:blip r:embed="rId2"/>
-          <a:stretch>
-            <a:fillRect/>
-          </a:stretch>
-        </p:blipFill>
-        <p:spPr>
-          <a:xfrm>
-            <a:off x="11274552" y="6108192"/>
-            <a:ext cx="640080" cy="320040"/>
-          </a:xfrm>
-          <a:prstGeom prst="rect">
-            <a:avLst/>
-          </a:prstGeom>
-        </p:spPr>
-      </p:pic>
-      <p:sp>
-        <p:nvSpPr>
-          <p:cNvPr id="8" name="TextBox 7"/>
-          <p:cNvSpPr txBox="1"/>
-          <p:nvPr/>
-        </p:nvSpPr>
-        <p:spPr>
-          <a:xfrm>
-            <a:off x="11686032" y="6556248"/>
-            <a:ext cx="365760" cy="274320"/>
-          </a:xfrm>
-          <a:prstGeom prst="rect">
-            <a:avLst/>
-          </a:prstGeom>
-          <a:noFill/>
-        </p:spPr>
-        <p:txBody>
-          <a:bodyPr wrap="square">
-            <a:spAutoFit/>
-          </a:bodyPr>
-          <a:lstStyle/>
-          <a:p>
-            <a:pPr algn="r"/>
-            <a:r>
-              <a:rPr sz="900" b="0" i="0">
-                <a:solidFill>
-                  <a:srgbClr val="D2EBF8"/>
-                </a:solidFill>
-                <a:latin typeface="Calibri"/>
-              </a:rPr>
-              <a:t>18</a:t>
-            </a:r>
-          </a:p>
-        </p:txBody>
-      </p:sp>
-      <p:sp>
-        <p:nvSpPr>
-          <p:cNvPr id="9" name="TextBox 8"/>
-          <p:cNvSpPr txBox="1"/>
-          <p:nvPr/>
-        </p:nvSpPr>
-        <p:spPr>
-          <a:xfrm>
-            <a:off x="548640" y="1188720"/>
-            <a:ext cx="10881360" cy="5120640"/>
-          </a:xfrm>
-          <a:prstGeom prst="rect">
-            <a:avLst/>
-          </a:prstGeom>
-          <a:noFill/>
-        </p:spPr>
-        <p:txBody>
-          <a:bodyPr wrap="square">
-            <a:spAutoFit/>
-          </a:bodyPr>
-          <a:lstStyle/>
-          <a:p>
-            <a:pPr>
-              <a:spcAft>
-                <a:spcPts val="900"/>
-              </a:spcAft>
-            </a:pPr>
-            <a:r>
-              <a:rPr sz="2000" b="1">
-                <a:solidFill>
-                  <a:srgbClr val="1A3A5C"/>
-                </a:solidFill>
-                <a:latin typeface="Calibri"/>
-              </a:rPr>
-              <a:t>▸  Nos pistes : longueur, revêtement, pente, repère de remise de gaz</a:t>
-            </a:r>
-          </a:p>
-          <a:p>
-            <a:pPr>
-              <a:spcAft>
-                <a:spcPts val="900"/>
-              </a:spcAft>
-            </a:pPr>
-            <a:r>
-              <a:rPr sz="1500">
-                <a:solidFill>
-                  <a:srgbClr val="5A6A7E"/>
-                </a:solidFill>
-                <a:latin typeface="Calibri Light"/>
-              </a:rPr>
-              <a:t>       [À compléter : pour chaque QFU, un repère visible depuis le cockpit avant lequel les roues doivent être au sol.]</a:t>
-            </a:r>
-          </a:p>
-          <a:p>
-            <a:pPr>
-              <a:spcAft>
-                <a:spcPts val="900"/>
-              </a:spcAft>
-            </a:pPr>
-            <a:r>
-              <a:rPr sz="2000" b="1">
-                <a:solidFill>
-                  <a:srgbClr val="1A3A5C"/>
-                </a:solidFill>
-                <a:latin typeface="Calibri"/>
-              </a:rPr>
-              <a:t>▸  Nos terrains de navigation habituels de moins de 800 m</a:t>
-            </a:r>
-          </a:p>
-          <a:p>
-            <a:pPr>
-              <a:spcAft>
-                <a:spcPts val="900"/>
-              </a:spcAft>
-            </a:pPr>
-            <a:r>
-              <a:rPr sz="1500">
-                <a:solidFill>
-                  <a:srgbClr val="5A6A7E"/>
-                </a:solidFill>
-                <a:latin typeface="Calibri Light"/>
-              </a:rPr>
-              <a:t>       [À compléter : liste des terrains courts fréquentés par le club, avec leurs particularités VAC.]</a:t>
-            </a:r>
-          </a:p>
-          <a:p>
-            <a:pPr>
-              <a:spcAft>
-                <a:spcPts val="900"/>
-              </a:spcAft>
-            </a:pPr>
-            <a:r>
-              <a:rPr sz="2000" b="1">
-                <a:solidFill>
-                  <a:srgbClr val="1A3A5C"/>
-                </a:solidFill>
-                <a:latin typeface="Calibri"/>
-              </a:rPr>
-              <a:t>▸  Exercice au tableau : distance d'atterrissage majorée</a:t>
-            </a:r>
-          </a:p>
-          <a:p>
-            <a:pPr>
-              <a:spcAft>
-                <a:spcPts val="900"/>
-              </a:spcAft>
-            </a:pPr>
-            <a:r>
-              <a:rPr sz="1500">
-                <a:solidFill>
-                  <a:srgbClr val="5A6A7E"/>
-                </a:solidFill>
-                <a:latin typeface="Calibri Light"/>
-              </a:rPr>
-              <a:t>       Distance manuel (piste dure, sèche, vent nul) × herbe × mouillée × vent arrière × marge personnelle = ?</a:t>
-            </a:r>
-          </a:p>
-          <a:p>
-            <a:pPr>
-              <a:spcAft>
-                <a:spcPts val="900"/>
-              </a:spcAft>
-            </a:pPr>
-            <a:r>
-              <a:rPr sz="1500">
-                <a:solidFill>
-                  <a:srgbClr val="5A6A7E"/>
-                </a:solidFill>
-                <a:latin typeface="Calibri Light"/>
-              </a:rPr>
-              <a:t>       Comparer le résultat à la longueur de piste. Si l'écart est faible, le terrain est hors limites ce jour-là.</a:t>
-            </a:r>
-          </a:p>
-          <a:p>
-            <a:pPr>
-              <a:spcAft>
-                <a:spcPts val="900"/>
-              </a:spcAft>
-            </a:pPr>
-            <a:r>
-              <a:rPr sz="2000" b="1">
-                <a:solidFill>
-                  <a:srgbClr val="1A3A5C"/>
-                </a:solidFill>
-                <a:latin typeface="Calibri"/>
-              </a:rPr>
-              <a:t>▸  Engagement de séance</a:t>
-            </a:r>
-          </a:p>
-          <a:p>
-            <a:pPr>
-              <a:spcAft>
-                <a:spcPts val="900"/>
-              </a:spcAft>
-            </a:pPr>
-            <a:r>
-              <a:rPr sz="1500">
-                <a:solidFill>
-                  <a:srgbClr val="5A6A7E"/>
-                </a:solidFill>
-                <a:latin typeface="Calibri Light"/>
-              </a:rPr>
-              <a:t>       Chacun repart avec une valeur de distance pour son avion habituel et un repère de remise de gaz sur notre piste principale.</a:t>
             </a:r>
           </a:p>
         </p:txBody>
@@ -10282,7 +10783,7 @@
                 </a:solidFill>
                 <a:latin typeface="Calibri Light"/>
               </a:rPr>
-              <a:t>Question de révision</a:t>
+              <a:t>Application à nos pistes et à nos navigations</a:t>
             </a:r>
           </a:p>
         </p:txBody>
@@ -10427,595 +10928,14 @@
       </p:sp>
       <p:sp>
         <p:nvSpPr>
-          <p:cNvPr id="9" name="Rectangle 8"/>
-          <p:cNvSpPr/>
-          <p:nvPr/>
-        </p:nvSpPr>
-        <p:spPr>
-          <a:xfrm>
-            <a:off x="640080" y="1325880"/>
-            <a:ext cx="10881360" cy="1005840"/>
-          </a:xfrm>
-          <a:prstGeom prst="rect">
-            <a:avLst/>
-          </a:prstGeom>
-          <a:solidFill>
-            <a:srgbClr val="D2EBF8"/>
-          </a:solidFill>
-          <a:ln>
-            <a:noFill/>
-          </a:ln>
-          <a:effectLst/>
-        </p:spPr>
-        <p:style>
-          <a:lnRef idx="1">
-            <a:schemeClr val="accent1"/>
-          </a:lnRef>
-          <a:fillRef idx="3">
-            <a:schemeClr val="accent1"/>
-          </a:fillRef>
-          <a:effectRef idx="2">
-            <a:schemeClr val="accent1"/>
-          </a:effectRef>
-          <a:fontRef idx="minor">
-            <a:schemeClr val="lt1"/>
-          </a:fontRef>
-        </p:style>
-        <p:txBody>
-          <a:bodyPr rtlCol="0" anchor="ctr" wrap="square" lIns="228600"/>
-          <a:lstStyle/>
-          <a:p>
-            <a:pPr algn="ctr"/>
-            <a:r>
-              <a:rPr sz="1800" b="1">
-                <a:solidFill>
-                  <a:srgbClr val="1A3A5C"/>
-                </a:solidFill>
-                <a:latin typeface="Calibri"/>
-              </a:rPr>
-              <a:t>Finale sur une piste en herbe de 750 m. À 300 ft sol, vous êtes à Vref + 15 kt et légèrement au-dessus du plan. Que faites-vous ?</a:t>
-            </a:r>
-          </a:p>
-        </p:txBody>
-      </p:sp>
-      <p:sp>
-        <p:nvSpPr>
-          <p:cNvPr id="10" name="Rectangle 9"/>
-          <p:cNvSpPr/>
-          <p:nvPr/>
-        </p:nvSpPr>
-        <p:spPr>
-          <a:xfrm>
-            <a:off x="640080" y="2697480"/>
-            <a:ext cx="5257800" cy="1051560"/>
-          </a:xfrm>
-          <a:prstGeom prst="rect">
-            <a:avLst/>
-          </a:prstGeom>
-          <a:solidFill>
-            <a:srgbClr val="F5F7FA"/>
-          </a:solidFill>
-          <a:ln>
-            <a:noFill/>
-          </a:ln>
-          <a:effectLst/>
-        </p:spPr>
-        <p:style>
-          <a:lnRef idx="1">
-            <a:schemeClr val="accent1"/>
-          </a:lnRef>
-          <a:fillRef idx="3">
-            <a:schemeClr val="accent1"/>
-          </a:fillRef>
-          <a:effectRef idx="2">
-            <a:schemeClr val="accent1"/>
-          </a:effectRef>
-          <a:fontRef idx="minor">
-            <a:schemeClr val="lt1"/>
-          </a:fontRef>
-        </p:style>
-        <p:txBody>
-          <a:bodyPr rtlCol="0" anchor="ctr"/>
-          <a:lstStyle/>
-          <a:p>
-            <a:pPr algn="ctr"/>
-          </a:p>
-        </p:txBody>
-      </p:sp>
-      <p:sp>
-        <p:nvSpPr>
-          <p:cNvPr id="11" name="Oval 10"/>
-          <p:cNvSpPr/>
-          <p:nvPr/>
-        </p:nvSpPr>
-        <p:spPr>
-          <a:xfrm>
-            <a:off x="804671" y="2990088"/>
-            <a:ext cx="457200" cy="457200"/>
-          </a:xfrm>
-          <a:prstGeom prst="ellipse">
-            <a:avLst/>
-          </a:prstGeom>
-          <a:solidFill>
-            <a:srgbClr val="1A3A5C"/>
-          </a:solidFill>
-          <a:ln>
-            <a:noFill/>
-          </a:ln>
-          <a:effectLst/>
-        </p:spPr>
-        <p:style>
-          <a:lnRef idx="1">
-            <a:schemeClr val="accent1"/>
-          </a:lnRef>
-          <a:fillRef idx="3">
-            <a:schemeClr val="accent1"/>
-          </a:fillRef>
-          <a:effectRef idx="2">
-            <a:schemeClr val="accent1"/>
-          </a:effectRef>
-          <a:fontRef idx="minor">
-            <a:schemeClr val="lt1"/>
-          </a:fontRef>
-        </p:style>
-        <p:txBody>
-          <a:bodyPr rtlCol="0" anchor="ctr"/>
-          <a:lstStyle/>
-          <a:p>
-            <a:pPr algn="ctr"/>
-            <a:r>
-              <a:rPr sz="1600" b="1">
-                <a:solidFill>
-                  <a:srgbClr val="FFFFFF"/>
-                </a:solidFill>
-                <a:latin typeface="Calibri"/>
-              </a:rPr>
-              <a:t>A</a:t>
-            </a:r>
-          </a:p>
-        </p:txBody>
-      </p:sp>
-      <p:sp>
-        <p:nvSpPr>
-          <p:cNvPr id="12" name="TextBox 11"/>
+          <p:cNvPr id="9" name="TextBox 8"/>
           <p:cNvSpPr txBox="1"/>
           <p:nvPr/>
         </p:nvSpPr>
         <p:spPr>
           <a:xfrm>
-            <a:off x="1417319" y="2834640"/>
-            <a:ext cx="4389120" cy="777240"/>
-          </a:xfrm>
-          <a:prstGeom prst="rect">
-            <a:avLst/>
-          </a:prstGeom>
-          <a:noFill/>
-        </p:spPr>
-        <p:txBody>
-          <a:bodyPr wrap="square" anchor="ctr">
-            <a:spAutoFit/>
-          </a:bodyPr>
-          <a:lstStyle/>
-          <a:p>
-            <a:pPr algn="l"/>
-            <a:r>
-              <a:rPr sz="1400" b="0" i="0">
-                <a:solidFill>
-                  <a:srgbClr val="1A3A5C"/>
-                </a:solidFill>
-                <a:latin typeface="Calibri"/>
-              </a:rPr>
-              <a:t>Réduire les gaz, sortir le dernier cran de volets et rattraper le plan avant l'arrondi</a:t>
-            </a:r>
-          </a:p>
-        </p:txBody>
-      </p:sp>
-      <p:sp>
-        <p:nvSpPr>
-          <p:cNvPr id="13" name="Rectangle 12"/>
-          <p:cNvSpPr/>
-          <p:nvPr/>
-        </p:nvSpPr>
-        <p:spPr>
-          <a:xfrm>
-            <a:off x="6263640" y="2697480"/>
-            <a:ext cx="5257800" cy="1051560"/>
-          </a:xfrm>
-          <a:prstGeom prst="rect">
-            <a:avLst/>
-          </a:prstGeom>
-          <a:solidFill>
-            <a:srgbClr val="E3F1E8"/>
-          </a:solidFill>
-          <a:ln>
-            <a:noFill/>
-          </a:ln>
-          <a:effectLst/>
-        </p:spPr>
-        <p:style>
-          <a:lnRef idx="1">
-            <a:schemeClr val="accent1"/>
-          </a:lnRef>
-          <a:fillRef idx="3">
-            <a:schemeClr val="accent1"/>
-          </a:fillRef>
-          <a:effectRef idx="2">
-            <a:schemeClr val="accent1"/>
-          </a:effectRef>
-          <a:fontRef idx="minor">
-            <a:schemeClr val="lt1"/>
-          </a:fontRef>
-        </p:style>
-        <p:txBody>
-          <a:bodyPr rtlCol="0" anchor="ctr"/>
-          <a:lstStyle/>
-          <a:p>
-            <a:pPr algn="ctr"/>
-          </a:p>
-        </p:txBody>
-      </p:sp>
-      <p:sp>
-        <p:nvSpPr>
-          <p:cNvPr id="14" name="Oval 13"/>
-          <p:cNvSpPr/>
-          <p:nvPr/>
-        </p:nvSpPr>
-        <p:spPr>
-          <a:xfrm>
-            <a:off x="6428231" y="2990088"/>
-            <a:ext cx="457200" cy="457200"/>
-          </a:xfrm>
-          <a:prstGeom prst="ellipse">
-            <a:avLst/>
-          </a:prstGeom>
-          <a:solidFill>
-            <a:srgbClr val="2E7D4F"/>
-          </a:solidFill>
-          <a:ln>
-            <a:noFill/>
-          </a:ln>
-          <a:effectLst/>
-        </p:spPr>
-        <p:style>
-          <a:lnRef idx="1">
-            <a:schemeClr val="accent1"/>
-          </a:lnRef>
-          <a:fillRef idx="3">
-            <a:schemeClr val="accent1"/>
-          </a:fillRef>
-          <a:effectRef idx="2">
-            <a:schemeClr val="accent1"/>
-          </a:effectRef>
-          <a:fontRef idx="minor">
-            <a:schemeClr val="lt1"/>
-          </a:fontRef>
-        </p:style>
-        <p:txBody>
-          <a:bodyPr rtlCol="0" anchor="ctr"/>
-          <a:lstStyle/>
-          <a:p>
-            <a:pPr algn="ctr"/>
-            <a:r>
-              <a:rPr sz="1600" b="1">
-                <a:solidFill>
-                  <a:srgbClr val="FFFFFF"/>
-                </a:solidFill>
-                <a:latin typeface="Calibri"/>
-              </a:rPr>
-              <a:t>B</a:t>
-            </a:r>
-          </a:p>
-        </p:txBody>
-      </p:sp>
-      <p:sp>
-        <p:nvSpPr>
-          <p:cNvPr id="15" name="TextBox 14"/>
-          <p:cNvSpPr txBox="1"/>
-          <p:nvPr/>
-        </p:nvSpPr>
-        <p:spPr>
-          <a:xfrm>
-            <a:off x="7040879" y="2834640"/>
-            <a:ext cx="4389120" cy="777240"/>
-          </a:xfrm>
-          <a:prstGeom prst="rect">
-            <a:avLst/>
-          </a:prstGeom>
-          <a:noFill/>
-        </p:spPr>
-        <p:txBody>
-          <a:bodyPr wrap="square" anchor="ctr">
-            <a:spAutoFit/>
-          </a:bodyPr>
-          <a:lstStyle/>
-          <a:p>
-            <a:pPr algn="l"/>
-            <a:r>
-              <a:rPr sz="1400" b="1" i="0">
-                <a:solidFill>
-                  <a:srgbClr val="2E7D4F"/>
-                </a:solidFill>
-                <a:latin typeface="Calibri"/>
-              </a:rPr>
-              <a:t>Remettre les gaz maintenant, refaire un tour de piste complet et une finale stabilisée</a:t>
-            </a:r>
-          </a:p>
-        </p:txBody>
-      </p:sp>
-      <p:sp>
-        <p:nvSpPr>
-          <p:cNvPr id="16" name="Rectangle 15"/>
-          <p:cNvSpPr/>
-          <p:nvPr/>
-        </p:nvSpPr>
-        <p:spPr>
-          <a:xfrm>
-            <a:off x="640080" y="4069080"/>
-            <a:ext cx="5257800" cy="1051560"/>
-          </a:xfrm>
-          <a:prstGeom prst="rect">
-            <a:avLst/>
-          </a:prstGeom>
-          <a:solidFill>
-            <a:srgbClr val="F5F7FA"/>
-          </a:solidFill>
-          <a:ln>
-            <a:noFill/>
-          </a:ln>
-          <a:effectLst/>
-        </p:spPr>
-        <p:style>
-          <a:lnRef idx="1">
-            <a:schemeClr val="accent1"/>
-          </a:lnRef>
-          <a:fillRef idx="3">
-            <a:schemeClr val="accent1"/>
-          </a:fillRef>
-          <a:effectRef idx="2">
-            <a:schemeClr val="accent1"/>
-          </a:effectRef>
-          <a:fontRef idx="minor">
-            <a:schemeClr val="lt1"/>
-          </a:fontRef>
-        </p:style>
-        <p:txBody>
-          <a:bodyPr rtlCol="0" anchor="ctr"/>
-          <a:lstStyle/>
-          <a:p>
-            <a:pPr algn="ctr"/>
-          </a:p>
-        </p:txBody>
-      </p:sp>
-      <p:sp>
-        <p:nvSpPr>
-          <p:cNvPr id="17" name="Oval 16"/>
-          <p:cNvSpPr/>
-          <p:nvPr/>
-        </p:nvSpPr>
-        <p:spPr>
-          <a:xfrm>
-            <a:off x="804671" y="4361688"/>
-            <a:ext cx="457200" cy="457200"/>
-          </a:xfrm>
-          <a:prstGeom prst="ellipse">
-            <a:avLst/>
-          </a:prstGeom>
-          <a:solidFill>
-            <a:srgbClr val="1A3A5C"/>
-          </a:solidFill>
-          <a:ln>
-            <a:noFill/>
-          </a:ln>
-          <a:effectLst/>
-        </p:spPr>
-        <p:style>
-          <a:lnRef idx="1">
-            <a:schemeClr val="accent1"/>
-          </a:lnRef>
-          <a:fillRef idx="3">
-            <a:schemeClr val="accent1"/>
-          </a:fillRef>
-          <a:effectRef idx="2">
-            <a:schemeClr val="accent1"/>
-          </a:effectRef>
-          <a:fontRef idx="minor">
-            <a:schemeClr val="lt1"/>
-          </a:fontRef>
-        </p:style>
-        <p:txBody>
-          <a:bodyPr rtlCol="0" anchor="ctr"/>
-          <a:lstStyle/>
-          <a:p>
-            <a:pPr algn="ctr"/>
-            <a:r>
-              <a:rPr sz="1600" b="1">
-                <a:solidFill>
-                  <a:srgbClr val="FFFFFF"/>
-                </a:solidFill>
-                <a:latin typeface="Calibri"/>
-              </a:rPr>
-              <a:t>C</a:t>
-            </a:r>
-          </a:p>
-        </p:txBody>
-      </p:sp>
-      <p:sp>
-        <p:nvSpPr>
-          <p:cNvPr id="18" name="TextBox 17"/>
-          <p:cNvSpPr txBox="1"/>
-          <p:nvPr/>
-        </p:nvSpPr>
-        <p:spPr>
-          <a:xfrm>
-            <a:off x="1417319" y="4206240"/>
-            <a:ext cx="4389120" cy="777240"/>
-          </a:xfrm>
-          <a:prstGeom prst="rect">
-            <a:avLst/>
-          </a:prstGeom>
-          <a:noFill/>
-        </p:spPr>
-        <p:txBody>
-          <a:bodyPr wrap="square" anchor="ctr">
-            <a:spAutoFit/>
-          </a:bodyPr>
-          <a:lstStyle/>
-          <a:p>
-            <a:pPr algn="l"/>
-            <a:r>
-              <a:rPr sz="1400" b="0" i="0">
-                <a:solidFill>
-                  <a:srgbClr val="1A3A5C"/>
-                </a:solidFill>
-                <a:latin typeface="Calibri"/>
-              </a:rPr>
-              <a:t>Continuer, poser dans le premier tiers et freiner énergiquement</a:t>
-            </a:r>
-          </a:p>
-        </p:txBody>
-      </p:sp>
-      <p:sp>
-        <p:nvSpPr>
-          <p:cNvPr id="19" name="Rectangle 18"/>
-          <p:cNvSpPr/>
-          <p:nvPr/>
-        </p:nvSpPr>
-        <p:spPr>
-          <a:xfrm>
-            <a:off x="6263640" y="4069080"/>
-            <a:ext cx="5257800" cy="1051560"/>
-          </a:xfrm>
-          <a:prstGeom prst="rect">
-            <a:avLst/>
-          </a:prstGeom>
-          <a:solidFill>
-            <a:srgbClr val="F5F7FA"/>
-          </a:solidFill>
-          <a:ln>
-            <a:noFill/>
-          </a:ln>
-          <a:effectLst/>
-        </p:spPr>
-        <p:style>
-          <a:lnRef idx="1">
-            <a:schemeClr val="accent1"/>
-          </a:lnRef>
-          <a:fillRef idx="3">
-            <a:schemeClr val="accent1"/>
-          </a:fillRef>
-          <a:effectRef idx="2">
-            <a:schemeClr val="accent1"/>
-          </a:effectRef>
-          <a:fontRef idx="minor">
-            <a:schemeClr val="lt1"/>
-          </a:fontRef>
-        </p:style>
-        <p:txBody>
-          <a:bodyPr rtlCol="0" anchor="ctr"/>
-          <a:lstStyle/>
-          <a:p>
-            <a:pPr algn="ctr"/>
-          </a:p>
-        </p:txBody>
-      </p:sp>
-      <p:sp>
-        <p:nvSpPr>
-          <p:cNvPr id="20" name="Oval 19"/>
-          <p:cNvSpPr/>
-          <p:nvPr/>
-        </p:nvSpPr>
-        <p:spPr>
-          <a:xfrm>
-            <a:off x="6428231" y="4361688"/>
-            <a:ext cx="457200" cy="457200"/>
-          </a:xfrm>
-          <a:prstGeom prst="ellipse">
-            <a:avLst/>
-          </a:prstGeom>
-          <a:solidFill>
-            <a:srgbClr val="1A3A5C"/>
-          </a:solidFill>
-          <a:ln>
-            <a:noFill/>
-          </a:ln>
-          <a:effectLst/>
-        </p:spPr>
-        <p:style>
-          <a:lnRef idx="1">
-            <a:schemeClr val="accent1"/>
-          </a:lnRef>
-          <a:fillRef idx="3">
-            <a:schemeClr val="accent1"/>
-          </a:fillRef>
-          <a:effectRef idx="2">
-            <a:schemeClr val="accent1"/>
-          </a:effectRef>
-          <a:fontRef idx="minor">
-            <a:schemeClr val="lt1"/>
-          </a:fontRef>
-        </p:style>
-        <p:txBody>
-          <a:bodyPr rtlCol="0" anchor="ctr"/>
-          <a:lstStyle/>
-          <a:p>
-            <a:pPr algn="ctr"/>
-            <a:r>
-              <a:rPr sz="1600" b="1">
-                <a:solidFill>
-                  <a:srgbClr val="FFFFFF"/>
-                </a:solidFill>
-                <a:latin typeface="Calibri"/>
-              </a:rPr>
-              <a:t>D</a:t>
-            </a:r>
-          </a:p>
-        </p:txBody>
-      </p:sp>
-      <p:sp>
-        <p:nvSpPr>
-          <p:cNvPr id="21" name="TextBox 20"/>
-          <p:cNvSpPr txBox="1"/>
-          <p:nvPr/>
-        </p:nvSpPr>
-        <p:spPr>
-          <a:xfrm>
-            <a:off x="7040879" y="4206240"/>
-            <a:ext cx="4389120" cy="777240"/>
-          </a:xfrm>
-          <a:prstGeom prst="rect">
-            <a:avLst/>
-          </a:prstGeom>
-          <a:noFill/>
-        </p:spPr>
-        <p:txBody>
-          <a:bodyPr wrap="square" anchor="ctr">
-            <a:spAutoFit/>
-          </a:bodyPr>
-          <a:lstStyle/>
-          <a:p>
-            <a:pPr algn="l"/>
-            <a:r>
-              <a:rPr sz="1400" b="0" i="0">
-                <a:solidFill>
-                  <a:srgbClr val="1A3A5C"/>
-                </a:solidFill>
-                <a:latin typeface="Calibri"/>
-              </a:rPr>
-              <a:t>Faire une glissade pour perdre la hauteur en excès et poser normalement</a:t>
-            </a:r>
-          </a:p>
-        </p:txBody>
-      </p:sp>
-      <p:sp>
-        <p:nvSpPr>
-          <p:cNvPr id="22" name="TextBox 21"/>
-          <p:cNvSpPr txBox="1"/>
-          <p:nvPr/>
-        </p:nvSpPr>
-        <p:spPr>
-          <a:xfrm>
-            <a:off x="640080" y="5349240"/>
-            <a:ext cx="10058400" cy="822960"/>
+            <a:off x="548640" y="1188720"/>
+            <a:ext cx="10881360" cy="5120640"/>
           </a:xfrm>
           <a:prstGeom prst="rect">
             <a:avLst/>
@@ -11028,15 +10948,147 @@
           </a:bodyPr>
           <a:lstStyle/>
           <a:p>
-            <a:pPr algn="l"/>
-            <a:r>
-              <a:rPr sz="1200" b="0" i="1">
-                <a:solidFill>
-                  <a:srgbClr val="6B7A8C"/>
+            <a:pPr>
+              <a:spcAft>
+                <a:spcPts val="900"/>
+              </a:spcAft>
+            </a:pPr>
+            <a:r>
+              <a:rPr sz="2000" b="1">
+                <a:solidFill>
+                  <a:srgbClr val="1A3A5C"/>
                 </a:solidFill>
                 <a:latin typeface="Calibri"/>
               </a:rPr>
-              <a:t>Correction : deux paramètres hors tolérance à la porte de décision. Rattraper en finale courte, c'est exactement le scénario des trois cas BEA. La réponse B est la seule qui restaure les marges.</a:t>
+              <a:t>▸  Nos pistes : longueur, revêtement, pente, repère de remise de gaz</a:t>
+            </a:r>
+          </a:p>
+          <a:p>
+            <a:pPr>
+              <a:spcAft>
+                <a:spcPts val="900"/>
+              </a:spcAft>
+            </a:pPr>
+            <a:r>
+              <a:rPr sz="1500">
+                <a:solidFill>
+                  <a:srgbClr val="5A6A7E"/>
+                </a:solidFill>
+                <a:latin typeface="Calibri Light"/>
+              </a:rPr>
+              <a:t>       [À compléter : pour chaque QFU, un repère visible depuis le cockpit avant lequel les roues doivent être au sol.]</a:t>
+            </a:r>
+          </a:p>
+          <a:p>
+            <a:pPr>
+              <a:spcAft>
+                <a:spcPts val="900"/>
+              </a:spcAft>
+            </a:pPr>
+            <a:r>
+              <a:rPr sz="2000" b="1">
+                <a:solidFill>
+                  <a:srgbClr val="1A3A5C"/>
+                </a:solidFill>
+                <a:latin typeface="Calibri"/>
+              </a:rPr>
+              <a:t>▸  Nos terrains de navigation habituels de moins de 800 m</a:t>
+            </a:r>
+          </a:p>
+          <a:p>
+            <a:pPr>
+              <a:spcAft>
+                <a:spcPts val="900"/>
+              </a:spcAft>
+            </a:pPr>
+            <a:r>
+              <a:rPr sz="1500">
+                <a:solidFill>
+                  <a:srgbClr val="5A6A7E"/>
+                </a:solidFill>
+                <a:latin typeface="Calibri Light"/>
+              </a:rPr>
+              <a:t>       [À compléter : liste des terrains courts fréquentés par le club, avec leurs particularités VAC.]</a:t>
+            </a:r>
+          </a:p>
+          <a:p>
+            <a:pPr>
+              <a:spcAft>
+                <a:spcPts val="900"/>
+              </a:spcAft>
+            </a:pPr>
+            <a:r>
+              <a:rPr sz="2000" b="1">
+                <a:solidFill>
+                  <a:srgbClr val="1A3A5C"/>
+                </a:solidFill>
+                <a:latin typeface="Calibri"/>
+              </a:rPr>
+              <a:t>▸  Exercice au tableau : distance d'atterrissage majorée</a:t>
+            </a:r>
+          </a:p>
+          <a:p>
+            <a:pPr>
+              <a:spcAft>
+                <a:spcPts val="900"/>
+              </a:spcAft>
+            </a:pPr>
+            <a:r>
+              <a:rPr sz="1500">
+                <a:solidFill>
+                  <a:srgbClr val="5A6A7E"/>
+                </a:solidFill>
+                <a:latin typeface="Calibri Light"/>
+              </a:rPr>
+              <a:t>       Distance manuel (piste dure, sèche, vent nul) × herbe × mouillée × vent arrière × marge personnelle = ?</a:t>
+            </a:r>
+          </a:p>
+          <a:p>
+            <a:pPr>
+              <a:spcAft>
+                <a:spcPts val="900"/>
+              </a:spcAft>
+            </a:pPr>
+            <a:r>
+              <a:rPr sz="1500">
+                <a:solidFill>
+                  <a:srgbClr val="5A6A7E"/>
+                </a:solidFill>
+                <a:latin typeface="Calibri Light"/>
+              </a:rPr>
+              <a:t>       Comparer le résultat à la longueur de piste. Si l'écart est faible, le terrain est hors limites ce jour-là.</a:t>
+            </a:r>
+          </a:p>
+          <a:p>
+            <a:pPr>
+              <a:spcAft>
+                <a:spcPts val="900"/>
+              </a:spcAft>
+            </a:pPr>
+            <a:r>
+              <a:rPr sz="2000" b="1">
+                <a:solidFill>
+                  <a:srgbClr val="1A3A5C"/>
+                </a:solidFill>
+                <a:latin typeface="Calibri"/>
+              </a:rPr>
+              <a:t>▸  Engagement de séance</a:t>
+            </a:r>
+          </a:p>
+          <a:p>
+            <a:pPr>
+              <a:spcAft>
+                <a:spcPts val="900"/>
+              </a:spcAft>
+            </a:pPr>
+            <a:r>
+              <a:rPr sz="1500">
+                <a:solidFill>
+                  <a:srgbClr val="5A6A7E"/>
+                </a:solidFill>
+                <a:latin typeface="Calibri Light"/>
+              </a:rPr>
+              <a:t>       Chacun repart avec une valeur de distance pour son avion habituel et un repère de remise de gaz sur notre piste principale.</a:t>
             </a:r>
           </a:p>
         </p:txBody>
@@ -11859,7 +11911,7 @@
                 </a:solidFill>
                 <a:latin typeface="Calibri Light"/>
               </a:rPr>
-              <a:t>Pour le débat</a:t>
+              <a:t>Question de révision</a:t>
             </a:r>
           </a:p>
         </p:txBody>
@@ -12004,14 +12056,595 @@
       </p:sp>
       <p:sp>
         <p:nvSpPr>
-          <p:cNvPr id="9" name="TextBox 8"/>
+          <p:cNvPr id="9" name="Rectangle 8"/>
+          <p:cNvSpPr/>
+          <p:nvPr/>
+        </p:nvSpPr>
+        <p:spPr>
+          <a:xfrm>
+            <a:off x="640080" y="1325880"/>
+            <a:ext cx="10881360" cy="1005840"/>
+          </a:xfrm>
+          <a:prstGeom prst="rect">
+            <a:avLst/>
+          </a:prstGeom>
+          <a:solidFill>
+            <a:srgbClr val="D2EBF8"/>
+          </a:solidFill>
+          <a:ln>
+            <a:noFill/>
+          </a:ln>
+          <a:effectLst/>
+        </p:spPr>
+        <p:style>
+          <a:lnRef idx="1">
+            <a:schemeClr val="accent1"/>
+          </a:lnRef>
+          <a:fillRef idx="3">
+            <a:schemeClr val="accent1"/>
+          </a:fillRef>
+          <a:effectRef idx="2">
+            <a:schemeClr val="accent1"/>
+          </a:effectRef>
+          <a:fontRef idx="minor">
+            <a:schemeClr val="lt1"/>
+          </a:fontRef>
+        </p:style>
+        <p:txBody>
+          <a:bodyPr rtlCol="0" anchor="ctr" wrap="square" lIns="228600"/>
+          <a:lstStyle/>
+          <a:p>
+            <a:pPr algn="ctr"/>
+            <a:r>
+              <a:rPr sz="1800" b="1">
+                <a:solidFill>
+                  <a:srgbClr val="1A3A5C"/>
+                </a:solidFill>
+                <a:latin typeface="Calibri"/>
+              </a:rPr>
+              <a:t>Finale sur une piste en herbe de 750 m. À 300 ft sol, vous êtes à Vref + 15 kt et légèrement au-dessus du plan. Que faites-vous ?</a:t>
+            </a:r>
+          </a:p>
+        </p:txBody>
+      </p:sp>
+      <p:sp>
+        <p:nvSpPr>
+          <p:cNvPr id="10" name="Rectangle 9"/>
+          <p:cNvSpPr/>
+          <p:nvPr/>
+        </p:nvSpPr>
+        <p:spPr>
+          <a:xfrm>
+            <a:off x="640080" y="2697480"/>
+            <a:ext cx="5257800" cy="1051560"/>
+          </a:xfrm>
+          <a:prstGeom prst="rect">
+            <a:avLst/>
+          </a:prstGeom>
+          <a:solidFill>
+            <a:srgbClr val="F5F7FA"/>
+          </a:solidFill>
+          <a:ln>
+            <a:noFill/>
+          </a:ln>
+          <a:effectLst/>
+        </p:spPr>
+        <p:style>
+          <a:lnRef idx="1">
+            <a:schemeClr val="accent1"/>
+          </a:lnRef>
+          <a:fillRef idx="3">
+            <a:schemeClr val="accent1"/>
+          </a:fillRef>
+          <a:effectRef idx="2">
+            <a:schemeClr val="accent1"/>
+          </a:effectRef>
+          <a:fontRef idx="minor">
+            <a:schemeClr val="lt1"/>
+          </a:fontRef>
+        </p:style>
+        <p:txBody>
+          <a:bodyPr rtlCol="0" anchor="ctr"/>
+          <a:lstStyle/>
+          <a:p>
+            <a:pPr algn="ctr"/>
+          </a:p>
+        </p:txBody>
+      </p:sp>
+      <p:sp>
+        <p:nvSpPr>
+          <p:cNvPr id="11" name="Oval 10"/>
+          <p:cNvSpPr/>
+          <p:nvPr/>
+        </p:nvSpPr>
+        <p:spPr>
+          <a:xfrm>
+            <a:off x="804671" y="2990088"/>
+            <a:ext cx="457200" cy="457200"/>
+          </a:xfrm>
+          <a:prstGeom prst="ellipse">
+            <a:avLst/>
+          </a:prstGeom>
+          <a:solidFill>
+            <a:srgbClr val="1A3A5C"/>
+          </a:solidFill>
+          <a:ln>
+            <a:noFill/>
+          </a:ln>
+          <a:effectLst/>
+        </p:spPr>
+        <p:style>
+          <a:lnRef idx="1">
+            <a:schemeClr val="accent1"/>
+          </a:lnRef>
+          <a:fillRef idx="3">
+            <a:schemeClr val="accent1"/>
+          </a:fillRef>
+          <a:effectRef idx="2">
+            <a:schemeClr val="accent1"/>
+          </a:effectRef>
+          <a:fontRef idx="minor">
+            <a:schemeClr val="lt1"/>
+          </a:fontRef>
+        </p:style>
+        <p:txBody>
+          <a:bodyPr rtlCol="0" anchor="ctr"/>
+          <a:lstStyle/>
+          <a:p>
+            <a:pPr algn="ctr"/>
+            <a:r>
+              <a:rPr sz="1600" b="1">
+                <a:solidFill>
+                  <a:srgbClr val="FFFFFF"/>
+                </a:solidFill>
+                <a:latin typeface="Calibri"/>
+              </a:rPr>
+              <a:t>A</a:t>
+            </a:r>
+          </a:p>
+        </p:txBody>
+      </p:sp>
+      <p:sp>
+        <p:nvSpPr>
+          <p:cNvPr id="12" name="TextBox 11"/>
           <p:cNvSpPr txBox="1"/>
           <p:nvPr/>
         </p:nvSpPr>
         <p:spPr>
           <a:xfrm>
-            <a:off x="548640" y="1280160"/>
-            <a:ext cx="10881360" cy="4937760"/>
+            <a:off x="1417319" y="2834640"/>
+            <a:ext cx="4389120" cy="777240"/>
+          </a:xfrm>
+          <a:prstGeom prst="rect">
+            <a:avLst/>
+          </a:prstGeom>
+          <a:noFill/>
+        </p:spPr>
+        <p:txBody>
+          <a:bodyPr wrap="square" anchor="ctr">
+            <a:spAutoFit/>
+          </a:bodyPr>
+          <a:lstStyle/>
+          <a:p>
+            <a:pPr algn="l"/>
+            <a:r>
+              <a:rPr sz="1400" b="0" i="0">
+                <a:solidFill>
+                  <a:srgbClr val="1A3A5C"/>
+                </a:solidFill>
+                <a:latin typeface="Calibri"/>
+              </a:rPr>
+              <a:t>Réduire les gaz, sortir le dernier cran de volets et rattraper le plan avant l'arrondi</a:t>
+            </a:r>
+          </a:p>
+        </p:txBody>
+      </p:sp>
+      <p:sp>
+        <p:nvSpPr>
+          <p:cNvPr id="13" name="Rectangle 12"/>
+          <p:cNvSpPr/>
+          <p:nvPr/>
+        </p:nvSpPr>
+        <p:spPr>
+          <a:xfrm>
+            <a:off x="6263640" y="2697480"/>
+            <a:ext cx="5257800" cy="1051560"/>
+          </a:xfrm>
+          <a:prstGeom prst="rect">
+            <a:avLst/>
+          </a:prstGeom>
+          <a:solidFill>
+            <a:srgbClr val="E3F1E8"/>
+          </a:solidFill>
+          <a:ln>
+            <a:noFill/>
+          </a:ln>
+          <a:effectLst/>
+        </p:spPr>
+        <p:style>
+          <a:lnRef idx="1">
+            <a:schemeClr val="accent1"/>
+          </a:lnRef>
+          <a:fillRef idx="3">
+            <a:schemeClr val="accent1"/>
+          </a:fillRef>
+          <a:effectRef idx="2">
+            <a:schemeClr val="accent1"/>
+          </a:effectRef>
+          <a:fontRef idx="minor">
+            <a:schemeClr val="lt1"/>
+          </a:fontRef>
+        </p:style>
+        <p:txBody>
+          <a:bodyPr rtlCol="0" anchor="ctr"/>
+          <a:lstStyle/>
+          <a:p>
+            <a:pPr algn="ctr"/>
+          </a:p>
+        </p:txBody>
+      </p:sp>
+      <p:sp>
+        <p:nvSpPr>
+          <p:cNvPr id="14" name="Oval 13"/>
+          <p:cNvSpPr/>
+          <p:nvPr/>
+        </p:nvSpPr>
+        <p:spPr>
+          <a:xfrm>
+            <a:off x="6428231" y="2990088"/>
+            <a:ext cx="457200" cy="457200"/>
+          </a:xfrm>
+          <a:prstGeom prst="ellipse">
+            <a:avLst/>
+          </a:prstGeom>
+          <a:solidFill>
+            <a:srgbClr val="2E7D4F"/>
+          </a:solidFill>
+          <a:ln>
+            <a:noFill/>
+          </a:ln>
+          <a:effectLst/>
+        </p:spPr>
+        <p:style>
+          <a:lnRef idx="1">
+            <a:schemeClr val="accent1"/>
+          </a:lnRef>
+          <a:fillRef idx="3">
+            <a:schemeClr val="accent1"/>
+          </a:fillRef>
+          <a:effectRef idx="2">
+            <a:schemeClr val="accent1"/>
+          </a:effectRef>
+          <a:fontRef idx="minor">
+            <a:schemeClr val="lt1"/>
+          </a:fontRef>
+        </p:style>
+        <p:txBody>
+          <a:bodyPr rtlCol="0" anchor="ctr"/>
+          <a:lstStyle/>
+          <a:p>
+            <a:pPr algn="ctr"/>
+            <a:r>
+              <a:rPr sz="1600" b="1">
+                <a:solidFill>
+                  <a:srgbClr val="FFFFFF"/>
+                </a:solidFill>
+                <a:latin typeface="Calibri"/>
+              </a:rPr>
+              <a:t>B</a:t>
+            </a:r>
+          </a:p>
+        </p:txBody>
+      </p:sp>
+      <p:sp>
+        <p:nvSpPr>
+          <p:cNvPr id="15" name="TextBox 14"/>
+          <p:cNvSpPr txBox="1"/>
+          <p:nvPr/>
+        </p:nvSpPr>
+        <p:spPr>
+          <a:xfrm>
+            <a:off x="7040879" y="2834640"/>
+            <a:ext cx="4389120" cy="777240"/>
+          </a:xfrm>
+          <a:prstGeom prst="rect">
+            <a:avLst/>
+          </a:prstGeom>
+          <a:noFill/>
+        </p:spPr>
+        <p:txBody>
+          <a:bodyPr wrap="square" anchor="ctr">
+            <a:spAutoFit/>
+          </a:bodyPr>
+          <a:lstStyle/>
+          <a:p>
+            <a:pPr algn="l"/>
+            <a:r>
+              <a:rPr sz="1400" b="1" i="0">
+                <a:solidFill>
+                  <a:srgbClr val="2E7D4F"/>
+                </a:solidFill>
+                <a:latin typeface="Calibri"/>
+              </a:rPr>
+              <a:t>Remettre les gaz maintenant, refaire un tour de piste complet et une finale stabilisée</a:t>
+            </a:r>
+          </a:p>
+        </p:txBody>
+      </p:sp>
+      <p:sp>
+        <p:nvSpPr>
+          <p:cNvPr id="16" name="Rectangle 15"/>
+          <p:cNvSpPr/>
+          <p:nvPr/>
+        </p:nvSpPr>
+        <p:spPr>
+          <a:xfrm>
+            <a:off x="640080" y="4069080"/>
+            <a:ext cx="5257800" cy="1051560"/>
+          </a:xfrm>
+          <a:prstGeom prst="rect">
+            <a:avLst/>
+          </a:prstGeom>
+          <a:solidFill>
+            <a:srgbClr val="F5F7FA"/>
+          </a:solidFill>
+          <a:ln>
+            <a:noFill/>
+          </a:ln>
+          <a:effectLst/>
+        </p:spPr>
+        <p:style>
+          <a:lnRef idx="1">
+            <a:schemeClr val="accent1"/>
+          </a:lnRef>
+          <a:fillRef idx="3">
+            <a:schemeClr val="accent1"/>
+          </a:fillRef>
+          <a:effectRef idx="2">
+            <a:schemeClr val="accent1"/>
+          </a:effectRef>
+          <a:fontRef idx="minor">
+            <a:schemeClr val="lt1"/>
+          </a:fontRef>
+        </p:style>
+        <p:txBody>
+          <a:bodyPr rtlCol="0" anchor="ctr"/>
+          <a:lstStyle/>
+          <a:p>
+            <a:pPr algn="ctr"/>
+          </a:p>
+        </p:txBody>
+      </p:sp>
+      <p:sp>
+        <p:nvSpPr>
+          <p:cNvPr id="17" name="Oval 16"/>
+          <p:cNvSpPr/>
+          <p:nvPr/>
+        </p:nvSpPr>
+        <p:spPr>
+          <a:xfrm>
+            <a:off x="804671" y="4361688"/>
+            <a:ext cx="457200" cy="457200"/>
+          </a:xfrm>
+          <a:prstGeom prst="ellipse">
+            <a:avLst/>
+          </a:prstGeom>
+          <a:solidFill>
+            <a:srgbClr val="1A3A5C"/>
+          </a:solidFill>
+          <a:ln>
+            <a:noFill/>
+          </a:ln>
+          <a:effectLst/>
+        </p:spPr>
+        <p:style>
+          <a:lnRef idx="1">
+            <a:schemeClr val="accent1"/>
+          </a:lnRef>
+          <a:fillRef idx="3">
+            <a:schemeClr val="accent1"/>
+          </a:fillRef>
+          <a:effectRef idx="2">
+            <a:schemeClr val="accent1"/>
+          </a:effectRef>
+          <a:fontRef idx="minor">
+            <a:schemeClr val="lt1"/>
+          </a:fontRef>
+        </p:style>
+        <p:txBody>
+          <a:bodyPr rtlCol="0" anchor="ctr"/>
+          <a:lstStyle/>
+          <a:p>
+            <a:pPr algn="ctr"/>
+            <a:r>
+              <a:rPr sz="1600" b="1">
+                <a:solidFill>
+                  <a:srgbClr val="FFFFFF"/>
+                </a:solidFill>
+                <a:latin typeface="Calibri"/>
+              </a:rPr>
+              <a:t>C</a:t>
+            </a:r>
+          </a:p>
+        </p:txBody>
+      </p:sp>
+      <p:sp>
+        <p:nvSpPr>
+          <p:cNvPr id="18" name="TextBox 17"/>
+          <p:cNvSpPr txBox="1"/>
+          <p:nvPr/>
+        </p:nvSpPr>
+        <p:spPr>
+          <a:xfrm>
+            <a:off x="1417319" y="4206240"/>
+            <a:ext cx="4389120" cy="777240"/>
+          </a:xfrm>
+          <a:prstGeom prst="rect">
+            <a:avLst/>
+          </a:prstGeom>
+          <a:noFill/>
+        </p:spPr>
+        <p:txBody>
+          <a:bodyPr wrap="square" anchor="ctr">
+            <a:spAutoFit/>
+          </a:bodyPr>
+          <a:lstStyle/>
+          <a:p>
+            <a:pPr algn="l"/>
+            <a:r>
+              <a:rPr sz="1400" b="0" i="0">
+                <a:solidFill>
+                  <a:srgbClr val="1A3A5C"/>
+                </a:solidFill>
+                <a:latin typeface="Calibri"/>
+              </a:rPr>
+              <a:t>Continuer, poser dans le premier tiers et freiner énergiquement</a:t>
+            </a:r>
+          </a:p>
+        </p:txBody>
+      </p:sp>
+      <p:sp>
+        <p:nvSpPr>
+          <p:cNvPr id="19" name="Rectangle 18"/>
+          <p:cNvSpPr/>
+          <p:nvPr/>
+        </p:nvSpPr>
+        <p:spPr>
+          <a:xfrm>
+            <a:off x="6263640" y="4069080"/>
+            <a:ext cx="5257800" cy="1051560"/>
+          </a:xfrm>
+          <a:prstGeom prst="rect">
+            <a:avLst/>
+          </a:prstGeom>
+          <a:solidFill>
+            <a:srgbClr val="F5F7FA"/>
+          </a:solidFill>
+          <a:ln>
+            <a:noFill/>
+          </a:ln>
+          <a:effectLst/>
+        </p:spPr>
+        <p:style>
+          <a:lnRef idx="1">
+            <a:schemeClr val="accent1"/>
+          </a:lnRef>
+          <a:fillRef idx="3">
+            <a:schemeClr val="accent1"/>
+          </a:fillRef>
+          <a:effectRef idx="2">
+            <a:schemeClr val="accent1"/>
+          </a:effectRef>
+          <a:fontRef idx="minor">
+            <a:schemeClr val="lt1"/>
+          </a:fontRef>
+        </p:style>
+        <p:txBody>
+          <a:bodyPr rtlCol="0" anchor="ctr"/>
+          <a:lstStyle/>
+          <a:p>
+            <a:pPr algn="ctr"/>
+          </a:p>
+        </p:txBody>
+      </p:sp>
+      <p:sp>
+        <p:nvSpPr>
+          <p:cNvPr id="20" name="Oval 19"/>
+          <p:cNvSpPr/>
+          <p:nvPr/>
+        </p:nvSpPr>
+        <p:spPr>
+          <a:xfrm>
+            <a:off x="6428231" y="4361688"/>
+            <a:ext cx="457200" cy="457200"/>
+          </a:xfrm>
+          <a:prstGeom prst="ellipse">
+            <a:avLst/>
+          </a:prstGeom>
+          <a:solidFill>
+            <a:srgbClr val="1A3A5C"/>
+          </a:solidFill>
+          <a:ln>
+            <a:noFill/>
+          </a:ln>
+          <a:effectLst/>
+        </p:spPr>
+        <p:style>
+          <a:lnRef idx="1">
+            <a:schemeClr val="accent1"/>
+          </a:lnRef>
+          <a:fillRef idx="3">
+            <a:schemeClr val="accent1"/>
+          </a:fillRef>
+          <a:effectRef idx="2">
+            <a:schemeClr val="accent1"/>
+          </a:effectRef>
+          <a:fontRef idx="minor">
+            <a:schemeClr val="lt1"/>
+          </a:fontRef>
+        </p:style>
+        <p:txBody>
+          <a:bodyPr rtlCol="0" anchor="ctr"/>
+          <a:lstStyle/>
+          <a:p>
+            <a:pPr algn="ctr"/>
+            <a:r>
+              <a:rPr sz="1600" b="1">
+                <a:solidFill>
+                  <a:srgbClr val="FFFFFF"/>
+                </a:solidFill>
+                <a:latin typeface="Calibri"/>
+              </a:rPr>
+              <a:t>D</a:t>
+            </a:r>
+          </a:p>
+        </p:txBody>
+      </p:sp>
+      <p:sp>
+        <p:nvSpPr>
+          <p:cNvPr id="21" name="TextBox 20"/>
+          <p:cNvSpPr txBox="1"/>
+          <p:nvPr/>
+        </p:nvSpPr>
+        <p:spPr>
+          <a:xfrm>
+            <a:off x="7040879" y="4206240"/>
+            <a:ext cx="4389120" cy="777240"/>
+          </a:xfrm>
+          <a:prstGeom prst="rect">
+            <a:avLst/>
+          </a:prstGeom>
+          <a:noFill/>
+        </p:spPr>
+        <p:txBody>
+          <a:bodyPr wrap="square" anchor="ctr">
+            <a:spAutoFit/>
+          </a:bodyPr>
+          <a:lstStyle/>
+          <a:p>
+            <a:pPr algn="l"/>
+            <a:r>
+              <a:rPr sz="1400" b="0" i="0">
+                <a:solidFill>
+                  <a:srgbClr val="1A3A5C"/>
+                </a:solidFill>
+                <a:latin typeface="Calibri"/>
+              </a:rPr>
+              <a:t>Faire une glissade pour perdre la hauteur en excès et poser normalement</a:t>
+            </a:r>
+          </a:p>
+        </p:txBody>
+      </p:sp>
+      <p:sp>
+        <p:nvSpPr>
+          <p:cNvPr id="22" name="TextBox 21"/>
+          <p:cNvSpPr txBox="1"/>
+          <p:nvPr/>
+        </p:nvSpPr>
+        <p:spPr>
+          <a:xfrm>
+            <a:off x="640080" y="5349240"/>
+            <a:ext cx="10058400" cy="822960"/>
           </a:xfrm>
           <a:prstGeom prst="rect">
             <a:avLst/>
@@ -12024,99 +12657,15 @@
           </a:bodyPr>
           <a:lstStyle/>
           <a:p>
-            <a:pPr>
-              <a:spcAft>
-                <a:spcPts val="1800"/>
-              </a:spcAft>
-            </a:pPr>
-            <a:r>
-              <a:rPr sz="2200" b="1">
-                <a:solidFill>
-                  <a:srgbClr val="1A3A5C"/>
+            <a:pPr algn="l"/>
+            <a:r>
+              <a:rPr sz="1200" b="0" i="1">
+                <a:solidFill>
+                  <a:srgbClr val="6B7A8C"/>
                 </a:solidFill>
                 <a:latin typeface="Calibri"/>
               </a:rPr>
-              <a:t>▸  Qui a déjà continué un atterrissage qu'il aurait dû abandonner ? Pourquoi ?</a:t>
-            </a:r>
-          </a:p>
-          <a:p>
-            <a:pPr>
-              <a:spcAft>
-                <a:spcPts val="1800"/>
-              </a:spcAft>
-            </a:pPr>
-            <a:r>
-              <a:rPr sz="1600">
-                <a:solidFill>
-                  <a:srgbClr val="5A6A7E"/>
-                </a:solidFill>
-                <a:latin typeface="Calibri Light"/>
-              </a:rPr>
-              <a:t>       Sans jugement : la fatigue, l'orgueil, la présence d'un passager, le « ça va passer » sont des facteurs partagés par tous.</a:t>
-            </a:r>
-          </a:p>
-          <a:p>
-            <a:pPr>
-              <a:spcAft>
-                <a:spcPts val="1800"/>
-              </a:spcAft>
-            </a:pPr>
-            <a:r>
-              <a:rPr sz="2200" b="1">
-                <a:solidFill>
-                  <a:srgbClr val="1A3A5C"/>
-                </a:solidFill>
-                <a:latin typeface="Calibri"/>
-              </a:rPr>
-              <a:t>▸  Que se passe-t-il au club après une remise de gaz ?</a:t>
-            </a:r>
-          </a:p>
-          <a:p>
-            <a:pPr>
-              <a:spcAft>
-                <a:spcPts val="1800"/>
-              </a:spcAft>
-            </a:pPr>
-            <a:r>
-              <a:rPr sz="1600">
-                <a:solidFill>
-                  <a:srgbClr val="5A6A7E"/>
-                </a:solidFill>
-                <a:latin typeface="Calibri Light"/>
-              </a:rPr>
-              <a:t>       Est-elle vue comme un échec ou comme une bonne décision ? La culture du club influence la décision en finale.</a:t>
-            </a:r>
-          </a:p>
-          <a:p>
-            <a:pPr>
-              <a:spcAft>
-                <a:spcPts val="1800"/>
-              </a:spcAft>
-            </a:pPr>
-            <a:r>
-              <a:rPr sz="2200" b="1">
-                <a:solidFill>
-                  <a:srgbClr val="1A3A5C"/>
-                </a:solidFill>
-                <a:latin typeface="Calibri"/>
-              </a:rPr>
-              <a:t>▸  Quels terrains de nos navigations méritent une préparation particulière ?</a:t>
-            </a:r>
-          </a:p>
-          <a:p>
-            <a:pPr>
-              <a:spcAft>
-                <a:spcPts val="1800"/>
-              </a:spcAft>
-            </a:pPr>
-            <a:r>
-              <a:rPr sz="1600">
-                <a:solidFill>
-                  <a:srgbClr val="5A6A7E"/>
-                </a:solidFill>
-                <a:latin typeface="Calibri Light"/>
-              </a:rPr>
-              <a:t>       Pente, bosse, relief, QFU imposé, herbe : les repérer maintenant, pas au moment de s'y poser.</a:t>
+              <a:t>Correction : deux paramètres hors tolérance à la porte de décision. Rattraper en finale courte, c'est exactement le scénario des trois cas BEA. La réponse B est la seule qui restaure les marges.</a:t>
             </a:r>
           </a:p>
         </p:txBody>
@@ -12130,6 +12679,412 @@
 </file>
 
 <file path=ppt/slides/slide21.xml><?xml version="1.0" encoding="utf-8"?>
+<p:sld xmlns:a="http://schemas.openxmlformats.org/drawingml/2006/main" xmlns:p="http://schemas.openxmlformats.org/presentationml/2006/main" xmlns:r="http://schemas.openxmlformats.org/officeDocument/2006/relationships">
+  <p:cSld>
+    <p:bg>
+      <p:bgPr>
+        <a:solidFill>
+          <a:srgbClr val="FFFFFF"/>
+        </a:solidFill>
+        <a:effectLst/>
+      </p:bgPr>
+    </p:bg>
+    <p:spTree>
+      <p:nvGrpSpPr>
+        <p:cNvPr id="1" name=""/>
+        <p:cNvGrpSpPr/>
+        <p:nvPr/>
+      </p:nvGrpSpPr>
+      <p:grpSpPr/>
+      <p:sp>
+        <p:nvSpPr>
+          <p:cNvPr id="2" name="Rectangle 1"/>
+          <p:cNvSpPr/>
+          <p:nvPr/>
+        </p:nvSpPr>
+        <p:spPr>
+          <a:xfrm>
+            <a:off x="0" y="0"/>
+            <a:ext cx="12188952" cy="960120"/>
+          </a:xfrm>
+          <a:prstGeom prst="rect">
+            <a:avLst/>
+          </a:prstGeom>
+          <a:solidFill>
+            <a:srgbClr val="1A3A5C"/>
+          </a:solidFill>
+          <a:ln>
+            <a:noFill/>
+          </a:ln>
+          <a:effectLst/>
+        </p:spPr>
+        <p:style>
+          <a:lnRef idx="1">
+            <a:schemeClr val="accent1"/>
+          </a:lnRef>
+          <a:fillRef idx="3">
+            <a:schemeClr val="accent1"/>
+          </a:fillRef>
+          <a:effectRef idx="2">
+            <a:schemeClr val="accent1"/>
+          </a:effectRef>
+          <a:fontRef idx="minor">
+            <a:schemeClr val="lt1"/>
+          </a:fontRef>
+        </p:style>
+        <p:txBody>
+          <a:bodyPr rtlCol="0" anchor="ctr"/>
+          <a:lstStyle/>
+          <a:p>
+            <a:pPr algn="ctr"/>
+          </a:p>
+        </p:txBody>
+      </p:sp>
+      <p:sp>
+        <p:nvSpPr>
+          <p:cNvPr id="3" name="Rectangle 2"/>
+          <p:cNvSpPr/>
+          <p:nvPr/>
+        </p:nvSpPr>
+        <p:spPr>
+          <a:xfrm>
+            <a:off x="0" y="960120"/>
+            <a:ext cx="12188952" cy="54864"/>
+          </a:xfrm>
+          <a:prstGeom prst="rect">
+            <a:avLst/>
+          </a:prstGeom>
+          <a:solidFill>
+            <a:srgbClr val="4A9ED6"/>
+          </a:solidFill>
+          <a:ln>
+            <a:noFill/>
+          </a:ln>
+          <a:effectLst/>
+        </p:spPr>
+        <p:style>
+          <a:lnRef idx="1">
+            <a:schemeClr val="accent1"/>
+          </a:lnRef>
+          <a:fillRef idx="3">
+            <a:schemeClr val="accent1"/>
+          </a:fillRef>
+          <a:effectRef idx="2">
+            <a:schemeClr val="accent1"/>
+          </a:effectRef>
+          <a:fontRef idx="minor">
+            <a:schemeClr val="lt1"/>
+          </a:fontRef>
+        </p:style>
+        <p:txBody>
+          <a:bodyPr rtlCol="0" anchor="ctr"/>
+          <a:lstStyle/>
+          <a:p>
+            <a:pPr algn="ctr"/>
+          </a:p>
+        </p:txBody>
+      </p:sp>
+      <p:sp>
+        <p:nvSpPr>
+          <p:cNvPr id="4" name="TextBox 3"/>
+          <p:cNvSpPr txBox="1"/>
+          <p:nvPr/>
+        </p:nvSpPr>
+        <p:spPr>
+          <a:xfrm>
+            <a:off x="457200" y="155448"/>
+            <a:ext cx="11274552" cy="713232"/>
+          </a:xfrm>
+          <a:prstGeom prst="rect">
+            <a:avLst/>
+          </a:prstGeom>
+          <a:noFill/>
+        </p:spPr>
+        <p:txBody>
+          <a:bodyPr wrap="square" anchor="ctr">
+            <a:spAutoFit/>
+          </a:bodyPr>
+          <a:lstStyle/>
+          <a:p>
+            <a:pPr algn="l"/>
+            <a:r>
+              <a:rPr sz="2800" b="1" i="0">
+                <a:solidFill>
+                  <a:srgbClr val="FFFFFF"/>
+                </a:solidFill>
+                <a:latin typeface="Calibri Light"/>
+              </a:rPr>
+              <a:t>Pour le débat</a:t>
+            </a:r>
+          </a:p>
+        </p:txBody>
+      </p:sp>
+      <p:sp>
+        <p:nvSpPr>
+          <p:cNvPr id="5" name="Rectangle 4"/>
+          <p:cNvSpPr/>
+          <p:nvPr/>
+        </p:nvSpPr>
+        <p:spPr>
+          <a:xfrm>
+            <a:off x="0" y="6510528"/>
+            <a:ext cx="12188952" cy="347472"/>
+          </a:xfrm>
+          <a:prstGeom prst="rect">
+            <a:avLst/>
+          </a:prstGeom>
+          <a:solidFill>
+            <a:srgbClr val="1A3A5C"/>
+          </a:solidFill>
+          <a:ln>
+            <a:noFill/>
+          </a:ln>
+          <a:effectLst/>
+        </p:spPr>
+        <p:style>
+          <a:lnRef idx="1">
+            <a:schemeClr val="accent1"/>
+          </a:lnRef>
+          <a:fillRef idx="3">
+            <a:schemeClr val="accent1"/>
+          </a:fillRef>
+          <a:effectRef idx="2">
+            <a:schemeClr val="accent1"/>
+          </a:effectRef>
+          <a:fontRef idx="minor">
+            <a:schemeClr val="lt1"/>
+          </a:fontRef>
+        </p:style>
+        <p:txBody>
+          <a:bodyPr rtlCol="0" anchor="ctr"/>
+          <a:lstStyle/>
+          <a:p>
+            <a:pPr algn="ctr"/>
+          </a:p>
+        </p:txBody>
+      </p:sp>
+      <p:sp>
+        <p:nvSpPr>
+          <p:cNvPr id="6" name="TextBox 5"/>
+          <p:cNvSpPr txBox="1"/>
+          <p:nvPr/>
+        </p:nvSpPr>
+        <p:spPr>
+          <a:xfrm>
+            <a:off x="365760" y="6556248"/>
+            <a:ext cx="8229600" cy="274320"/>
+          </a:xfrm>
+          <a:prstGeom prst="rect">
+            <a:avLst/>
+          </a:prstGeom>
+          <a:noFill/>
+        </p:spPr>
+        <p:txBody>
+          <a:bodyPr wrap="square">
+            <a:spAutoFit/>
+          </a:bodyPr>
+          <a:lstStyle/>
+          <a:p>
+            <a:pPr algn="l"/>
+            <a:r>
+              <a:rPr sz="900" b="0" i="0">
+                <a:solidFill>
+                  <a:srgbClr val="D2EBF8"/>
+                </a:solidFill>
+                <a:latin typeface="Calibri"/>
+              </a:rPr>
+              <a:t>Formation PPL · LAPL  —  Frédéric Vincenot · FI</a:t>
+            </a:r>
+          </a:p>
+        </p:txBody>
+      </p:sp>
+      <p:pic>
+        <p:nvPicPr>
+          <p:cNvPr id="7" name="Picture 6" descr="tampon_fv_gris.png"/>
+          <p:cNvPicPr>
+            <a:picLocks noChangeAspect="1"/>
+          </p:cNvPicPr>
+          <p:nvPr/>
+        </p:nvPicPr>
+        <p:blipFill>
+          <a:blip r:embed="rId2"/>
+          <a:stretch>
+            <a:fillRect/>
+          </a:stretch>
+        </p:blipFill>
+        <p:spPr>
+          <a:xfrm>
+            <a:off x="11274552" y="6108192"/>
+            <a:ext cx="640080" cy="320040"/>
+          </a:xfrm>
+          <a:prstGeom prst="rect">
+            <a:avLst/>
+          </a:prstGeom>
+        </p:spPr>
+      </p:pic>
+      <p:sp>
+        <p:nvSpPr>
+          <p:cNvPr id="8" name="TextBox 7"/>
+          <p:cNvSpPr txBox="1"/>
+          <p:nvPr/>
+        </p:nvSpPr>
+        <p:spPr>
+          <a:xfrm>
+            <a:off x="11686032" y="6556248"/>
+            <a:ext cx="365760" cy="274320"/>
+          </a:xfrm>
+          <a:prstGeom prst="rect">
+            <a:avLst/>
+          </a:prstGeom>
+          <a:noFill/>
+        </p:spPr>
+        <p:txBody>
+          <a:bodyPr wrap="square">
+            <a:spAutoFit/>
+          </a:bodyPr>
+          <a:lstStyle/>
+          <a:p>
+            <a:pPr algn="r"/>
+            <a:r>
+              <a:rPr sz="900" b="0" i="0">
+                <a:solidFill>
+                  <a:srgbClr val="D2EBF8"/>
+                </a:solidFill>
+                <a:latin typeface="Calibri"/>
+              </a:rPr>
+              <a:t>21</a:t>
+            </a:r>
+          </a:p>
+        </p:txBody>
+      </p:sp>
+      <p:sp>
+        <p:nvSpPr>
+          <p:cNvPr id="9" name="TextBox 8"/>
+          <p:cNvSpPr txBox="1"/>
+          <p:nvPr/>
+        </p:nvSpPr>
+        <p:spPr>
+          <a:xfrm>
+            <a:off x="548640" y="1280160"/>
+            <a:ext cx="10881360" cy="4937760"/>
+          </a:xfrm>
+          <a:prstGeom prst="rect">
+            <a:avLst/>
+          </a:prstGeom>
+          <a:noFill/>
+        </p:spPr>
+        <p:txBody>
+          <a:bodyPr wrap="square">
+            <a:spAutoFit/>
+          </a:bodyPr>
+          <a:lstStyle/>
+          <a:p>
+            <a:pPr>
+              <a:spcAft>
+                <a:spcPts val="1800"/>
+              </a:spcAft>
+            </a:pPr>
+            <a:r>
+              <a:rPr sz="2200" b="1">
+                <a:solidFill>
+                  <a:srgbClr val="1A3A5C"/>
+                </a:solidFill>
+                <a:latin typeface="Calibri"/>
+              </a:rPr>
+              <a:t>▸  Qui a déjà continué un atterrissage qu'il aurait dû abandonner ? Pourquoi ?</a:t>
+            </a:r>
+          </a:p>
+          <a:p>
+            <a:pPr>
+              <a:spcAft>
+                <a:spcPts val="1800"/>
+              </a:spcAft>
+            </a:pPr>
+            <a:r>
+              <a:rPr sz="1600">
+                <a:solidFill>
+                  <a:srgbClr val="5A6A7E"/>
+                </a:solidFill>
+                <a:latin typeface="Calibri Light"/>
+              </a:rPr>
+              <a:t>       Sans jugement : la fatigue, l'orgueil, la présence d'un passager, le « ça va passer » sont des facteurs partagés par tous.</a:t>
+            </a:r>
+          </a:p>
+          <a:p>
+            <a:pPr>
+              <a:spcAft>
+                <a:spcPts val="1800"/>
+              </a:spcAft>
+            </a:pPr>
+            <a:r>
+              <a:rPr sz="2200" b="1">
+                <a:solidFill>
+                  <a:srgbClr val="1A3A5C"/>
+                </a:solidFill>
+                <a:latin typeface="Calibri"/>
+              </a:rPr>
+              <a:t>▸  Que se passe-t-il au club après une remise de gaz ?</a:t>
+            </a:r>
+          </a:p>
+          <a:p>
+            <a:pPr>
+              <a:spcAft>
+                <a:spcPts val="1800"/>
+              </a:spcAft>
+            </a:pPr>
+            <a:r>
+              <a:rPr sz="1600">
+                <a:solidFill>
+                  <a:srgbClr val="5A6A7E"/>
+                </a:solidFill>
+                <a:latin typeface="Calibri Light"/>
+              </a:rPr>
+              <a:t>       Est-elle vue comme un échec ou comme une bonne décision ? La culture du club influence la décision en finale.</a:t>
+            </a:r>
+          </a:p>
+          <a:p>
+            <a:pPr>
+              <a:spcAft>
+                <a:spcPts val="1800"/>
+              </a:spcAft>
+            </a:pPr>
+            <a:r>
+              <a:rPr sz="2200" b="1">
+                <a:solidFill>
+                  <a:srgbClr val="1A3A5C"/>
+                </a:solidFill>
+                <a:latin typeface="Calibri"/>
+              </a:rPr>
+              <a:t>▸  Quels terrains de nos navigations méritent une préparation particulière ?</a:t>
+            </a:r>
+          </a:p>
+          <a:p>
+            <a:pPr>
+              <a:spcAft>
+                <a:spcPts val="1800"/>
+              </a:spcAft>
+            </a:pPr>
+            <a:r>
+              <a:rPr sz="1600">
+                <a:solidFill>
+                  <a:srgbClr val="5A6A7E"/>
+                </a:solidFill>
+                <a:latin typeface="Calibri Light"/>
+              </a:rPr>
+              <a:t>       Pente, bosse, relief, QFU imposé, herbe : les repérer maintenant, pas au moment de s'y poser.</a:t>
+            </a:r>
+          </a:p>
+        </p:txBody>
+      </p:sp>
+    </p:spTree>
+  </p:cSld>
+  <p:clrMapOvr>
+    <a:masterClrMapping/>
+  </p:clrMapOvr>
+</p:sld>
+</file>
+
+<file path=ppt/slides/slide22.xml><?xml version="1.0" encoding="utf-8"?>
 <p:sld xmlns:a="http://schemas.openxmlformats.org/drawingml/2006/main" xmlns:p="http://schemas.openxmlformats.org/presentationml/2006/main" xmlns:r="http://schemas.openxmlformats.org/officeDocument/2006/relationships">
   <p:cSld>
     <p:bg>
@@ -12403,7 +13358,7 @@
                 </a:solidFill>
                 <a:latin typeface="Calibri"/>
               </a:rPr>
-              <a:t>21</a:t>
+              <a:t>22</a:t>
             </a:r>
           </a:p>
         </p:txBody>
@@ -12944,7 +13899,7 @@
 </p:sld>
 </file>
 
-<file path=ppt/slides/slide22.xml><?xml version="1.0" encoding="utf-8"?>
+<file path=ppt/slides/slide23.xml><?xml version="1.0" encoding="utf-8"?>
 <p:sld xmlns:a="http://schemas.openxmlformats.org/drawingml/2006/main" xmlns:p="http://schemas.openxmlformats.org/presentationml/2006/main" xmlns:r="http://schemas.openxmlformats.org/officeDocument/2006/relationships">
   <p:cSld>
     <p:bg>
@@ -13218,7 +14173,7 @@
                 </a:solidFill>
                 <a:latin typeface="Calibri"/>
               </a:rPr>
-              <a:t>22</a:t>
+              <a:t>23</a:t>
             </a:r>
           </a:p>
         </p:txBody>
@@ -13347,13 +14302,13 @@
               </a:spcAft>
             </a:pPr>
             <a:r>
-              <a:rPr sz="1700" b="1">
-                <a:solidFill>
-                  <a:srgbClr val="1A3A5C"/>
-                </a:solidFill>
-                <a:latin typeface="Calibri"/>
-              </a:rPr>
-              <a:t>▸  Doctrine</a:t>
+              <a:rPr sz="1300">
+                <a:solidFill>
+                  <a:srgbClr val="5A6A7E"/>
+                </a:solidFill>
+                <a:latin typeface="Calibri Light"/>
+              </a:rPr>
+              <a:t>       Cas cités par aeroVFR sans référence : DR-360 posé à contre-QFU ; atterrissage long sur 685 m d'herbe mouillée</a:t>
             </a:r>
           </a:p>
           <a:p>
@@ -13363,6 +14318,22 @@
               </a:spcAft>
             </a:pPr>
             <a:r>
+              <a:rPr sz="1700" b="1">
+                <a:solidFill>
+                  <a:srgbClr val="1A3A5C"/>
+                </a:solidFill>
+                <a:latin typeface="Calibri"/>
+              </a:rPr>
+              <a:t>▸  Doctrine</a:t>
+            </a:r>
+          </a:p>
+          <a:p>
+            <a:pPr>
+              <a:spcAft>
+                <a:spcPts val="600"/>
+              </a:spcAft>
+            </a:pPr>
+            <a:r>
               <a:rPr sz="1300">
                 <a:solidFill>
                   <a:srgbClr val="5A6A7E"/>
@@ -13370,6 +14341,22 @@
                 <a:latin typeface="Calibri Light"/>
               </a:rPr>
               <a:t>       aeroVFR, « Pour éviter les sorties longitudinales à l'atterrissage » (2015) ; « Finale non stabilisée, prise de décision et remise de gaz » (2023) ; « La menace des circuits contraints » (2025)</a:t>
+            </a:r>
+          </a:p>
+          <a:p>
+            <a:pPr>
+              <a:spcAft>
+                <a:spcPts val="600"/>
+              </a:spcAft>
+            </a:pPr>
+            <a:r>
+              <a:rPr sz="1300">
+                <a:solidFill>
+                  <a:srgbClr val="5A6A7E"/>
+                </a:solidFill>
+                <a:latin typeface="Calibri Light"/>
+              </a:rPr>
+              <a:t>       aeroVFR, « Ne pas faire brouette à l'atterrissage » (2026), sur le freinage et la roulette de nez</a:t>
             </a:r>
           </a:p>
           <a:p>
@@ -13414,7 +14401,7 @@
 </p:sld>
 </file>
 
-<file path=ppt/slides/slide23.xml><?xml version="1.0" encoding="utf-8"?>
+<file path=ppt/slides/slide24.xml><?xml version="1.0" encoding="utf-8"?>
 <p:sld xmlns:a="http://schemas.openxmlformats.org/drawingml/2006/main" xmlns:p="http://schemas.openxmlformats.org/presentationml/2006/main" xmlns:r="http://schemas.openxmlformats.org/officeDocument/2006/relationships">
   <p:cSld>
     <p:bg>
@@ -17905,7 +18892,7 @@
                 </a:solidFill>
                 <a:latin typeface="Calibri"/>
               </a:rPr>
-              <a:t>▸  Avion à aile lisse, peu tolérant à l'excès de vitesse</a:t>
+              <a:t>▸  Expérience récente limitée, DA40 jugé « très exigeant » par le pilote</a:t>
             </a:r>
           </a:p>
           <a:p>
@@ -17921,7 +18908,7 @@
                 </a:solidFill>
                 <a:latin typeface="Calibri"/>
               </a:rPr>
-              <a:t>▸  La première remise de gaz avait consommé une partie de l'attention</a:t>
+              <a:t>▸  Dernier posé sur ce terrain : cinq ans plus tôt, en DR400</a:t>
             </a:r>
           </a:p>
           <a:p>

</xml_diff>

<commit_message>
Ajoute la diapositive VAC LFSL au support sorties de piste
Carte d'atterrissage à vue AD 2 LFSL ATT 01 (AMDT 08/26) découpée autour
de la piste, chiffres clés du terrain et consignes particulières utiles au
sujet. La diapositive d'application locale et les sources sont mises à jour.
25 diapositives.

Co-Authored-By: Claude Fable 5.1 <noreply@anthropic.com>
Claude-Session: https://claude.ai/code/session_01HRmUKUt1JuTKhtALye4yQd
</commit_message>
<xml_diff>
--- a/aeroclub/sorties-de-piste/Sorties_de_piste_longitudinales_FV.pptx
+++ b/aeroclub/sorties-de-piste/Sorties_de_piste_longitudinales_FV.pptx
@@ -29,6 +29,7 @@
     <p:sldId id="277" r:id="rId29"/>
     <p:sldId id="278" r:id="rId30"/>
     <p:sldId id="279" r:id="rId31"/>
+    <p:sldId id="280" r:id="rId32"/>
   </p:sldIdLst>
   <p:sldSz cx="12188952" cy="6858000" type="screen4x3"/>
   <p:notesSz cx="6858000" cy="9144000"/>
@@ -831,6 +832,76 @@
 </file>
 
 <file path=ppt/notesSlides/notesSlide14.xml><?xml version="1.0" encoding="utf-8"?>
+<p:notes xmlns:a="http://schemas.openxmlformats.org/drawingml/2006/main" xmlns:p="http://schemas.openxmlformats.org/presentationml/2006/main" xmlns:r="http://schemas.openxmlformats.org/officeDocument/2006/relationships">
+  <p:cSld>
+    <p:spTree>
+      <p:nvGrpSpPr>
+        <p:cNvPr id="1" name=""/>
+        <p:cNvGrpSpPr/>
+        <p:nvPr/>
+      </p:nvGrpSpPr>
+      <p:grpSpPr>
+        <a:xfrm>
+          <a:off x="0" y="0"/>
+          <a:ext cx="0" cy="0"/>
+          <a:chOff x="0" y="0"/>
+          <a:chExt cx="0" cy="0"/>
+        </a:xfrm>
+      </p:grpSpPr>
+      <p:sp>
+        <p:nvSpPr>
+          <p:cNvPr id="2" name="Slide Image Placeholder 1"/>
+          <p:cNvSpPr>
+            <a:spLocks noGrp="1"/>
+          </p:cNvSpPr>
+          <p:nvPr>
+            <p:ph type="sldImg" idx="2"/>
+          </p:nvPr>
+        </p:nvSpPr>
+        <p:spPr/>
+      </p:sp>
+      <p:sp>
+        <p:nvSpPr>
+          <p:cNvPr id="3" name="Notes Placeholder 2"/>
+          <p:cNvSpPr>
+            <a:spLocks noGrp="1"/>
+          </p:cNvSpPr>
+          <p:nvPr>
+            <p:ph type="body" idx="3" sz="quarter"/>
+          </p:nvPr>
+        </p:nvSpPr>
+        <p:spPr/>
+        <p:txBody>
+          <a:bodyPr/>
+          <a:lstStyle/>
+          <a:p>
+            <a:r>
+              <a:t>VAC extraite du mail « Mise à jour carte VAC LFSL » de Thomas Andrieu du 10 juillet 2026 (fichier LFSL_2026_08_vac_en.pdf). Le changement principal de cette édition est la fréquence 121,130. Projeter la VAC complète (pages APP et ATT) en complément. Discussion : où placer notre repère de remise de gaz en 11 et en 29 ? Par exemple une bretelle ou les hangars, visibles depuis le cockpit.</a:t>
+            </a:r>
+          </a:p>
+        </p:txBody>
+      </p:sp>
+      <p:sp>
+        <p:nvSpPr>
+          <p:cNvPr id="4" name="Slide Number Placeholder 3"/>
+          <p:cNvSpPr>
+            <a:spLocks noGrp="1"/>
+          </p:cNvSpPr>
+          <p:nvPr>
+            <p:ph type="sldNum" idx="5" sz="quarter"/>
+          </p:nvPr>
+        </p:nvSpPr>
+        <p:spPr/>
+      </p:sp>
+    </p:spTree>
+  </p:cSld>
+  <p:clrMapOvr>
+    <a:masterClrMapping/>
+  </p:clrMapOvr>
+</p:notes>
+</file>
+
+<file path=ppt/notesSlides/notesSlide15.xml><?xml version="1.0" encoding="utf-8"?>
 <p:notes xmlns:a="http://schemas.openxmlformats.org/drawingml/2006/main" xmlns:p="http://schemas.openxmlformats.org/presentationml/2006/main" xmlns:r="http://schemas.openxmlformats.org/officeDocument/2006/relationships">
   <p:cSld>
     <p:spTree>
@@ -10653,7 +10724,7 @@
     <p:bg>
       <p:bgPr>
         <a:solidFill>
-          <a:srgbClr val="FFFFFF"/>
+          <a:srgbClr val="F4F8FD"/>
         </a:solidFill>
         <a:effectLst/>
       </p:bgPr>
@@ -10783,7 +10854,7 @@
                 </a:solidFill>
                 <a:latin typeface="Calibri Light"/>
               </a:rPr>
-              <a:t>Application à nos pistes et à nos navigations</a:t>
+              <a:t>Notre terrain : LFSL Brive Vallée de la Dordogne</a:t>
             </a:r>
           </a:p>
         </p:txBody>
@@ -10928,14 +10999,82 @@
       </p:sp>
       <p:sp>
         <p:nvSpPr>
-          <p:cNvPr id="9" name="TextBox 8"/>
+          <p:cNvPr id="9" name="Rectangle 8"/>
+          <p:cNvSpPr/>
+          <p:nvPr/>
+        </p:nvSpPr>
+        <p:spPr>
+          <a:xfrm>
+            <a:off x="457200" y="1234440"/>
+            <a:ext cx="7498079" cy="4846320"/>
+          </a:xfrm>
+          <a:prstGeom prst="rect">
+            <a:avLst/>
+          </a:prstGeom>
+          <a:solidFill>
+            <a:srgbClr val="FFFFFF"/>
+          </a:solidFill>
+          <a:ln>
+            <a:noFill/>
+          </a:ln>
+          <a:effectLst/>
+        </p:spPr>
+        <p:style>
+          <a:lnRef idx="1">
+            <a:schemeClr val="accent1"/>
+          </a:lnRef>
+          <a:fillRef idx="3">
+            <a:schemeClr val="accent1"/>
+          </a:fillRef>
+          <a:effectRef idx="2">
+            <a:schemeClr val="accent1"/>
+          </a:effectRef>
+          <a:fontRef idx="minor">
+            <a:schemeClr val="lt1"/>
+          </a:fontRef>
+        </p:style>
+        <p:txBody>
+          <a:bodyPr rtlCol="0" anchor="ctr"/>
+          <a:lstStyle/>
+          <a:p>
+            <a:pPr algn="ctr"/>
+          </a:p>
+        </p:txBody>
+      </p:sp>
+      <p:pic>
+        <p:nvPicPr>
+          <p:cNvPr id="10" name="Picture 9" descr="vac_lfsl_att_crop.png"/>
+          <p:cNvPicPr>
+            <a:picLocks noChangeAspect="1"/>
+          </p:cNvPicPr>
+          <p:nvPr/>
+        </p:nvPicPr>
+        <p:blipFill>
+          <a:blip r:embed="rId3"/>
+          <a:stretch>
+            <a:fillRect/>
+          </a:stretch>
+        </p:blipFill>
+        <p:spPr>
+          <a:xfrm>
+            <a:off x="548640" y="1325880"/>
+            <a:ext cx="7315200" cy="3838968"/>
+          </a:xfrm>
+          <a:prstGeom prst="rect">
+            <a:avLst/>
+          </a:prstGeom>
+        </p:spPr>
+      </p:pic>
+      <p:sp>
+        <p:nvSpPr>
+          <p:cNvPr id="11" name="TextBox 10"/>
           <p:cNvSpPr txBox="1"/>
           <p:nvPr/>
         </p:nvSpPr>
         <p:spPr>
           <a:xfrm>
-            <a:off x="548640" y="1188720"/>
-            <a:ext cx="10881360" cy="5120640"/>
+            <a:off x="548640" y="5193792"/>
+            <a:ext cx="7315200" cy="411480"/>
           </a:xfrm>
           <a:prstGeom prst="rect">
             <a:avLst/>
@@ -10948,147 +11087,530 @@
           </a:bodyPr>
           <a:lstStyle/>
           <a:p>
+            <a:pPr algn="l"/>
+            <a:r>
+              <a:rPr sz="1000" b="0" i="1">
+                <a:solidFill>
+                  <a:srgbClr val="6B7A8C"/>
+                </a:solidFill>
+                <a:latin typeface="Calibri"/>
+              </a:rPr>
+              <a:t>Extrait de la VAC AD 2 LFSL ATT 01, AMDT 08/26 en vigueur depuis le 9 juillet 2026, © SIA. Prochaine mise à jour AIP le 1er octobre 2026 : revérifier la carte avant la séance.</a:t>
+            </a:r>
+          </a:p>
+        </p:txBody>
+      </p:sp>
+      <p:sp>
+        <p:nvSpPr>
+          <p:cNvPr id="12" name="Rectangle 11"/>
+          <p:cNvSpPr/>
+          <p:nvPr/>
+        </p:nvSpPr>
+        <p:spPr>
+          <a:xfrm>
+            <a:off x="548640" y="5577840"/>
+            <a:ext cx="7315200" cy="411480"/>
+          </a:xfrm>
+          <a:prstGeom prst="rect">
+            <a:avLst/>
+          </a:prstGeom>
+          <a:solidFill>
+            <a:srgbClr val="2E7D4F"/>
+          </a:solidFill>
+          <a:ln>
+            <a:noFill/>
+          </a:ln>
+          <a:effectLst/>
+        </p:spPr>
+        <p:style>
+          <a:lnRef idx="1">
+            <a:schemeClr val="accent1"/>
+          </a:lnRef>
+          <a:fillRef idx="3">
+            <a:schemeClr val="accent1"/>
+          </a:fillRef>
+          <a:effectRef idx="2">
+            <a:schemeClr val="accent1"/>
+          </a:effectRef>
+          <a:fontRef idx="minor">
+            <a:schemeClr val="lt1"/>
+          </a:fontRef>
+        </p:style>
+        <p:txBody>
+          <a:bodyPr rtlCol="0" anchor="ctr"/>
+          <a:lstStyle/>
+          <a:p>
+            <a:pPr algn="ctr"/>
+          </a:p>
+        </p:txBody>
+      </p:sp>
+      <p:sp>
+        <p:nvSpPr>
+          <p:cNvPr id="13" name="TextBox 12"/>
+          <p:cNvSpPr txBox="1"/>
+          <p:nvPr/>
+        </p:nvSpPr>
+        <p:spPr>
+          <a:xfrm>
+            <a:off x="685800" y="5577840"/>
+            <a:ext cx="7132320" cy="411480"/>
+          </a:xfrm>
+          <a:prstGeom prst="rect">
+            <a:avLst/>
+          </a:prstGeom>
+          <a:noFill/>
+        </p:spPr>
+        <p:txBody>
+          <a:bodyPr wrap="square" anchor="ctr">
+            <a:spAutoFit/>
+          </a:bodyPr>
+          <a:lstStyle/>
+          <a:p>
+            <a:pPr algn="l"/>
+            <a:r>
+              <a:rPr sz="1300" b="1" i="0">
+                <a:solidFill>
+                  <a:srgbClr val="FFFFFF"/>
+                </a:solidFill>
+                <a:latin typeface="Calibri"/>
+              </a:rPr>
+              <a:t>2 100 m ne dispensent pas d'une zone de toucher : roues au sol dans le premier tiers, sinon remise de gaz.</a:t>
+            </a:r>
+          </a:p>
+        </p:txBody>
+      </p:sp>
+      <p:sp>
+        <p:nvSpPr>
+          <p:cNvPr id="14" name="Rectangle 13"/>
+          <p:cNvSpPr/>
+          <p:nvPr/>
+        </p:nvSpPr>
+        <p:spPr>
+          <a:xfrm>
+            <a:off x="8138160" y="1234440"/>
+            <a:ext cx="3611880" cy="4846320"/>
+          </a:xfrm>
+          <a:prstGeom prst="rect">
+            <a:avLst/>
+          </a:prstGeom>
+          <a:solidFill>
+            <a:srgbClr val="FFFFFF"/>
+          </a:solidFill>
+          <a:ln>
+            <a:noFill/>
+          </a:ln>
+          <a:effectLst/>
+        </p:spPr>
+        <p:style>
+          <a:lnRef idx="1">
+            <a:schemeClr val="accent1"/>
+          </a:lnRef>
+          <a:fillRef idx="3">
+            <a:schemeClr val="accent1"/>
+          </a:fillRef>
+          <a:effectRef idx="2">
+            <a:schemeClr val="accent1"/>
+          </a:effectRef>
+          <a:fontRef idx="minor">
+            <a:schemeClr val="lt1"/>
+          </a:fontRef>
+        </p:style>
+        <p:txBody>
+          <a:bodyPr rtlCol="0" anchor="ctr"/>
+          <a:lstStyle/>
+          <a:p>
+            <a:pPr algn="ctr"/>
+          </a:p>
+        </p:txBody>
+      </p:sp>
+      <p:sp>
+        <p:nvSpPr>
+          <p:cNvPr id="15" name="Rectangle 14"/>
+          <p:cNvSpPr/>
+          <p:nvPr/>
+        </p:nvSpPr>
+        <p:spPr>
+          <a:xfrm>
+            <a:off x="8138160" y="1234440"/>
+            <a:ext cx="3611880" cy="502920"/>
+          </a:xfrm>
+          <a:prstGeom prst="rect">
+            <a:avLst/>
+          </a:prstGeom>
+          <a:solidFill>
+            <a:srgbClr val="1A3A5C"/>
+          </a:solidFill>
+          <a:ln>
+            <a:noFill/>
+          </a:ln>
+          <a:effectLst/>
+        </p:spPr>
+        <p:style>
+          <a:lnRef idx="1">
+            <a:schemeClr val="accent1"/>
+          </a:lnRef>
+          <a:fillRef idx="3">
+            <a:schemeClr val="accent1"/>
+          </a:fillRef>
+          <a:effectRef idx="2">
+            <a:schemeClr val="accent1"/>
+          </a:effectRef>
+          <a:fontRef idx="minor">
+            <a:schemeClr val="lt1"/>
+          </a:fontRef>
+        </p:style>
+        <p:txBody>
+          <a:bodyPr rtlCol="0" anchor="ctr"/>
+          <a:lstStyle/>
+          <a:p>
+            <a:pPr algn="ctr"/>
+          </a:p>
+        </p:txBody>
+      </p:sp>
+      <p:sp>
+        <p:nvSpPr>
+          <p:cNvPr id="16" name="TextBox 15"/>
+          <p:cNvSpPr txBox="1"/>
+          <p:nvPr/>
+        </p:nvSpPr>
+        <p:spPr>
+          <a:xfrm>
+            <a:off x="8275320" y="1280160"/>
+            <a:ext cx="3383280" cy="411480"/>
+          </a:xfrm>
+          <a:prstGeom prst="rect">
+            <a:avLst/>
+          </a:prstGeom>
+          <a:noFill/>
+        </p:spPr>
+        <p:txBody>
+          <a:bodyPr wrap="square" anchor="ctr">
+            <a:spAutoFit/>
+          </a:bodyPr>
+          <a:lstStyle/>
+          <a:p>
+            <a:pPr algn="l"/>
+            <a:r>
+              <a:rPr sz="1500" b="1" i="0">
+                <a:solidFill>
+                  <a:srgbClr val="FFFFFF"/>
+                </a:solidFill>
+                <a:latin typeface="Calibri"/>
+              </a:rPr>
+              <a:t>LFSL en chiffres</a:t>
+            </a:r>
+          </a:p>
+        </p:txBody>
+      </p:sp>
+      <p:sp>
+        <p:nvSpPr>
+          <p:cNvPr id="17" name="TextBox 16"/>
+          <p:cNvSpPr txBox="1"/>
+          <p:nvPr/>
+        </p:nvSpPr>
+        <p:spPr>
+          <a:xfrm>
+            <a:off x="8229600" y="1783080"/>
+            <a:ext cx="3474720" cy="2011680"/>
+          </a:xfrm>
+          <a:prstGeom prst="rect">
+            <a:avLst/>
+          </a:prstGeom>
+          <a:noFill/>
+        </p:spPr>
+        <p:txBody>
+          <a:bodyPr wrap="square">
+            <a:spAutoFit/>
+          </a:bodyPr>
+          <a:lstStyle/>
+          <a:p>
             <a:pPr>
               <a:spcAft>
-                <a:spcPts val="900"/>
+                <a:spcPts val="300"/>
               </a:spcAft>
             </a:pPr>
             <a:r>
-              <a:rPr sz="2000" b="1">
+              <a:rPr sz="1200" b="1">
                 <a:solidFill>
                   <a:srgbClr val="1A3A5C"/>
                 </a:solidFill>
                 <a:latin typeface="Calibri"/>
               </a:rPr>
-              <a:t>▸  Nos pistes : longueur, revêtement, pente, repère de remise de gaz</a:t>
+              <a:t>▸  ALT 1 016 ft · piste 11/29 · 2 100 × 45 m revêtue</a:t>
             </a:r>
           </a:p>
           <a:p>
             <a:pPr>
               <a:spcAft>
-                <a:spcPts val="900"/>
+                <a:spcPts val="300"/>
               </a:spcAft>
             </a:pPr>
             <a:r>
-              <a:rPr sz="1500">
-                <a:solidFill>
-                  <a:srgbClr val="5A6A7E"/>
-                </a:solidFill>
-                <a:latin typeface="Calibri Light"/>
-              </a:rPr>
-              <a:t>       [À compléter : pour chaque QFU, un repère visible depuis le cockpit avant lequel les roues doivent être au sol.]</a:t>
+              <a:rPr sz="1200" b="1">
+                <a:solidFill>
+                  <a:srgbClr val="1A3A5C"/>
+                </a:solidFill>
+                <a:latin typeface="Calibri"/>
+              </a:rPr>
+              <a:t>▸  QFU 113° / 293° · QFU 293° préférentiel (IFR)</a:t>
             </a:r>
           </a:p>
           <a:p>
             <a:pPr>
               <a:spcAft>
-                <a:spcPts val="900"/>
+                <a:spcPts val="300"/>
               </a:spcAft>
             </a:pPr>
             <a:r>
-              <a:rPr sz="2000" b="1">
+              <a:rPr sz="1200" b="1">
                 <a:solidFill>
                   <a:srgbClr val="1A3A5C"/>
                 </a:solidFill>
                 <a:latin typeface="Calibri"/>
               </a:rPr>
-              <a:t>▸  Nos terrains de navigation habituels de moins de 800 m</a:t>
+              <a:t>▸  PAPI 3,0° en 11 · PAPI 3,2° en 29</a:t>
             </a:r>
           </a:p>
           <a:p>
             <a:pPr>
               <a:spcAft>
-                <a:spcPts val="900"/>
+                <a:spcPts val="300"/>
               </a:spcAft>
             </a:pPr>
             <a:r>
-              <a:rPr sz="1500">
-                <a:solidFill>
-                  <a:srgbClr val="5A6A7E"/>
-                </a:solidFill>
-                <a:latin typeface="Calibri Light"/>
-              </a:rPr>
-              <a:t>       [À compléter : liste des terrains courts fréquentés par le club, avec leurs particularités VAC.]</a:t>
+              <a:rPr sz="1200" b="1">
+                <a:solidFill>
+                  <a:srgbClr val="1A3A5C"/>
+                </a:solidFill>
+                <a:latin typeface="Calibri"/>
+              </a:rPr>
+              <a:t>▸  Tour de piste 2 000 ft (1 000 ft AAL)</a:t>
             </a:r>
           </a:p>
           <a:p>
             <a:pPr>
               <a:spcAft>
-                <a:spcPts val="900"/>
+                <a:spcPts val="300"/>
               </a:spcAft>
             </a:pPr>
             <a:r>
-              <a:rPr sz="2000" b="1">
+              <a:rPr sz="1200" b="1">
                 <a:solidFill>
                   <a:srgbClr val="1A3A5C"/>
                 </a:solidFill>
                 <a:latin typeface="Calibri"/>
               </a:rPr>
-              <a:t>▸  Exercice au tableau : distance d'atterrissage majorée</a:t>
-            </a:r>
-          </a:p>
+              <a:t>▸  TWR, AFIS et A/A : 121,130</a:t>
+            </a:r>
+          </a:p>
+        </p:txBody>
+      </p:sp>
+      <p:sp>
+        <p:nvSpPr>
+          <p:cNvPr id="18" name="Rectangle 17"/>
+          <p:cNvSpPr/>
+          <p:nvPr/>
+        </p:nvSpPr>
+        <p:spPr>
+          <a:xfrm>
+            <a:off x="8138160" y="3840480"/>
+            <a:ext cx="3611880" cy="457200"/>
+          </a:xfrm>
+          <a:prstGeom prst="rect">
+            <a:avLst/>
+          </a:prstGeom>
+          <a:solidFill>
+            <a:srgbClr val="D68910"/>
+          </a:solidFill>
+          <a:ln>
+            <a:noFill/>
+          </a:ln>
+          <a:effectLst/>
+        </p:spPr>
+        <p:style>
+          <a:lnRef idx="1">
+            <a:schemeClr val="accent1"/>
+          </a:lnRef>
+          <a:fillRef idx="3">
+            <a:schemeClr val="accent1"/>
+          </a:fillRef>
+          <a:effectRef idx="2">
+            <a:schemeClr val="accent1"/>
+          </a:effectRef>
+          <a:fontRef idx="minor">
+            <a:schemeClr val="lt1"/>
+          </a:fontRef>
+        </p:style>
+        <p:txBody>
+          <a:bodyPr rtlCol="0" anchor="ctr"/>
+          <a:lstStyle/>
+          <a:p>
+            <a:pPr algn="ctr"/>
+          </a:p>
+        </p:txBody>
+      </p:sp>
+      <p:sp>
+        <p:nvSpPr>
+          <p:cNvPr id="19" name="TextBox 18"/>
+          <p:cNvSpPr txBox="1"/>
+          <p:nvPr/>
+        </p:nvSpPr>
+        <p:spPr>
+          <a:xfrm>
+            <a:off x="8275320" y="3858768"/>
+            <a:ext cx="3383280" cy="411480"/>
+          </a:xfrm>
+          <a:prstGeom prst="rect">
+            <a:avLst/>
+          </a:prstGeom>
+          <a:noFill/>
+        </p:spPr>
+        <p:txBody>
+          <a:bodyPr wrap="square" anchor="ctr">
+            <a:spAutoFit/>
+          </a:bodyPr>
+          <a:lstStyle/>
+          <a:p>
+            <a:pPr algn="l"/>
+            <a:r>
+              <a:rPr sz="1400" b="1" i="0">
+                <a:solidFill>
+                  <a:srgbClr val="FFFFFF"/>
+                </a:solidFill>
+                <a:latin typeface="Calibri"/>
+              </a:rPr>
+              <a:t>Ce que la VAC nous dit</a:t>
+            </a:r>
+          </a:p>
+        </p:txBody>
+      </p:sp>
+      <p:sp>
+        <p:nvSpPr>
+          <p:cNvPr id="20" name="Rectangle 19"/>
+          <p:cNvSpPr/>
+          <p:nvPr/>
+        </p:nvSpPr>
+        <p:spPr>
+          <a:xfrm>
+            <a:off x="8138160" y="4297680"/>
+            <a:ext cx="3611880" cy="1783080"/>
+          </a:xfrm>
+          <a:prstGeom prst="rect">
+            <a:avLst/>
+          </a:prstGeom>
+          <a:solidFill>
+            <a:srgbClr val="FBF0DC"/>
+          </a:solidFill>
+          <a:ln>
+            <a:noFill/>
+          </a:ln>
+          <a:effectLst/>
+        </p:spPr>
+        <p:style>
+          <a:lnRef idx="1">
+            <a:schemeClr val="accent1"/>
+          </a:lnRef>
+          <a:fillRef idx="3">
+            <a:schemeClr val="accent1"/>
+          </a:fillRef>
+          <a:effectRef idx="2">
+            <a:schemeClr val="accent1"/>
+          </a:effectRef>
+          <a:fontRef idx="minor">
+            <a:schemeClr val="lt1"/>
+          </a:fontRef>
+        </p:style>
+        <p:txBody>
+          <a:bodyPr rtlCol="0" anchor="ctr"/>
+          <a:lstStyle/>
+          <a:p>
+            <a:pPr algn="ctr"/>
+          </a:p>
+        </p:txBody>
+      </p:sp>
+      <p:sp>
+        <p:nvSpPr>
+          <p:cNvPr id="21" name="TextBox 20"/>
+          <p:cNvSpPr txBox="1"/>
+          <p:nvPr/>
+        </p:nvSpPr>
+        <p:spPr>
+          <a:xfrm>
+            <a:off x="8229600" y="4343400"/>
+            <a:ext cx="3474720" cy="1737360"/>
+          </a:xfrm>
+          <a:prstGeom prst="rect">
+            <a:avLst/>
+          </a:prstGeom>
+          <a:noFill/>
+        </p:spPr>
+        <p:txBody>
+          <a:bodyPr wrap="square">
+            <a:spAutoFit/>
+          </a:bodyPr>
+          <a:lstStyle/>
           <a:p>
             <a:pPr>
               <a:spcAft>
-                <a:spcPts val="900"/>
+                <a:spcPts val="300"/>
               </a:spcAft>
             </a:pPr>
             <a:r>
-              <a:rPr sz="1500">
-                <a:solidFill>
-                  <a:srgbClr val="5A6A7E"/>
-                </a:solidFill>
-                <a:latin typeface="Calibri Light"/>
-              </a:rPr>
-              <a:t>       Distance manuel (piste dure, sèche, vent nul) × herbe × mouillée × vent arrière × marge personnelle = ?</a:t>
+              <a:rPr sz="1200" b="1">
+                <a:solidFill>
+                  <a:srgbClr val="1A3A5C"/>
+                </a:solidFill>
+                <a:latin typeface="Calibri"/>
+              </a:rPr>
+              <a:t>▸  Turbulence possible aux seuils 11 et 29</a:t>
             </a:r>
           </a:p>
           <a:p>
             <a:pPr>
               <a:spcAft>
-                <a:spcPts val="900"/>
+                <a:spcPts val="300"/>
               </a:spcAft>
             </a:pPr>
             <a:r>
-              <a:rPr sz="1500">
-                <a:solidFill>
-                  <a:srgbClr val="5A6A7E"/>
-                </a:solidFill>
-                <a:latin typeface="Calibri Light"/>
-              </a:rPr>
-              <a:t>       Comparer le résultat à la longueur de piste. Si l'écart est faible, le terrain est hors limites ce jour-là.</a:t>
+              <a:rPr sz="1200" b="1">
+                <a:solidFill>
+                  <a:srgbClr val="1A3A5C"/>
+                </a:solidFill>
+                <a:latin typeface="Calibri"/>
+              </a:rPr>
+              <a:t>▸  Colline dans la surface d'approche du seuil 29</a:t>
             </a:r>
           </a:p>
           <a:p>
             <a:pPr>
               <a:spcAft>
-                <a:spcPts val="900"/>
+                <a:spcPts val="300"/>
               </a:spcAft>
             </a:pPr>
             <a:r>
-              <a:rPr sz="2000" b="1">
+              <a:rPr sz="1200" b="1">
                 <a:solidFill>
                   <a:srgbClr val="1A3A5C"/>
                 </a:solidFill>
                 <a:latin typeface="Calibri"/>
               </a:rPr>
-              <a:t>▸  Engagement de séance</a:t>
+              <a:t>▸  RWY 29 : virage à gauche au plus tard à 500 ft AAL</a:t>
             </a:r>
           </a:p>
           <a:p>
             <a:pPr>
               <a:spcAft>
-                <a:spcPts val="900"/>
+                <a:spcPts val="300"/>
               </a:spcAft>
             </a:pPr>
             <a:r>
-              <a:rPr sz="1500">
-                <a:solidFill>
-                  <a:srgbClr val="5A6A7E"/>
-                </a:solidFill>
-                <a:latin typeface="Calibri Light"/>
-              </a:rPr>
-              <a:t>       Chacun repart avec une valeur de distance pour son avion habituel et un repère de remise de gaz sur notre piste principale.</a:t>
+              <a:rPr sz="1200" b="1">
+                <a:solidFill>
+                  <a:srgbClr val="1A3A5C"/>
+                </a:solidFill>
+                <a:latin typeface="Calibri"/>
+              </a:rPr>
+              <a:t>▸  Arrivée en 29 interdite si PAPI hors service</a:t>
             </a:r>
           </a:p>
         </p:txBody>
@@ -11911,7 +12433,7 @@
                 </a:solidFill>
                 <a:latin typeface="Calibri Light"/>
               </a:rPr>
-              <a:t>Question de révision</a:t>
+              <a:t>Application à nos pistes et à nos navigations</a:t>
             </a:r>
           </a:p>
         </p:txBody>
@@ -12056,595 +12578,14 @@
       </p:sp>
       <p:sp>
         <p:nvSpPr>
-          <p:cNvPr id="9" name="Rectangle 8"/>
-          <p:cNvSpPr/>
-          <p:nvPr/>
-        </p:nvSpPr>
-        <p:spPr>
-          <a:xfrm>
-            <a:off x="640080" y="1325880"/>
-            <a:ext cx="10881360" cy="1005840"/>
-          </a:xfrm>
-          <a:prstGeom prst="rect">
-            <a:avLst/>
-          </a:prstGeom>
-          <a:solidFill>
-            <a:srgbClr val="D2EBF8"/>
-          </a:solidFill>
-          <a:ln>
-            <a:noFill/>
-          </a:ln>
-          <a:effectLst/>
-        </p:spPr>
-        <p:style>
-          <a:lnRef idx="1">
-            <a:schemeClr val="accent1"/>
-          </a:lnRef>
-          <a:fillRef idx="3">
-            <a:schemeClr val="accent1"/>
-          </a:fillRef>
-          <a:effectRef idx="2">
-            <a:schemeClr val="accent1"/>
-          </a:effectRef>
-          <a:fontRef idx="minor">
-            <a:schemeClr val="lt1"/>
-          </a:fontRef>
-        </p:style>
-        <p:txBody>
-          <a:bodyPr rtlCol="0" anchor="ctr" wrap="square" lIns="228600"/>
-          <a:lstStyle/>
-          <a:p>
-            <a:pPr algn="ctr"/>
-            <a:r>
-              <a:rPr sz="1800" b="1">
-                <a:solidFill>
-                  <a:srgbClr val="1A3A5C"/>
-                </a:solidFill>
-                <a:latin typeface="Calibri"/>
-              </a:rPr>
-              <a:t>Finale sur une piste en herbe de 750 m. À 300 ft sol, vous êtes à Vref + 15 kt et légèrement au-dessus du plan. Que faites-vous ?</a:t>
-            </a:r>
-          </a:p>
-        </p:txBody>
-      </p:sp>
-      <p:sp>
-        <p:nvSpPr>
-          <p:cNvPr id="10" name="Rectangle 9"/>
-          <p:cNvSpPr/>
-          <p:nvPr/>
-        </p:nvSpPr>
-        <p:spPr>
-          <a:xfrm>
-            <a:off x="640080" y="2697480"/>
-            <a:ext cx="5257800" cy="1051560"/>
-          </a:xfrm>
-          <a:prstGeom prst="rect">
-            <a:avLst/>
-          </a:prstGeom>
-          <a:solidFill>
-            <a:srgbClr val="F5F7FA"/>
-          </a:solidFill>
-          <a:ln>
-            <a:noFill/>
-          </a:ln>
-          <a:effectLst/>
-        </p:spPr>
-        <p:style>
-          <a:lnRef idx="1">
-            <a:schemeClr val="accent1"/>
-          </a:lnRef>
-          <a:fillRef idx="3">
-            <a:schemeClr val="accent1"/>
-          </a:fillRef>
-          <a:effectRef idx="2">
-            <a:schemeClr val="accent1"/>
-          </a:effectRef>
-          <a:fontRef idx="minor">
-            <a:schemeClr val="lt1"/>
-          </a:fontRef>
-        </p:style>
-        <p:txBody>
-          <a:bodyPr rtlCol="0" anchor="ctr"/>
-          <a:lstStyle/>
-          <a:p>
-            <a:pPr algn="ctr"/>
-          </a:p>
-        </p:txBody>
-      </p:sp>
-      <p:sp>
-        <p:nvSpPr>
-          <p:cNvPr id="11" name="Oval 10"/>
-          <p:cNvSpPr/>
-          <p:nvPr/>
-        </p:nvSpPr>
-        <p:spPr>
-          <a:xfrm>
-            <a:off x="804671" y="2990088"/>
-            <a:ext cx="457200" cy="457200"/>
-          </a:xfrm>
-          <a:prstGeom prst="ellipse">
-            <a:avLst/>
-          </a:prstGeom>
-          <a:solidFill>
-            <a:srgbClr val="1A3A5C"/>
-          </a:solidFill>
-          <a:ln>
-            <a:noFill/>
-          </a:ln>
-          <a:effectLst/>
-        </p:spPr>
-        <p:style>
-          <a:lnRef idx="1">
-            <a:schemeClr val="accent1"/>
-          </a:lnRef>
-          <a:fillRef idx="3">
-            <a:schemeClr val="accent1"/>
-          </a:fillRef>
-          <a:effectRef idx="2">
-            <a:schemeClr val="accent1"/>
-          </a:effectRef>
-          <a:fontRef idx="minor">
-            <a:schemeClr val="lt1"/>
-          </a:fontRef>
-        </p:style>
-        <p:txBody>
-          <a:bodyPr rtlCol="0" anchor="ctr"/>
-          <a:lstStyle/>
-          <a:p>
-            <a:pPr algn="ctr"/>
-            <a:r>
-              <a:rPr sz="1600" b="1">
-                <a:solidFill>
-                  <a:srgbClr val="FFFFFF"/>
-                </a:solidFill>
-                <a:latin typeface="Calibri"/>
-              </a:rPr>
-              <a:t>A</a:t>
-            </a:r>
-          </a:p>
-        </p:txBody>
-      </p:sp>
-      <p:sp>
-        <p:nvSpPr>
-          <p:cNvPr id="12" name="TextBox 11"/>
+          <p:cNvPr id="9" name="TextBox 8"/>
           <p:cNvSpPr txBox="1"/>
           <p:nvPr/>
         </p:nvSpPr>
         <p:spPr>
           <a:xfrm>
-            <a:off x="1417319" y="2834640"/>
-            <a:ext cx="4389120" cy="777240"/>
-          </a:xfrm>
-          <a:prstGeom prst="rect">
-            <a:avLst/>
-          </a:prstGeom>
-          <a:noFill/>
-        </p:spPr>
-        <p:txBody>
-          <a:bodyPr wrap="square" anchor="ctr">
-            <a:spAutoFit/>
-          </a:bodyPr>
-          <a:lstStyle/>
-          <a:p>
-            <a:pPr algn="l"/>
-            <a:r>
-              <a:rPr sz="1400" b="0" i="0">
-                <a:solidFill>
-                  <a:srgbClr val="1A3A5C"/>
-                </a:solidFill>
-                <a:latin typeface="Calibri"/>
-              </a:rPr>
-              <a:t>Réduire les gaz, sortir le dernier cran de volets et rattraper le plan avant l'arrondi</a:t>
-            </a:r>
-          </a:p>
-        </p:txBody>
-      </p:sp>
-      <p:sp>
-        <p:nvSpPr>
-          <p:cNvPr id="13" name="Rectangle 12"/>
-          <p:cNvSpPr/>
-          <p:nvPr/>
-        </p:nvSpPr>
-        <p:spPr>
-          <a:xfrm>
-            <a:off x="6263640" y="2697480"/>
-            <a:ext cx="5257800" cy="1051560"/>
-          </a:xfrm>
-          <a:prstGeom prst="rect">
-            <a:avLst/>
-          </a:prstGeom>
-          <a:solidFill>
-            <a:srgbClr val="E3F1E8"/>
-          </a:solidFill>
-          <a:ln>
-            <a:noFill/>
-          </a:ln>
-          <a:effectLst/>
-        </p:spPr>
-        <p:style>
-          <a:lnRef idx="1">
-            <a:schemeClr val="accent1"/>
-          </a:lnRef>
-          <a:fillRef idx="3">
-            <a:schemeClr val="accent1"/>
-          </a:fillRef>
-          <a:effectRef idx="2">
-            <a:schemeClr val="accent1"/>
-          </a:effectRef>
-          <a:fontRef idx="minor">
-            <a:schemeClr val="lt1"/>
-          </a:fontRef>
-        </p:style>
-        <p:txBody>
-          <a:bodyPr rtlCol="0" anchor="ctr"/>
-          <a:lstStyle/>
-          <a:p>
-            <a:pPr algn="ctr"/>
-          </a:p>
-        </p:txBody>
-      </p:sp>
-      <p:sp>
-        <p:nvSpPr>
-          <p:cNvPr id="14" name="Oval 13"/>
-          <p:cNvSpPr/>
-          <p:nvPr/>
-        </p:nvSpPr>
-        <p:spPr>
-          <a:xfrm>
-            <a:off x="6428231" y="2990088"/>
-            <a:ext cx="457200" cy="457200"/>
-          </a:xfrm>
-          <a:prstGeom prst="ellipse">
-            <a:avLst/>
-          </a:prstGeom>
-          <a:solidFill>
-            <a:srgbClr val="2E7D4F"/>
-          </a:solidFill>
-          <a:ln>
-            <a:noFill/>
-          </a:ln>
-          <a:effectLst/>
-        </p:spPr>
-        <p:style>
-          <a:lnRef idx="1">
-            <a:schemeClr val="accent1"/>
-          </a:lnRef>
-          <a:fillRef idx="3">
-            <a:schemeClr val="accent1"/>
-          </a:fillRef>
-          <a:effectRef idx="2">
-            <a:schemeClr val="accent1"/>
-          </a:effectRef>
-          <a:fontRef idx="minor">
-            <a:schemeClr val="lt1"/>
-          </a:fontRef>
-        </p:style>
-        <p:txBody>
-          <a:bodyPr rtlCol="0" anchor="ctr"/>
-          <a:lstStyle/>
-          <a:p>
-            <a:pPr algn="ctr"/>
-            <a:r>
-              <a:rPr sz="1600" b="1">
-                <a:solidFill>
-                  <a:srgbClr val="FFFFFF"/>
-                </a:solidFill>
-                <a:latin typeface="Calibri"/>
-              </a:rPr>
-              <a:t>B</a:t>
-            </a:r>
-          </a:p>
-        </p:txBody>
-      </p:sp>
-      <p:sp>
-        <p:nvSpPr>
-          <p:cNvPr id="15" name="TextBox 14"/>
-          <p:cNvSpPr txBox="1"/>
-          <p:nvPr/>
-        </p:nvSpPr>
-        <p:spPr>
-          <a:xfrm>
-            <a:off x="7040879" y="2834640"/>
-            <a:ext cx="4389120" cy="777240"/>
-          </a:xfrm>
-          <a:prstGeom prst="rect">
-            <a:avLst/>
-          </a:prstGeom>
-          <a:noFill/>
-        </p:spPr>
-        <p:txBody>
-          <a:bodyPr wrap="square" anchor="ctr">
-            <a:spAutoFit/>
-          </a:bodyPr>
-          <a:lstStyle/>
-          <a:p>
-            <a:pPr algn="l"/>
-            <a:r>
-              <a:rPr sz="1400" b="1" i="0">
-                <a:solidFill>
-                  <a:srgbClr val="2E7D4F"/>
-                </a:solidFill>
-                <a:latin typeface="Calibri"/>
-              </a:rPr>
-              <a:t>Remettre les gaz maintenant, refaire un tour de piste complet et une finale stabilisée</a:t>
-            </a:r>
-          </a:p>
-        </p:txBody>
-      </p:sp>
-      <p:sp>
-        <p:nvSpPr>
-          <p:cNvPr id="16" name="Rectangle 15"/>
-          <p:cNvSpPr/>
-          <p:nvPr/>
-        </p:nvSpPr>
-        <p:spPr>
-          <a:xfrm>
-            <a:off x="640080" y="4069080"/>
-            <a:ext cx="5257800" cy="1051560"/>
-          </a:xfrm>
-          <a:prstGeom prst="rect">
-            <a:avLst/>
-          </a:prstGeom>
-          <a:solidFill>
-            <a:srgbClr val="F5F7FA"/>
-          </a:solidFill>
-          <a:ln>
-            <a:noFill/>
-          </a:ln>
-          <a:effectLst/>
-        </p:spPr>
-        <p:style>
-          <a:lnRef idx="1">
-            <a:schemeClr val="accent1"/>
-          </a:lnRef>
-          <a:fillRef idx="3">
-            <a:schemeClr val="accent1"/>
-          </a:fillRef>
-          <a:effectRef idx="2">
-            <a:schemeClr val="accent1"/>
-          </a:effectRef>
-          <a:fontRef idx="minor">
-            <a:schemeClr val="lt1"/>
-          </a:fontRef>
-        </p:style>
-        <p:txBody>
-          <a:bodyPr rtlCol="0" anchor="ctr"/>
-          <a:lstStyle/>
-          <a:p>
-            <a:pPr algn="ctr"/>
-          </a:p>
-        </p:txBody>
-      </p:sp>
-      <p:sp>
-        <p:nvSpPr>
-          <p:cNvPr id="17" name="Oval 16"/>
-          <p:cNvSpPr/>
-          <p:nvPr/>
-        </p:nvSpPr>
-        <p:spPr>
-          <a:xfrm>
-            <a:off x="804671" y="4361688"/>
-            <a:ext cx="457200" cy="457200"/>
-          </a:xfrm>
-          <a:prstGeom prst="ellipse">
-            <a:avLst/>
-          </a:prstGeom>
-          <a:solidFill>
-            <a:srgbClr val="1A3A5C"/>
-          </a:solidFill>
-          <a:ln>
-            <a:noFill/>
-          </a:ln>
-          <a:effectLst/>
-        </p:spPr>
-        <p:style>
-          <a:lnRef idx="1">
-            <a:schemeClr val="accent1"/>
-          </a:lnRef>
-          <a:fillRef idx="3">
-            <a:schemeClr val="accent1"/>
-          </a:fillRef>
-          <a:effectRef idx="2">
-            <a:schemeClr val="accent1"/>
-          </a:effectRef>
-          <a:fontRef idx="minor">
-            <a:schemeClr val="lt1"/>
-          </a:fontRef>
-        </p:style>
-        <p:txBody>
-          <a:bodyPr rtlCol="0" anchor="ctr"/>
-          <a:lstStyle/>
-          <a:p>
-            <a:pPr algn="ctr"/>
-            <a:r>
-              <a:rPr sz="1600" b="1">
-                <a:solidFill>
-                  <a:srgbClr val="FFFFFF"/>
-                </a:solidFill>
-                <a:latin typeface="Calibri"/>
-              </a:rPr>
-              <a:t>C</a:t>
-            </a:r>
-          </a:p>
-        </p:txBody>
-      </p:sp>
-      <p:sp>
-        <p:nvSpPr>
-          <p:cNvPr id="18" name="TextBox 17"/>
-          <p:cNvSpPr txBox="1"/>
-          <p:nvPr/>
-        </p:nvSpPr>
-        <p:spPr>
-          <a:xfrm>
-            <a:off x="1417319" y="4206240"/>
-            <a:ext cx="4389120" cy="777240"/>
-          </a:xfrm>
-          <a:prstGeom prst="rect">
-            <a:avLst/>
-          </a:prstGeom>
-          <a:noFill/>
-        </p:spPr>
-        <p:txBody>
-          <a:bodyPr wrap="square" anchor="ctr">
-            <a:spAutoFit/>
-          </a:bodyPr>
-          <a:lstStyle/>
-          <a:p>
-            <a:pPr algn="l"/>
-            <a:r>
-              <a:rPr sz="1400" b="0" i="0">
-                <a:solidFill>
-                  <a:srgbClr val="1A3A5C"/>
-                </a:solidFill>
-                <a:latin typeface="Calibri"/>
-              </a:rPr>
-              <a:t>Continuer, poser dans le premier tiers et freiner énergiquement</a:t>
-            </a:r>
-          </a:p>
-        </p:txBody>
-      </p:sp>
-      <p:sp>
-        <p:nvSpPr>
-          <p:cNvPr id="19" name="Rectangle 18"/>
-          <p:cNvSpPr/>
-          <p:nvPr/>
-        </p:nvSpPr>
-        <p:spPr>
-          <a:xfrm>
-            <a:off x="6263640" y="4069080"/>
-            <a:ext cx="5257800" cy="1051560"/>
-          </a:xfrm>
-          <a:prstGeom prst="rect">
-            <a:avLst/>
-          </a:prstGeom>
-          <a:solidFill>
-            <a:srgbClr val="F5F7FA"/>
-          </a:solidFill>
-          <a:ln>
-            <a:noFill/>
-          </a:ln>
-          <a:effectLst/>
-        </p:spPr>
-        <p:style>
-          <a:lnRef idx="1">
-            <a:schemeClr val="accent1"/>
-          </a:lnRef>
-          <a:fillRef idx="3">
-            <a:schemeClr val="accent1"/>
-          </a:fillRef>
-          <a:effectRef idx="2">
-            <a:schemeClr val="accent1"/>
-          </a:effectRef>
-          <a:fontRef idx="minor">
-            <a:schemeClr val="lt1"/>
-          </a:fontRef>
-        </p:style>
-        <p:txBody>
-          <a:bodyPr rtlCol="0" anchor="ctr"/>
-          <a:lstStyle/>
-          <a:p>
-            <a:pPr algn="ctr"/>
-          </a:p>
-        </p:txBody>
-      </p:sp>
-      <p:sp>
-        <p:nvSpPr>
-          <p:cNvPr id="20" name="Oval 19"/>
-          <p:cNvSpPr/>
-          <p:nvPr/>
-        </p:nvSpPr>
-        <p:spPr>
-          <a:xfrm>
-            <a:off x="6428231" y="4361688"/>
-            <a:ext cx="457200" cy="457200"/>
-          </a:xfrm>
-          <a:prstGeom prst="ellipse">
-            <a:avLst/>
-          </a:prstGeom>
-          <a:solidFill>
-            <a:srgbClr val="1A3A5C"/>
-          </a:solidFill>
-          <a:ln>
-            <a:noFill/>
-          </a:ln>
-          <a:effectLst/>
-        </p:spPr>
-        <p:style>
-          <a:lnRef idx="1">
-            <a:schemeClr val="accent1"/>
-          </a:lnRef>
-          <a:fillRef idx="3">
-            <a:schemeClr val="accent1"/>
-          </a:fillRef>
-          <a:effectRef idx="2">
-            <a:schemeClr val="accent1"/>
-          </a:effectRef>
-          <a:fontRef idx="minor">
-            <a:schemeClr val="lt1"/>
-          </a:fontRef>
-        </p:style>
-        <p:txBody>
-          <a:bodyPr rtlCol="0" anchor="ctr"/>
-          <a:lstStyle/>
-          <a:p>
-            <a:pPr algn="ctr"/>
-            <a:r>
-              <a:rPr sz="1600" b="1">
-                <a:solidFill>
-                  <a:srgbClr val="FFFFFF"/>
-                </a:solidFill>
-                <a:latin typeface="Calibri"/>
-              </a:rPr>
-              <a:t>D</a:t>
-            </a:r>
-          </a:p>
-        </p:txBody>
-      </p:sp>
-      <p:sp>
-        <p:nvSpPr>
-          <p:cNvPr id="21" name="TextBox 20"/>
-          <p:cNvSpPr txBox="1"/>
-          <p:nvPr/>
-        </p:nvSpPr>
-        <p:spPr>
-          <a:xfrm>
-            <a:off x="7040879" y="4206240"/>
-            <a:ext cx="4389120" cy="777240"/>
-          </a:xfrm>
-          <a:prstGeom prst="rect">
-            <a:avLst/>
-          </a:prstGeom>
-          <a:noFill/>
-        </p:spPr>
-        <p:txBody>
-          <a:bodyPr wrap="square" anchor="ctr">
-            <a:spAutoFit/>
-          </a:bodyPr>
-          <a:lstStyle/>
-          <a:p>
-            <a:pPr algn="l"/>
-            <a:r>
-              <a:rPr sz="1400" b="0" i="0">
-                <a:solidFill>
-                  <a:srgbClr val="1A3A5C"/>
-                </a:solidFill>
-                <a:latin typeface="Calibri"/>
-              </a:rPr>
-              <a:t>Faire une glissade pour perdre la hauteur en excès et poser normalement</a:t>
-            </a:r>
-          </a:p>
-        </p:txBody>
-      </p:sp>
-      <p:sp>
-        <p:nvSpPr>
-          <p:cNvPr id="22" name="TextBox 21"/>
-          <p:cNvSpPr txBox="1"/>
-          <p:nvPr/>
-        </p:nvSpPr>
-        <p:spPr>
-          <a:xfrm>
-            <a:off x="640080" y="5349240"/>
-            <a:ext cx="10058400" cy="822960"/>
+            <a:off x="548640" y="1188720"/>
+            <a:ext cx="10881360" cy="5120640"/>
           </a:xfrm>
           <a:prstGeom prst="rect">
             <a:avLst/>
@@ -12657,15 +12598,147 @@
           </a:bodyPr>
           <a:lstStyle/>
           <a:p>
-            <a:pPr algn="l"/>
-            <a:r>
-              <a:rPr sz="1200" b="0" i="1">
-                <a:solidFill>
-                  <a:srgbClr val="6B7A8C"/>
-                </a:solidFill>
-                <a:latin typeface="Calibri"/>
-              </a:rPr>
-              <a:t>Correction : deux paramètres hors tolérance à la porte de décision. Rattraper en finale courte, c'est exactement le scénario des trois cas BEA. La réponse B est la seule qui restaure les marges.</a:t>
+            <a:pPr>
+              <a:spcAft>
+                <a:spcPts val="900"/>
+              </a:spcAft>
+            </a:pPr>
+            <a:r>
+              <a:rPr sz="2000" b="1">
+                <a:solidFill>
+                  <a:srgbClr val="1A3A5C"/>
+                </a:solidFill>
+                <a:latin typeface="Calibri"/>
+              </a:rPr>
+              <a:t>▸  Notre piste 11/29 : 2 100 m revêtue, PAPI aux deux seuils, turbulence possible aux seuils</a:t>
+            </a:r>
+          </a:p>
+          <a:p>
+            <a:pPr>
+              <a:spcAft>
+                <a:spcPts val="900"/>
+              </a:spcAft>
+            </a:pPr>
+            <a:r>
+              <a:rPr sz="1500">
+                <a:solidFill>
+                  <a:srgbClr val="5A6A7E"/>
+                </a:solidFill>
+                <a:latin typeface="Calibri Light"/>
+              </a:rPr>
+              <a:t>       Repère de remise de gaz à définir ensemble pour chaque QFU : un point visible depuis le cockpit (bretelle, hangars) avant lequel les roues doivent être au sol.</a:t>
+            </a:r>
+          </a:p>
+          <a:p>
+            <a:pPr>
+              <a:spcAft>
+                <a:spcPts val="900"/>
+              </a:spcAft>
+            </a:pPr>
+            <a:r>
+              <a:rPr sz="2000" b="1">
+                <a:solidFill>
+                  <a:srgbClr val="1A3A5C"/>
+                </a:solidFill>
+                <a:latin typeface="Calibri"/>
+              </a:rPr>
+              <a:t>▸  Nos terrains de navigation habituels de moins de 800 m</a:t>
+            </a:r>
+          </a:p>
+          <a:p>
+            <a:pPr>
+              <a:spcAft>
+                <a:spcPts val="900"/>
+              </a:spcAft>
+            </a:pPr>
+            <a:r>
+              <a:rPr sz="1500">
+                <a:solidFill>
+                  <a:srgbClr val="5A6A7E"/>
+                </a:solidFill>
+                <a:latin typeface="Calibri Light"/>
+              </a:rPr>
+              <a:t>       [À compléter : liste des terrains courts fréquentés par le club, avec leurs particularités VAC.]</a:t>
+            </a:r>
+          </a:p>
+          <a:p>
+            <a:pPr>
+              <a:spcAft>
+                <a:spcPts val="900"/>
+              </a:spcAft>
+            </a:pPr>
+            <a:r>
+              <a:rPr sz="2000" b="1">
+                <a:solidFill>
+                  <a:srgbClr val="1A3A5C"/>
+                </a:solidFill>
+                <a:latin typeface="Calibri"/>
+              </a:rPr>
+              <a:t>▸  Exercice au tableau : distance d'atterrissage majorée</a:t>
+            </a:r>
+          </a:p>
+          <a:p>
+            <a:pPr>
+              <a:spcAft>
+                <a:spcPts val="900"/>
+              </a:spcAft>
+            </a:pPr>
+            <a:r>
+              <a:rPr sz="1500">
+                <a:solidFill>
+                  <a:srgbClr val="5A6A7E"/>
+                </a:solidFill>
+                <a:latin typeface="Calibri Light"/>
+              </a:rPr>
+              <a:t>       Distance manuel (piste dure, sèche, vent nul) × herbe × mouillée × vent arrière × marge personnelle = ?</a:t>
+            </a:r>
+          </a:p>
+          <a:p>
+            <a:pPr>
+              <a:spcAft>
+                <a:spcPts val="900"/>
+              </a:spcAft>
+            </a:pPr>
+            <a:r>
+              <a:rPr sz="1500">
+                <a:solidFill>
+                  <a:srgbClr val="5A6A7E"/>
+                </a:solidFill>
+                <a:latin typeface="Calibri Light"/>
+              </a:rPr>
+              <a:t>       Comparer le résultat à la longueur de piste. Si l'écart est faible, le terrain est hors limites ce jour-là.</a:t>
+            </a:r>
+          </a:p>
+          <a:p>
+            <a:pPr>
+              <a:spcAft>
+                <a:spcPts val="900"/>
+              </a:spcAft>
+            </a:pPr>
+            <a:r>
+              <a:rPr sz="2000" b="1">
+                <a:solidFill>
+                  <a:srgbClr val="1A3A5C"/>
+                </a:solidFill>
+                <a:latin typeface="Calibri"/>
+              </a:rPr>
+              <a:t>▸  Engagement de séance</a:t>
+            </a:r>
+          </a:p>
+          <a:p>
+            <a:pPr>
+              <a:spcAft>
+                <a:spcPts val="900"/>
+              </a:spcAft>
+            </a:pPr>
+            <a:r>
+              <a:rPr sz="1500">
+                <a:solidFill>
+                  <a:srgbClr val="5A6A7E"/>
+                </a:solidFill>
+                <a:latin typeface="Calibri Light"/>
+              </a:rPr>
+              <a:t>       Chacun repart avec une valeur de distance pour son avion habituel et un repère de remise de gaz sur notre piste principale.</a:t>
             </a:r>
           </a:p>
         </p:txBody>
@@ -12814,7 +12887,7 @@
                 </a:solidFill>
                 <a:latin typeface="Calibri Light"/>
               </a:rPr>
-              <a:t>Pour le débat</a:t>
+              <a:t>Question de révision</a:t>
             </a:r>
           </a:p>
         </p:txBody>
@@ -12959,14 +13032,595 @@
       </p:sp>
       <p:sp>
         <p:nvSpPr>
-          <p:cNvPr id="9" name="TextBox 8"/>
+          <p:cNvPr id="9" name="Rectangle 8"/>
+          <p:cNvSpPr/>
+          <p:nvPr/>
+        </p:nvSpPr>
+        <p:spPr>
+          <a:xfrm>
+            <a:off x="640080" y="1325880"/>
+            <a:ext cx="10881360" cy="1005840"/>
+          </a:xfrm>
+          <a:prstGeom prst="rect">
+            <a:avLst/>
+          </a:prstGeom>
+          <a:solidFill>
+            <a:srgbClr val="D2EBF8"/>
+          </a:solidFill>
+          <a:ln>
+            <a:noFill/>
+          </a:ln>
+          <a:effectLst/>
+        </p:spPr>
+        <p:style>
+          <a:lnRef idx="1">
+            <a:schemeClr val="accent1"/>
+          </a:lnRef>
+          <a:fillRef idx="3">
+            <a:schemeClr val="accent1"/>
+          </a:fillRef>
+          <a:effectRef idx="2">
+            <a:schemeClr val="accent1"/>
+          </a:effectRef>
+          <a:fontRef idx="minor">
+            <a:schemeClr val="lt1"/>
+          </a:fontRef>
+        </p:style>
+        <p:txBody>
+          <a:bodyPr rtlCol="0" anchor="ctr" wrap="square" lIns="228600"/>
+          <a:lstStyle/>
+          <a:p>
+            <a:pPr algn="ctr"/>
+            <a:r>
+              <a:rPr sz="1800" b="1">
+                <a:solidFill>
+                  <a:srgbClr val="1A3A5C"/>
+                </a:solidFill>
+                <a:latin typeface="Calibri"/>
+              </a:rPr>
+              <a:t>Finale sur une piste en herbe de 750 m. À 300 ft sol, vous êtes à Vref + 15 kt et légèrement au-dessus du plan. Que faites-vous ?</a:t>
+            </a:r>
+          </a:p>
+        </p:txBody>
+      </p:sp>
+      <p:sp>
+        <p:nvSpPr>
+          <p:cNvPr id="10" name="Rectangle 9"/>
+          <p:cNvSpPr/>
+          <p:nvPr/>
+        </p:nvSpPr>
+        <p:spPr>
+          <a:xfrm>
+            <a:off x="640080" y="2697480"/>
+            <a:ext cx="5257800" cy="1051560"/>
+          </a:xfrm>
+          <a:prstGeom prst="rect">
+            <a:avLst/>
+          </a:prstGeom>
+          <a:solidFill>
+            <a:srgbClr val="F5F7FA"/>
+          </a:solidFill>
+          <a:ln>
+            <a:noFill/>
+          </a:ln>
+          <a:effectLst/>
+        </p:spPr>
+        <p:style>
+          <a:lnRef idx="1">
+            <a:schemeClr val="accent1"/>
+          </a:lnRef>
+          <a:fillRef idx="3">
+            <a:schemeClr val="accent1"/>
+          </a:fillRef>
+          <a:effectRef idx="2">
+            <a:schemeClr val="accent1"/>
+          </a:effectRef>
+          <a:fontRef idx="minor">
+            <a:schemeClr val="lt1"/>
+          </a:fontRef>
+        </p:style>
+        <p:txBody>
+          <a:bodyPr rtlCol="0" anchor="ctr"/>
+          <a:lstStyle/>
+          <a:p>
+            <a:pPr algn="ctr"/>
+          </a:p>
+        </p:txBody>
+      </p:sp>
+      <p:sp>
+        <p:nvSpPr>
+          <p:cNvPr id="11" name="Oval 10"/>
+          <p:cNvSpPr/>
+          <p:nvPr/>
+        </p:nvSpPr>
+        <p:spPr>
+          <a:xfrm>
+            <a:off x="804671" y="2990088"/>
+            <a:ext cx="457200" cy="457200"/>
+          </a:xfrm>
+          <a:prstGeom prst="ellipse">
+            <a:avLst/>
+          </a:prstGeom>
+          <a:solidFill>
+            <a:srgbClr val="1A3A5C"/>
+          </a:solidFill>
+          <a:ln>
+            <a:noFill/>
+          </a:ln>
+          <a:effectLst/>
+        </p:spPr>
+        <p:style>
+          <a:lnRef idx="1">
+            <a:schemeClr val="accent1"/>
+          </a:lnRef>
+          <a:fillRef idx="3">
+            <a:schemeClr val="accent1"/>
+          </a:fillRef>
+          <a:effectRef idx="2">
+            <a:schemeClr val="accent1"/>
+          </a:effectRef>
+          <a:fontRef idx="minor">
+            <a:schemeClr val="lt1"/>
+          </a:fontRef>
+        </p:style>
+        <p:txBody>
+          <a:bodyPr rtlCol="0" anchor="ctr"/>
+          <a:lstStyle/>
+          <a:p>
+            <a:pPr algn="ctr"/>
+            <a:r>
+              <a:rPr sz="1600" b="1">
+                <a:solidFill>
+                  <a:srgbClr val="FFFFFF"/>
+                </a:solidFill>
+                <a:latin typeface="Calibri"/>
+              </a:rPr>
+              <a:t>A</a:t>
+            </a:r>
+          </a:p>
+        </p:txBody>
+      </p:sp>
+      <p:sp>
+        <p:nvSpPr>
+          <p:cNvPr id="12" name="TextBox 11"/>
           <p:cNvSpPr txBox="1"/>
           <p:nvPr/>
         </p:nvSpPr>
         <p:spPr>
           <a:xfrm>
-            <a:off x="548640" y="1280160"/>
-            <a:ext cx="10881360" cy="4937760"/>
+            <a:off x="1417319" y="2834640"/>
+            <a:ext cx="4389120" cy="777240"/>
+          </a:xfrm>
+          <a:prstGeom prst="rect">
+            <a:avLst/>
+          </a:prstGeom>
+          <a:noFill/>
+        </p:spPr>
+        <p:txBody>
+          <a:bodyPr wrap="square" anchor="ctr">
+            <a:spAutoFit/>
+          </a:bodyPr>
+          <a:lstStyle/>
+          <a:p>
+            <a:pPr algn="l"/>
+            <a:r>
+              <a:rPr sz="1400" b="0" i="0">
+                <a:solidFill>
+                  <a:srgbClr val="1A3A5C"/>
+                </a:solidFill>
+                <a:latin typeface="Calibri"/>
+              </a:rPr>
+              <a:t>Réduire les gaz, sortir le dernier cran de volets et rattraper le plan avant l'arrondi</a:t>
+            </a:r>
+          </a:p>
+        </p:txBody>
+      </p:sp>
+      <p:sp>
+        <p:nvSpPr>
+          <p:cNvPr id="13" name="Rectangle 12"/>
+          <p:cNvSpPr/>
+          <p:nvPr/>
+        </p:nvSpPr>
+        <p:spPr>
+          <a:xfrm>
+            <a:off x="6263640" y="2697480"/>
+            <a:ext cx="5257800" cy="1051560"/>
+          </a:xfrm>
+          <a:prstGeom prst="rect">
+            <a:avLst/>
+          </a:prstGeom>
+          <a:solidFill>
+            <a:srgbClr val="E3F1E8"/>
+          </a:solidFill>
+          <a:ln>
+            <a:noFill/>
+          </a:ln>
+          <a:effectLst/>
+        </p:spPr>
+        <p:style>
+          <a:lnRef idx="1">
+            <a:schemeClr val="accent1"/>
+          </a:lnRef>
+          <a:fillRef idx="3">
+            <a:schemeClr val="accent1"/>
+          </a:fillRef>
+          <a:effectRef idx="2">
+            <a:schemeClr val="accent1"/>
+          </a:effectRef>
+          <a:fontRef idx="minor">
+            <a:schemeClr val="lt1"/>
+          </a:fontRef>
+        </p:style>
+        <p:txBody>
+          <a:bodyPr rtlCol="0" anchor="ctr"/>
+          <a:lstStyle/>
+          <a:p>
+            <a:pPr algn="ctr"/>
+          </a:p>
+        </p:txBody>
+      </p:sp>
+      <p:sp>
+        <p:nvSpPr>
+          <p:cNvPr id="14" name="Oval 13"/>
+          <p:cNvSpPr/>
+          <p:nvPr/>
+        </p:nvSpPr>
+        <p:spPr>
+          <a:xfrm>
+            <a:off x="6428231" y="2990088"/>
+            <a:ext cx="457200" cy="457200"/>
+          </a:xfrm>
+          <a:prstGeom prst="ellipse">
+            <a:avLst/>
+          </a:prstGeom>
+          <a:solidFill>
+            <a:srgbClr val="2E7D4F"/>
+          </a:solidFill>
+          <a:ln>
+            <a:noFill/>
+          </a:ln>
+          <a:effectLst/>
+        </p:spPr>
+        <p:style>
+          <a:lnRef idx="1">
+            <a:schemeClr val="accent1"/>
+          </a:lnRef>
+          <a:fillRef idx="3">
+            <a:schemeClr val="accent1"/>
+          </a:fillRef>
+          <a:effectRef idx="2">
+            <a:schemeClr val="accent1"/>
+          </a:effectRef>
+          <a:fontRef idx="minor">
+            <a:schemeClr val="lt1"/>
+          </a:fontRef>
+        </p:style>
+        <p:txBody>
+          <a:bodyPr rtlCol="0" anchor="ctr"/>
+          <a:lstStyle/>
+          <a:p>
+            <a:pPr algn="ctr"/>
+            <a:r>
+              <a:rPr sz="1600" b="1">
+                <a:solidFill>
+                  <a:srgbClr val="FFFFFF"/>
+                </a:solidFill>
+                <a:latin typeface="Calibri"/>
+              </a:rPr>
+              <a:t>B</a:t>
+            </a:r>
+          </a:p>
+        </p:txBody>
+      </p:sp>
+      <p:sp>
+        <p:nvSpPr>
+          <p:cNvPr id="15" name="TextBox 14"/>
+          <p:cNvSpPr txBox="1"/>
+          <p:nvPr/>
+        </p:nvSpPr>
+        <p:spPr>
+          <a:xfrm>
+            <a:off x="7040879" y="2834640"/>
+            <a:ext cx="4389120" cy="777240"/>
+          </a:xfrm>
+          <a:prstGeom prst="rect">
+            <a:avLst/>
+          </a:prstGeom>
+          <a:noFill/>
+        </p:spPr>
+        <p:txBody>
+          <a:bodyPr wrap="square" anchor="ctr">
+            <a:spAutoFit/>
+          </a:bodyPr>
+          <a:lstStyle/>
+          <a:p>
+            <a:pPr algn="l"/>
+            <a:r>
+              <a:rPr sz="1400" b="1" i="0">
+                <a:solidFill>
+                  <a:srgbClr val="2E7D4F"/>
+                </a:solidFill>
+                <a:latin typeface="Calibri"/>
+              </a:rPr>
+              <a:t>Remettre les gaz maintenant, refaire un tour de piste complet et une finale stabilisée</a:t>
+            </a:r>
+          </a:p>
+        </p:txBody>
+      </p:sp>
+      <p:sp>
+        <p:nvSpPr>
+          <p:cNvPr id="16" name="Rectangle 15"/>
+          <p:cNvSpPr/>
+          <p:nvPr/>
+        </p:nvSpPr>
+        <p:spPr>
+          <a:xfrm>
+            <a:off x="640080" y="4069080"/>
+            <a:ext cx="5257800" cy="1051560"/>
+          </a:xfrm>
+          <a:prstGeom prst="rect">
+            <a:avLst/>
+          </a:prstGeom>
+          <a:solidFill>
+            <a:srgbClr val="F5F7FA"/>
+          </a:solidFill>
+          <a:ln>
+            <a:noFill/>
+          </a:ln>
+          <a:effectLst/>
+        </p:spPr>
+        <p:style>
+          <a:lnRef idx="1">
+            <a:schemeClr val="accent1"/>
+          </a:lnRef>
+          <a:fillRef idx="3">
+            <a:schemeClr val="accent1"/>
+          </a:fillRef>
+          <a:effectRef idx="2">
+            <a:schemeClr val="accent1"/>
+          </a:effectRef>
+          <a:fontRef idx="minor">
+            <a:schemeClr val="lt1"/>
+          </a:fontRef>
+        </p:style>
+        <p:txBody>
+          <a:bodyPr rtlCol="0" anchor="ctr"/>
+          <a:lstStyle/>
+          <a:p>
+            <a:pPr algn="ctr"/>
+          </a:p>
+        </p:txBody>
+      </p:sp>
+      <p:sp>
+        <p:nvSpPr>
+          <p:cNvPr id="17" name="Oval 16"/>
+          <p:cNvSpPr/>
+          <p:nvPr/>
+        </p:nvSpPr>
+        <p:spPr>
+          <a:xfrm>
+            <a:off x="804671" y="4361688"/>
+            <a:ext cx="457200" cy="457200"/>
+          </a:xfrm>
+          <a:prstGeom prst="ellipse">
+            <a:avLst/>
+          </a:prstGeom>
+          <a:solidFill>
+            <a:srgbClr val="1A3A5C"/>
+          </a:solidFill>
+          <a:ln>
+            <a:noFill/>
+          </a:ln>
+          <a:effectLst/>
+        </p:spPr>
+        <p:style>
+          <a:lnRef idx="1">
+            <a:schemeClr val="accent1"/>
+          </a:lnRef>
+          <a:fillRef idx="3">
+            <a:schemeClr val="accent1"/>
+          </a:fillRef>
+          <a:effectRef idx="2">
+            <a:schemeClr val="accent1"/>
+          </a:effectRef>
+          <a:fontRef idx="minor">
+            <a:schemeClr val="lt1"/>
+          </a:fontRef>
+        </p:style>
+        <p:txBody>
+          <a:bodyPr rtlCol="0" anchor="ctr"/>
+          <a:lstStyle/>
+          <a:p>
+            <a:pPr algn="ctr"/>
+            <a:r>
+              <a:rPr sz="1600" b="1">
+                <a:solidFill>
+                  <a:srgbClr val="FFFFFF"/>
+                </a:solidFill>
+                <a:latin typeface="Calibri"/>
+              </a:rPr>
+              <a:t>C</a:t>
+            </a:r>
+          </a:p>
+        </p:txBody>
+      </p:sp>
+      <p:sp>
+        <p:nvSpPr>
+          <p:cNvPr id="18" name="TextBox 17"/>
+          <p:cNvSpPr txBox="1"/>
+          <p:nvPr/>
+        </p:nvSpPr>
+        <p:spPr>
+          <a:xfrm>
+            <a:off x="1417319" y="4206240"/>
+            <a:ext cx="4389120" cy="777240"/>
+          </a:xfrm>
+          <a:prstGeom prst="rect">
+            <a:avLst/>
+          </a:prstGeom>
+          <a:noFill/>
+        </p:spPr>
+        <p:txBody>
+          <a:bodyPr wrap="square" anchor="ctr">
+            <a:spAutoFit/>
+          </a:bodyPr>
+          <a:lstStyle/>
+          <a:p>
+            <a:pPr algn="l"/>
+            <a:r>
+              <a:rPr sz="1400" b="0" i="0">
+                <a:solidFill>
+                  <a:srgbClr val="1A3A5C"/>
+                </a:solidFill>
+                <a:latin typeface="Calibri"/>
+              </a:rPr>
+              <a:t>Continuer, poser dans le premier tiers et freiner énergiquement</a:t>
+            </a:r>
+          </a:p>
+        </p:txBody>
+      </p:sp>
+      <p:sp>
+        <p:nvSpPr>
+          <p:cNvPr id="19" name="Rectangle 18"/>
+          <p:cNvSpPr/>
+          <p:nvPr/>
+        </p:nvSpPr>
+        <p:spPr>
+          <a:xfrm>
+            <a:off x="6263640" y="4069080"/>
+            <a:ext cx="5257800" cy="1051560"/>
+          </a:xfrm>
+          <a:prstGeom prst="rect">
+            <a:avLst/>
+          </a:prstGeom>
+          <a:solidFill>
+            <a:srgbClr val="F5F7FA"/>
+          </a:solidFill>
+          <a:ln>
+            <a:noFill/>
+          </a:ln>
+          <a:effectLst/>
+        </p:spPr>
+        <p:style>
+          <a:lnRef idx="1">
+            <a:schemeClr val="accent1"/>
+          </a:lnRef>
+          <a:fillRef idx="3">
+            <a:schemeClr val="accent1"/>
+          </a:fillRef>
+          <a:effectRef idx="2">
+            <a:schemeClr val="accent1"/>
+          </a:effectRef>
+          <a:fontRef idx="minor">
+            <a:schemeClr val="lt1"/>
+          </a:fontRef>
+        </p:style>
+        <p:txBody>
+          <a:bodyPr rtlCol="0" anchor="ctr"/>
+          <a:lstStyle/>
+          <a:p>
+            <a:pPr algn="ctr"/>
+          </a:p>
+        </p:txBody>
+      </p:sp>
+      <p:sp>
+        <p:nvSpPr>
+          <p:cNvPr id="20" name="Oval 19"/>
+          <p:cNvSpPr/>
+          <p:nvPr/>
+        </p:nvSpPr>
+        <p:spPr>
+          <a:xfrm>
+            <a:off x="6428231" y="4361688"/>
+            <a:ext cx="457200" cy="457200"/>
+          </a:xfrm>
+          <a:prstGeom prst="ellipse">
+            <a:avLst/>
+          </a:prstGeom>
+          <a:solidFill>
+            <a:srgbClr val="1A3A5C"/>
+          </a:solidFill>
+          <a:ln>
+            <a:noFill/>
+          </a:ln>
+          <a:effectLst/>
+        </p:spPr>
+        <p:style>
+          <a:lnRef idx="1">
+            <a:schemeClr val="accent1"/>
+          </a:lnRef>
+          <a:fillRef idx="3">
+            <a:schemeClr val="accent1"/>
+          </a:fillRef>
+          <a:effectRef idx="2">
+            <a:schemeClr val="accent1"/>
+          </a:effectRef>
+          <a:fontRef idx="minor">
+            <a:schemeClr val="lt1"/>
+          </a:fontRef>
+        </p:style>
+        <p:txBody>
+          <a:bodyPr rtlCol="0" anchor="ctr"/>
+          <a:lstStyle/>
+          <a:p>
+            <a:pPr algn="ctr"/>
+            <a:r>
+              <a:rPr sz="1600" b="1">
+                <a:solidFill>
+                  <a:srgbClr val="FFFFFF"/>
+                </a:solidFill>
+                <a:latin typeface="Calibri"/>
+              </a:rPr>
+              <a:t>D</a:t>
+            </a:r>
+          </a:p>
+        </p:txBody>
+      </p:sp>
+      <p:sp>
+        <p:nvSpPr>
+          <p:cNvPr id="21" name="TextBox 20"/>
+          <p:cNvSpPr txBox="1"/>
+          <p:nvPr/>
+        </p:nvSpPr>
+        <p:spPr>
+          <a:xfrm>
+            <a:off x="7040879" y="4206240"/>
+            <a:ext cx="4389120" cy="777240"/>
+          </a:xfrm>
+          <a:prstGeom prst="rect">
+            <a:avLst/>
+          </a:prstGeom>
+          <a:noFill/>
+        </p:spPr>
+        <p:txBody>
+          <a:bodyPr wrap="square" anchor="ctr">
+            <a:spAutoFit/>
+          </a:bodyPr>
+          <a:lstStyle/>
+          <a:p>
+            <a:pPr algn="l"/>
+            <a:r>
+              <a:rPr sz="1400" b="0" i="0">
+                <a:solidFill>
+                  <a:srgbClr val="1A3A5C"/>
+                </a:solidFill>
+                <a:latin typeface="Calibri"/>
+              </a:rPr>
+              <a:t>Faire une glissade pour perdre la hauteur en excès et poser normalement</a:t>
+            </a:r>
+          </a:p>
+        </p:txBody>
+      </p:sp>
+      <p:sp>
+        <p:nvSpPr>
+          <p:cNvPr id="22" name="TextBox 21"/>
+          <p:cNvSpPr txBox="1"/>
+          <p:nvPr/>
+        </p:nvSpPr>
+        <p:spPr>
+          <a:xfrm>
+            <a:off x="640080" y="5349240"/>
+            <a:ext cx="10058400" cy="822960"/>
           </a:xfrm>
           <a:prstGeom prst="rect">
             <a:avLst/>
@@ -12979,99 +13633,15 @@
           </a:bodyPr>
           <a:lstStyle/>
           <a:p>
-            <a:pPr>
-              <a:spcAft>
-                <a:spcPts val="1800"/>
-              </a:spcAft>
-            </a:pPr>
-            <a:r>
-              <a:rPr sz="2200" b="1">
-                <a:solidFill>
-                  <a:srgbClr val="1A3A5C"/>
-                </a:solidFill>
-                <a:latin typeface="Calibri"/>
-              </a:rPr>
-              <a:t>▸  Qui a déjà continué un atterrissage qu'il aurait dû abandonner ? Pourquoi ?</a:t>
-            </a:r>
-          </a:p>
-          <a:p>
-            <a:pPr>
-              <a:spcAft>
-                <a:spcPts val="1800"/>
-              </a:spcAft>
-            </a:pPr>
-            <a:r>
-              <a:rPr sz="1600">
-                <a:solidFill>
-                  <a:srgbClr val="5A6A7E"/>
-                </a:solidFill>
-                <a:latin typeface="Calibri Light"/>
-              </a:rPr>
-              <a:t>       Sans jugement : la fatigue, l'orgueil, la présence d'un passager, le « ça va passer » sont des facteurs partagés par tous.</a:t>
-            </a:r>
-          </a:p>
-          <a:p>
-            <a:pPr>
-              <a:spcAft>
-                <a:spcPts val="1800"/>
-              </a:spcAft>
-            </a:pPr>
-            <a:r>
-              <a:rPr sz="2200" b="1">
-                <a:solidFill>
-                  <a:srgbClr val="1A3A5C"/>
-                </a:solidFill>
-                <a:latin typeface="Calibri"/>
-              </a:rPr>
-              <a:t>▸  Que se passe-t-il au club après une remise de gaz ?</a:t>
-            </a:r>
-          </a:p>
-          <a:p>
-            <a:pPr>
-              <a:spcAft>
-                <a:spcPts val="1800"/>
-              </a:spcAft>
-            </a:pPr>
-            <a:r>
-              <a:rPr sz="1600">
-                <a:solidFill>
-                  <a:srgbClr val="5A6A7E"/>
-                </a:solidFill>
-                <a:latin typeface="Calibri Light"/>
-              </a:rPr>
-              <a:t>       Est-elle vue comme un échec ou comme une bonne décision ? La culture du club influence la décision en finale.</a:t>
-            </a:r>
-          </a:p>
-          <a:p>
-            <a:pPr>
-              <a:spcAft>
-                <a:spcPts val="1800"/>
-              </a:spcAft>
-            </a:pPr>
-            <a:r>
-              <a:rPr sz="2200" b="1">
-                <a:solidFill>
-                  <a:srgbClr val="1A3A5C"/>
-                </a:solidFill>
-                <a:latin typeface="Calibri"/>
-              </a:rPr>
-              <a:t>▸  Quels terrains de nos navigations méritent une préparation particulière ?</a:t>
-            </a:r>
-          </a:p>
-          <a:p>
-            <a:pPr>
-              <a:spcAft>
-                <a:spcPts val="1800"/>
-              </a:spcAft>
-            </a:pPr>
-            <a:r>
-              <a:rPr sz="1600">
-                <a:solidFill>
-                  <a:srgbClr val="5A6A7E"/>
-                </a:solidFill>
-                <a:latin typeface="Calibri Light"/>
-              </a:rPr>
-              <a:t>       Pente, bosse, relief, QFU imposé, herbe : les repérer maintenant, pas au moment de s'y poser.</a:t>
+            <a:pPr algn="l"/>
+            <a:r>
+              <a:rPr sz="1200" b="0" i="1">
+                <a:solidFill>
+                  <a:srgbClr val="6B7A8C"/>
+                </a:solidFill>
+                <a:latin typeface="Calibri"/>
+              </a:rPr>
+              <a:t>Correction : deux paramètres hors tolérance à la porte de décision. Rattraper en finale courte, c'est exactement le scénario des trois cas BEA. La réponse B est la seule qui restaure les marges.</a:t>
             </a:r>
           </a:p>
         </p:txBody>
@@ -13085,6 +13655,412 @@
 </file>
 
 <file path=ppt/slides/slide22.xml><?xml version="1.0" encoding="utf-8"?>
+<p:sld xmlns:a="http://schemas.openxmlformats.org/drawingml/2006/main" xmlns:p="http://schemas.openxmlformats.org/presentationml/2006/main" xmlns:r="http://schemas.openxmlformats.org/officeDocument/2006/relationships">
+  <p:cSld>
+    <p:bg>
+      <p:bgPr>
+        <a:solidFill>
+          <a:srgbClr val="FFFFFF"/>
+        </a:solidFill>
+        <a:effectLst/>
+      </p:bgPr>
+    </p:bg>
+    <p:spTree>
+      <p:nvGrpSpPr>
+        <p:cNvPr id="1" name=""/>
+        <p:cNvGrpSpPr/>
+        <p:nvPr/>
+      </p:nvGrpSpPr>
+      <p:grpSpPr/>
+      <p:sp>
+        <p:nvSpPr>
+          <p:cNvPr id="2" name="Rectangle 1"/>
+          <p:cNvSpPr/>
+          <p:nvPr/>
+        </p:nvSpPr>
+        <p:spPr>
+          <a:xfrm>
+            <a:off x="0" y="0"/>
+            <a:ext cx="12188952" cy="960120"/>
+          </a:xfrm>
+          <a:prstGeom prst="rect">
+            <a:avLst/>
+          </a:prstGeom>
+          <a:solidFill>
+            <a:srgbClr val="1A3A5C"/>
+          </a:solidFill>
+          <a:ln>
+            <a:noFill/>
+          </a:ln>
+          <a:effectLst/>
+        </p:spPr>
+        <p:style>
+          <a:lnRef idx="1">
+            <a:schemeClr val="accent1"/>
+          </a:lnRef>
+          <a:fillRef idx="3">
+            <a:schemeClr val="accent1"/>
+          </a:fillRef>
+          <a:effectRef idx="2">
+            <a:schemeClr val="accent1"/>
+          </a:effectRef>
+          <a:fontRef idx="minor">
+            <a:schemeClr val="lt1"/>
+          </a:fontRef>
+        </p:style>
+        <p:txBody>
+          <a:bodyPr rtlCol="0" anchor="ctr"/>
+          <a:lstStyle/>
+          <a:p>
+            <a:pPr algn="ctr"/>
+          </a:p>
+        </p:txBody>
+      </p:sp>
+      <p:sp>
+        <p:nvSpPr>
+          <p:cNvPr id="3" name="Rectangle 2"/>
+          <p:cNvSpPr/>
+          <p:nvPr/>
+        </p:nvSpPr>
+        <p:spPr>
+          <a:xfrm>
+            <a:off x="0" y="960120"/>
+            <a:ext cx="12188952" cy="54864"/>
+          </a:xfrm>
+          <a:prstGeom prst="rect">
+            <a:avLst/>
+          </a:prstGeom>
+          <a:solidFill>
+            <a:srgbClr val="4A9ED6"/>
+          </a:solidFill>
+          <a:ln>
+            <a:noFill/>
+          </a:ln>
+          <a:effectLst/>
+        </p:spPr>
+        <p:style>
+          <a:lnRef idx="1">
+            <a:schemeClr val="accent1"/>
+          </a:lnRef>
+          <a:fillRef idx="3">
+            <a:schemeClr val="accent1"/>
+          </a:fillRef>
+          <a:effectRef idx="2">
+            <a:schemeClr val="accent1"/>
+          </a:effectRef>
+          <a:fontRef idx="minor">
+            <a:schemeClr val="lt1"/>
+          </a:fontRef>
+        </p:style>
+        <p:txBody>
+          <a:bodyPr rtlCol="0" anchor="ctr"/>
+          <a:lstStyle/>
+          <a:p>
+            <a:pPr algn="ctr"/>
+          </a:p>
+        </p:txBody>
+      </p:sp>
+      <p:sp>
+        <p:nvSpPr>
+          <p:cNvPr id="4" name="TextBox 3"/>
+          <p:cNvSpPr txBox="1"/>
+          <p:nvPr/>
+        </p:nvSpPr>
+        <p:spPr>
+          <a:xfrm>
+            <a:off x="457200" y="155448"/>
+            <a:ext cx="11274552" cy="713232"/>
+          </a:xfrm>
+          <a:prstGeom prst="rect">
+            <a:avLst/>
+          </a:prstGeom>
+          <a:noFill/>
+        </p:spPr>
+        <p:txBody>
+          <a:bodyPr wrap="square" anchor="ctr">
+            <a:spAutoFit/>
+          </a:bodyPr>
+          <a:lstStyle/>
+          <a:p>
+            <a:pPr algn="l"/>
+            <a:r>
+              <a:rPr sz="2800" b="1" i="0">
+                <a:solidFill>
+                  <a:srgbClr val="FFFFFF"/>
+                </a:solidFill>
+                <a:latin typeface="Calibri Light"/>
+              </a:rPr>
+              <a:t>Pour le débat</a:t>
+            </a:r>
+          </a:p>
+        </p:txBody>
+      </p:sp>
+      <p:sp>
+        <p:nvSpPr>
+          <p:cNvPr id="5" name="Rectangle 4"/>
+          <p:cNvSpPr/>
+          <p:nvPr/>
+        </p:nvSpPr>
+        <p:spPr>
+          <a:xfrm>
+            <a:off x="0" y="6510528"/>
+            <a:ext cx="12188952" cy="347472"/>
+          </a:xfrm>
+          <a:prstGeom prst="rect">
+            <a:avLst/>
+          </a:prstGeom>
+          <a:solidFill>
+            <a:srgbClr val="1A3A5C"/>
+          </a:solidFill>
+          <a:ln>
+            <a:noFill/>
+          </a:ln>
+          <a:effectLst/>
+        </p:spPr>
+        <p:style>
+          <a:lnRef idx="1">
+            <a:schemeClr val="accent1"/>
+          </a:lnRef>
+          <a:fillRef idx="3">
+            <a:schemeClr val="accent1"/>
+          </a:fillRef>
+          <a:effectRef idx="2">
+            <a:schemeClr val="accent1"/>
+          </a:effectRef>
+          <a:fontRef idx="minor">
+            <a:schemeClr val="lt1"/>
+          </a:fontRef>
+        </p:style>
+        <p:txBody>
+          <a:bodyPr rtlCol="0" anchor="ctr"/>
+          <a:lstStyle/>
+          <a:p>
+            <a:pPr algn="ctr"/>
+          </a:p>
+        </p:txBody>
+      </p:sp>
+      <p:sp>
+        <p:nvSpPr>
+          <p:cNvPr id="6" name="TextBox 5"/>
+          <p:cNvSpPr txBox="1"/>
+          <p:nvPr/>
+        </p:nvSpPr>
+        <p:spPr>
+          <a:xfrm>
+            <a:off x="365760" y="6556248"/>
+            <a:ext cx="8229600" cy="274320"/>
+          </a:xfrm>
+          <a:prstGeom prst="rect">
+            <a:avLst/>
+          </a:prstGeom>
+          <a:noFill/>
+        </p:spPr>
+        <p:txBody>
+          <a:bodyPr wrap="square">
+            <a:spAutoFit/>
+          </a:bodyPr>
+          <a:lstStyle/>
+          <a:p>
+            <a:pPr algn="l"/>
+            <a:r>
+              <a:rPr sz="900" b="0" i="0">
+                <a:solidFill>
+                  <a:srgbClr val="D2EBF8"/>
+                </a:solidFill>
+                <a:latin typeface="Calibri"/>
+              </a:rPr>
+              <a:t>Formation PPL · LAPL  —  Frédéric Vincenot · FI</a:t>
+            </a:r>
+          </a:p>
+        </p:txBody>
+      </p:sp>
+      <p:pic>
+        <p:nvPicPr>
+          <p:cNvPr id="7" name="Picture 6" descr="tampon_fv_gris.png"/>
+          <p:cNvPicPr>
+            <a:picLocks noChangeAspect="1"/>
+          </p:cNvPicPr>
+          <p:nvPr/>
+        </p:nvPicPr>
+        <p:blipFill>
+          <a:blip r:embed="rId2"/>
+          <a:stretch>
+            <a:fillRect/>
+          </a:stretch>
+        </p:blipFill>
+        <p:spPr>
+          <a:xfrm>
+            <a:off x="11274552" y="6108192"/>
+            <a:ext cx="640080" cy="320040"/>
+          </a:xfrm>
+          <a:prstGeom prst="rect">
+            <a:avLst/>
+          </a:prstGeom>
+        </p:spPr>
+      </p:pic>
+      <p:sp>
+        <p:nvSpPr>
+          <p:cNvPr id="8" name="TextBox 7"/>
+          <p:cNvSpPr txBox="1"/>
+          <p:nvPr/>
+        </p:nvSpPr>
+        <p:spPr>
+          <a:xfrm>
+            <a:off x="11686032" y="6556248"/>
+            <a:ext cx="365760" cy="274320"/>
+          </a:xfrm>
+          <a:prstGeom prst="rect">
+            <a:avLst/>
+          </a:prstGeom>
+          <a:noFill/>
+        </p:spPr>
+        <p:txBody>
+          <a:bodyPr wrap="square">
+            <a:spAutoFit/>
+          </a:bodyPr>
+          <a:lstStyle/>
+          <a:p>
+            <a:pPr algn="r"/>
+            <a:r>
+              <a:rPr sz="900" b="0" i="0">
+                <a:solidFill>
+                  <a:srgbClr val="D2EBF8"/>
+                </a:solidFill>
+                <a:latin typeface="Calibri"/>
+              </a:rPr>
+              <a:t>22</a:t>
+            </a:r>
+          </a:p>
+        </p:txBody>
+      </p:sp>
+      <p:sp>
+        <p:nvSpPr>
+          <p:cNvPr id="9" name="TextBox 8"/>
+          <p:cNvSpPr txBox="1"/>
+          <p:nvPr/>
+        </p:nvSpPr>
+        <p:spPr>
+          <a:xfrm>
+            <a:off x="548640" y="1280160"/>
+            <a:ext cx="10881360" cy="4937760"/>
+          </a:xfrm>
+          <a:prstGeom prst="rect">
+            <a:avLst/>
+          </a:prstGeom>
+          <a:noFill/>
+        </p:spPr>
+        <p:txBody>
+          <a:bodyPr wrap="square">
+            <a:spAutoFit/>
+          </a:bodyPr>
+          <a:lstStyle/>
+          <a:p>
+            <a:pPr>
+              <a:spcAft>
+                <a:spcPts val="1800"/>
+              </a:spcAft>
+            </a:pPr>
+            <a:r>
+              <a:rPr sz="2200" b="1">
+                <a:solidFill>
+                  <a:srgbClr val="1A3A5C"/>
+                </a:solidFill>
+                <a:latin typeface="Calibri"/>
+              </a:rPr>
+              <a:t>▸  Qui a déjà continué un atterrissage qu'il aurait dû abandonner ? Pourquoi ?</a:t>
+            </a:r>
+          </a:p>
+          <a:p>
+            <a:pPr>
+              <a:spcAft>
+                <a:spcPts val="1800"/>
+              </a:spcAft>
+            </a:pPr>
+            <a:r>
+              <a:rPr sz="1600">
+                <a:solidFill>
+                  <a:srgbClr val="5A6A7E"/>
+                </a:solidFill>
+                <a:latin typeface="Calibri Light"/>
+              </a:rPr>
+              <a:t>       Sans jugement : la fatigue, l'orgueil, la présence d'un passager, le « ça va passer » sont des facteurs partagés par tous.</a:t>
+            </a:r>
+          </a:p>
+          <a:p>
+            <a:pPr>
+              <a:spcAft>
+                <a:spcPts val="1800"/>
+              </a:spcAft>
+            </a:pPr>
+            <a:r>
+              <a:rPr sz="2200" b="1">
+                <a:solidFill>
+                  <a:srgbClr val="1A3A5C"/>
+                </a:solidFill>
+                <a:latin typeface="Calibri"/>
+              </a:rPr>
+              <a:t>▸  Que se passe-t-il au club après une remise de gaz ?</a:t>
+            </a:r>
+          </a:p>
+          <a:p>
+            <a:pPr>
+              <a:spcAft>
+                <a:spcPts val="1800"/>
+              </a:spcAft>
+            </a:pPr>
+            <a:r>
+              <a:rPr sz="1600">
+                <a:solidFill>
+                  <a:srgbClr val="5A6A7E"/>
+                </a:solidFill>
+                <a:latin typeface="Calibri Light"/>
+              </a:rPr>
+              <a:t>       Est-elle vue comme un échec ou comme une bonne décision ? La culture du club influence la décision en finale.</a:t>
+            </a:r>
+          </a:p>
+          <a:p>
+            <a:pPr>
+              <a:spcAft>
+                <a:spcPts val="1800"/>
+              </a:spcAft>
+            </a:pPr>
+            <a:r>
+              <a:rPr sz="2200" b="1">
+                <a:solidFill>
+                  <a:srgbClr val="1A3A5C"/>
+                </a:solidFill>
+                <a:latin typeface="Calibri"/>
+              </a:rPr>
+              <a:t>▸  Quels terrains de nos navigations méritent une préparation particulière ?</a:t>
+            </a:r>
+          </a:p>
+          <a:p>
+            <a:pPr>
+              <a:spcAft>
+                <a:spcPts val="1800"/>
+              </a:spcAft>
+            </a:pPr>
+            <a:r>
+              <a:rPr sz="1600">
+                <a:solidFill>
+                  <a:srgbClr val="5A6A7E"/>
+                </a:solidFill>
+                <a:latin typeface="Calibri Light"/>
+              </a:rPr>
+              <a:t>       Pente, bosse, relief, QFU imposé, herbe : les repérer maintenant, pas au moment de s'y poser.</a:t>
+            </a:r>
+          </a:p>
+        </p:txBody>
+      </p:sp>
+    </p:spTree>
+  </p:cSld>
+  <p:clrMapOvr>
+    <a:masterClrMapping/>
+  </p:clrMapOvr>
+</p:sld>
+</file>
+
+<file path=ppt/slides/slide23.xml><?xml version="1.0" encoding="utf-8"?>
 <p:sld xmlns:a="http://schemas.openxmlformats.org/drawingml/2006/main" xmlns:p="http://schemas.openxmlformats.org/presentationml/2006/main" xmlns:r="http://schemas.openxmlformats.org/officeDocument/2006/relationships">
   <p:cSld>
     <p:bg>
@@ -13358,7 +14334,7 @@
                 </a:solidFill>
                 <a:latin typeface="Calibri"/>
               </a:rPr>
-              <a:t>22</a:t>
+              <a:t>23</a:t>
             </a:r>
           </a:p>
         </p:txBody>
@@ -13899,7 +14875,7 @@
 </p:sld>
 </file>
 
-<file path=ppt/slides/slide23.xml><?xml version="1.0" encoding="utf-8"?>
+<file path=ppt/slides/slide24.xml><?xml version="1.0" encoding="utf-8"?>
 <p:sld xmlns:a="http://schemas.openxmlformats.org/drawingml/2006/main" xmlns:p="http://schemas.openxmlformats.org/presentationml/2006/main" xmlns:r="http://schemas.openxmlformats.org/officeDocument/2006/relationships">
   <p:cSld>
     <p:bg>
@@ -14173,7 +15149,7 @@
                 </a:solidFill>
                 <a:latin typeface="Calibri"/>
               </a:rPr>
-              <a:t>23</a:t>
+              <a:t>24</a:t>
             </a:r>
           </a:p>
         </p:txBody>
@@ -14309,6 +15285,38 @@
                 <a:latin typeface="Calibri Light"/>
               </a:rPr>
               <a:t>       Cas cités par aeroVFR sans référence : DR-360 posé à contre-QFU ; atterrissage long sur 685 m d'herbe mouillée</a:t>
+            </a:r>
+          </a:p>
+          <a:p>
+            <a:pPr>
+              <a:spcAft>
+                <a:spcPts val="600"/>
+              </a:spcAft>
+            </a:pPr>
+            <a:r>
+              <a:rPr sz="1700" b="1">
+                <a:solidFill>
+                  <a:srgbClr val="1A3A5C"/>
+                </a:solidFill>
+                <a:latin typeface="Calibri"/>
+              </a:rPr>
+              <a:t>▸  Carte VAC</a:t>
+            </a:r>
+          </a:p>
+          <a:p>
+            <a:pPr>
+              <a:spcAft>
+                <a:spcPts val="600"/>
+              </a:spcAft>
+            </a:pPr>
+            <a:r>
+              <a:rPr sz="1300">
+                <a:solidFill>
+                  <a:srgbClr val="5A6A7E"/>
+                </a:solidFill>
+                <a:latin typeface="Calibri Light"/>
+              </a:rPr>
+              <a:t>       SIA, AD 2 LFSL APP 01 / ATT 01 / TXT 01-02, AMDT 08/26 du 9 juillet 2026</a:t>
             </a:r>
           </a:p>
           <a:p>
@@ -14401,7 +15409,7 @@
 </p:sld>
 </file>
 
-<file path=ppt/slides/slide24.xml><?xml version="1.0" encoding="utf-8"?>
+<file path=ppt/slides/slide25.xml><?xml version="1.0" encoding="utf-8"?>
 <p:sld xmlns:a="http://schemas.openxmlformats.org/drawingml/2006/main" xmlns:p="http://schemas.openxmlformats.org/presentationml/2006/main" xmlns:r="http://schemas.openxmlformats.org/officeDocument/2006/relationships">
   <p:cSld>
     <p:bg>

</xml_diff>